<commit_message>
Mise à jour des présentations
</commit_message>
<xml_diff>
--- a/doc/Agent-QC-actuel-vs-propose.pptx
+++ b/doc/Agent-QC-actuel-vs-propose.pptx
@@ -13,9 +13,10 @@
     <p:sldId id="261" r:id="rId7"/>
     <p:sldId id="262" r:id="rId8"/>
     <p:sldId id="263" r:id="rId9"/>
+    <p:sldId id="264" r:id="rId10"/>
   </p:sldIdLst>
   <p:notesMasterIdLst>
-    <p:notesMasterId r:id="rId10"/>
+    <p:notesMasterId r:id="rId11"/>
   </p:notesMasterIdLst>
   <p:sldSz cx="12192000" cy="6858000"/>
   <p:notesSz cx="6858000" cy="12192000"/>
@@ -114,7 +115,7 @@
   <p:extLst>
     <p:ext uri="{521415D9-36F7-43E2-AB2F-B90AF26B5E84}">
       <p14:sectionLst xmlns:p14="http://schemas.microsoft.com/office/powerpoint/2010/main">
-        <p14:section name="Agent QC" id="{dc390719-2bad-3e7c-4243-0452e595971e}">
+        <p14:section name="Agent QC" id="{cb60ade3-0637-78d5-4d17-bfc8d81ab1da}">
           <p14:sldIdLst>
             <p14:sldId id="256"/>
             <p14:sldId id="257"/>
@@ -124,6 +125,7 @@
             <p14:sldId id="261"/>
             <p14:sldId id="262"/>
             <p14:sldId id="263"/>
+            <p14:sldId id="264"/>
           </p14:sldIdLst>
         </p14:section>
       </p14:sectionLst>
@@ -794,7 +796,7 @@
           <a:p>
             <a:r>
               <a:rPr lang="en-US" dirty="0"/>
-              <a:t>Le contexte projet est un fichier du dépôt, relu par l'équipe et daté : rôles, comptes de test, statuts, règles déjà validées, données fictives, points à confirmer. Il évite de traiter chaque US isolément. L'analyse lit l'US phrase par phrase, classe chaque règle (claire, à arbitrer, exploratoire), relève les préconditions et les combinaisons à tester, et rend un verdict qui dit quoi rédiger. La rédaction écrit ensuite les scénarios en français, seulement pour les règles claires. Les fichiers sont prêts : un modèle de contexte projet, un skill d'analyse, un skill de rédaction et son guide d'exemples.</a:t>
+              <a:t>Le contexte projet est un fichier du dépôt, relu par l'équipe et daté : rôles, comptes de test, statuts, règles déjà validées, données fictives, points à confirmer. Il est créé une fois à partir du PRD et du DAG, puis complété après chaque US avec ce que l'équipe a validé. Il évite de traiter chaque US isolément. L'analyse lit l'US phrase par phrase, classe chaque règle (claire, à arbitrer, exploratoire), relève les préconditions et les combinaisons à tester, et rend un verdict qui dit quoi rédiger. La rédaction écrit ensuite les scénarios en français, seulement pour les règles claires. Les fichiers sont prêts : l'agent, six skills, un modèle de contexte projet et un script de contrôle sans IA.</a:t>
             </a:r>
             <a:endParaRPr lang="en-US" dirty="0"/>
           </a:p>
@@ -882,7 +884,7 @@
           <a:p>
             <a:r>
               <a:rPr lang="en-US" dirty="0"/>
-              <a:t>Limite de la comparaison : la sortie de l'agent actuel a été produite dans GitHub Copilot ; notre résultat a été produit en appliquant les nouvelles consignes hors de Copilot. Le vrai test sera de rejouer les nouvelles consignes dans Copilot sur la même US. Comparaison faite sur la sortie de l'agent actuel (TC-001 à TC-014 et début de TC-015) et sur la version proposée appliquée à l'US complète. Sur l'accès, le panneau et les champs du formulaire, les deux couvertures sont proches. La différence est ailleurs. Exécutabilité : les cas actuels ne disent ni qui se connecte ni quelles données préparer. Règle métier : la validation dépend du statut de la demande existante sur l'entité ; l'agent actuel n'en teste qu'un cas. Honnêteté : l'US dit qu'une entité inconnue est refusée alors que la saisie libre est impossible ; l'agent actuel ne le voit pas, la version proposée en fait une question bloquante. Les textes exacts des messages sont dans les maquettes : ils restent à compléter.</a:t>
+              <a:t>L'agent ne fait qu'une étape par commande et s'arrête : on relit avant de passer à la suite. Un document déposé ou un texte collé sans commande ne déclenche rien. Le contexte du projet est créé une fois à partir du PRD et du DAG, puis chaque analyse d'US propose des lignes à y ajouter : une règle confirmée, un statut, un rôle, un point à confirmer. Rien n'y entre sans source ni sans validation : sinon une erreur faite sur une US se répéterait dans toutes les suivantes. Les écritures dans Azure DevOps, les commits et les push passent par une confirmation contrôlée par un script, en plus des consignes. Le vrai verrou reste le PAT : en lecture seule pour ceux qui analysent. Ces contrôles techniques existent dans Claude Code ; dans VS Code avec Copilot, l'agent et les skills fonctionnent mais sans eux.</a:t>
             </a:r>
             <a:endParaRPr lang="en-US" dirty="0"/>
           </a:p>
@@ -970,7 +972,7 @@
           <a:p>
             <a:r>
               <a:rPr lang="en-US" dirty="0"/>
-              <a:t>C'est la règle métier la plus importante de l'US, dans sa section Validation. Elle compte cinq situations : deux où la création est acceptée, trois où elle est refusée. L'agent actuel n'en teste qu'une, la plus simple. La version proposée les teste toutes ; pour chaque refus, elle vérifie aussi que la demande déjà existante n'a pas été modifiée. À droite, l'un des trois scénarios de refus, en version abrégée. Le texte exact du message d'erreur est dans les maquettes : il sera recopié dans le scénario.</a:t>
+              <a:t>Limite de la comparaison : la sortie de l'agent actuel a été produite par l'agent de l'équipe ; notre résultat a été produit en appliquant les nouvelles consignes en dehors de cet outil. Le vrai test sera de rejouer le nouvel agent dans l'outil de l'équipe sur la même US. Comparaison faite sur la sortie de l'agent actuel (TC-001 à TC-014 et début de TC-015) et sur la version proposée appliquée à l'US complète. Sur l'accès, le panneau et les champs du formulaire, les deux couvertures sont proches. La différence est ailleurs. Exécutabilité : les cas actuels ne disent ni qui se connecte ni quelles données préparer. Règle métier : la validation dépend du statut de la demande existante sur l'entité ; l'agent actuel n'en teste qu'un cas. Honnêteté : l'US dit qu'une entité inconnue est refusée alors que la saisie libre est impossible ; l'agent actuel ne le voit pas, la version proposée en fait une question bloquante. Les textes exacts des messages sont dans les maquettes : ils restent à compléter.</a:t>
             </a:r>
             <a:endParaRPr lang="en-US" dirty="0"/>
           </a:p>
@@ -1058,7 +1060,7 @@
           <a:p>
             <a:r>
               <a:rPr lang="en-US" dirty="0"/>
-              <a:t>Synthèse à dire en une phrase : l'agent actuel sait décrire l'écran et publier, mais ses cas ne sont pas exécutables tels quels et il passe à côté des règles métier et de ce que l'US ne dit pas. La proposition garde les deux points forts et corrige les quatre autres.</a:t>
+              <a:t>C'est la règle métier la plus importante de l'US, dans sa section Validation. Elle compte cinq situations : deux où la création est acceptée, trois où elle est refusée. L'agent actuel n'en teste qu'une, la plus simple. La version proposée les teste toutes ; pour chaque refus, elle vérifie aussi que la demande déjà existante n'a pas été modifiée. À droite, l'un des trois scénarios de refus, en version abrégée. Le texte exact du message d'erreur est dans les maquettes : il sera recopié dans le scénario.</a:t>
             </a:r>
             <a:endParaRPr lang="en-US" dirty="0"/>
           </a:p>
@@ -1146,7 +1148,7 @@
           <a:p>
             <a:r>
               <a:rPr lang="en-US" dirty="0"/>
-              <a:t>Les 3 US de référence sont des US déjà traitées à la main, dont les cas sont validés : on connaît la bonne réponse, on peut donc juger l'agent objectivement. Zéro cas inventé est la seule cible non négociable : un cas avec un résultat inventé coûte plus de temps qu'il n'en fait gagner. Le contenu des US est envoyé à Copilot : rester dans l'outil autorisé par KPMG.</a:t>
+              <a:t>Synthèse à dire en une phrase : l'agent actuel sait décrire l'écran et publier, mais ses cas ne sont pas exécutables tels quels et il passe à côté des règles métier et de ce que l'US ne dit pas. La proposition garde les deux points forts et corrige les quatre autres.</a:t>
             </a:r>
             <a:endParaRPr lang="en-US" dirty="0"/>
           </a:p>
@@ -1170,6 +1172,94 @@
             <a:fld id="{F7021451-1387-4CA6-816F-3879F97B5CBC}" type="slidenum">
               <a:rPr lang="en-US"/>
               <a:t>8</a:t>
+            </a:fld>
+            <a:endParaRPr lang="en-US"/>
+          </a:p>
+        </p:txBody>
+      </p:sp>
+    </p:spTree>
+    <p:extLst>
+      <p:ext uri="{BB962C8B-B14F-4D97-AF65-F5344CB8AC3E}">
+        <p14:creationId xmlns:p14="http://schemas.microsoft.com/office/powerpoint/2010/main" val="1024086991"/>
+      </p:ext>
+    </p:extLst>
+  </p:cSld>
+  <p:clrMapOvr>
+    <a:masterClrMapping/>
+  </p:clrMapOvr>
+</p:notes>
+</file>
+
+<file path=ppt/notesSlides/notesSlide9.xml><?xml version="1.0" encoding="utf-8"?>
+<p:notes xmlns:a="http://schemas.openxmlformats.org/drawingml/2006/main" xmlns:r="http://schemas.openxmlformats.org/officeDocument/2006/relationships" xmlns:p="http://schemas.openxmlformats.org/presentationml/2006/main">
+  <p:cSld>
+    <p:spTree>
+      <p:nvGrpSpPr>
+        <p:cNvPr id="1" name=""/>
+        <p:cNvGrpSpPr/>
+        <p:nvPr/>
+      </p:nvGrpSpPr>
+      <p:grpSpPr>
+        <a:xfrm>
+          <a:off x="0" y="0"/>
+          <a:ext cx="0" cy="0"/>
+          <a:chOff x="0" y="0"/>
+          <a:chExt cx="0" cy="0"/>
+        </a:xfrm>
+      </p:grpSpPr>
+      <p:sp>
+        <p:nvSpPr>
+          <p:cNvPr id="2" name="Slide Image Placeholder 1"/>
+          <p:cNvSpPr>
+            <a:spLocks noGrp="1" noRot="1" noChangeAspect="1"/>
+          </p:cNvSpPr>
+          <p:nvPr>
+            <p:ph type="sldImg"/>
+          </p:nvPr>
+        </p:nvSpPr>
+        <p:spPr/>
+      </p:sp>
+      <p:sp>
+        <p:nvSpPr>
+          <p:cNvPr id="3" name="Notes Placeholder 2"/>
+          <p:cNvSpPr>
+            <a:spLocks noGrp="1"/>
+          </p:cNvSpPr>
+          <p:nvPr>
+            <p:ph type="body" idx="1"/>
+          </p:nvPr>
+        </p:nvSpPr>
+        <p:spPr/>
+        <p:txBody>
+          <a:bodyPr/>
+          <a:lstStyle/>
+          <a:p>
+            <a:r>
+              <a:rPr lang="en-US" dirty="0"/>
+              <a:t>Les 3 US de référence sont des US déjà traitées à la main, dont les cas sont validés : on connaît la bonne réponse, on peut donc juger l'agent objectivement. Zéro cas inventé est la seule cible non négociable : un cas avec un résultat inventé coûte plus de temps qu'il n'en fait gagner. Le contenu des US, du PRD et du DAG est envoyé à l'outil IA : rester dans l'outil et le périmètre de données autorisés par KPMG.</a:t>
+            </a:r>
+            <a:endParaRPr lang="en-US" dirty="0"/>
+          </a:p>
+        </p:txBody>
+      </p:sp>
+      <p:sp>
+        <p:nvSpPr>
+          <p:cNvPr id="4" name="Slide Number Placeholder 3"/>
+          <p:cNvSpPr>
+            <a:spLocks noGrp="1"/>
+          </p:cNvSpPr>
+          <p:nvPr>
+            <p:ph type="sldNum" sz="quarter" idx="10"/>
+          </p:nvPr>
+        </p:nvSpPr>
+        <p:spPr/>
+        <p:txBody>
+          <a:bodyPr/>
+          <a:lstStyle/>
+          <a:p>
+            <a:fld id="{F7021451-1387-4CA6-816F-3879F97B5CBC}" type="slidenum">
+              <a:rPr lang="en-US"/>
+              <a:t>9</a:t>
             </a:fld>
             <a:endParaRPr lang="en-US"/>
           </a:p>
@@ -5099,7 +5189,7 @@
                             <a:srgbClr val="00338D"/>
                           </a:solidFill>
                         </a:rPr>
-                        <a:t>Contexte projet relu ; publication après accord</a:t>
+                        <a:t>Contexte projet relu et enrichi après chaque US ; publication après accord</a:t>
                       </a:r>
                       <a:endParaRPr lang="en-US" sz="1000" dirty="0"/>
                     </a:p>
@@ -5291,7 +5381,7 @@
                   <a:schemeClr val="accent1"/>
                 </a:solidFill>
               </a:rPr>
-              <a:t>Un contexte projet relu, deux étapes (analyser puis rédiger), une relecture humaine avant toute publication.</a:t>
+              <a:t>Un contexte projet qui s'enrichit, deux étapes (analyser puis rédiger), une relecture humaine avant toute publication.</a:t>
             </a:r>
             <a:endParaRPr lang="en-US" sz="1600" dirty="0"/>
           </a:p>
@@ -5361,7 +5451,7 @@
                   <a:schemeClr val="bg1"/>
                 </a:solidFill>
               </a:rPr>
-              <a:t>Rôles, comptes de test, statuts, règles validées</a:t>
+              <a:t>Créé depuis le PRD et le DAG, enrichi après validation</a:t>
             </a:r>
             <a:endParaRPr lang="en-US" sz="1300" dirty="0"/>
           </a:p>
@@ -6303,7 +6393,7 @@
                   <a:schemeClr val="tx2"/>
                 </a:solidFill>
               </a:rPr>
-              <a:t>Les résultats comparés sur l'US 417829</a:t>
+              <a:t>Comment l'agent travaille : une étape à la fois</a:t>
             </a:r>
             <a:endParaRPr lang="en-US" sz="2800" dirty="0"/>
           </a:p>
@@ -6341,7 +6431,7 @@
                   <a:schemeClr val="accent1"/>
                 </a:solidFill>
               </a:rPr>
-              <a:t>Même US « Créer une nouvelle demande ». Notre résultat est un premier essai, à rejouer dans Copilot.</a:t>
+              <a:t>Chaque commande fait une étape puis s'arrête ; le contexte ne retient que ce que l'humain a validé.</a:t>
             </a:r>
             <a:endParaRPr lang="en-US" sz="1600" dirty="0"/>
           </a:p>
@@ -6349,7 +6439,7 @@
       </p:sp>
       <p:graphicFrame>
         <p:nvGraphicFramePr>
-          <p:cNvPr id="6" name="table-comparaison"/>
+          <p:cNvPr id="6" name="table-etapes"/>
           <p:cNvGraphicFramePr>
             <a:graphicFrameLocks noGrp="1"/>
           </p:cNvGraphicFramePr>
@@ -6363,16 +6453,16 @@
         </p:nvGraphicFramePr>
         <p:xfrm>
           <a:off x="548640" y="1572768"/>
-          <a:ext cx="11064240" cy="914400"/>
+          <a:ext cx="6400800" cy="914400"/>
         </p:xfrm>
         <a:graphic>
           <a:graphicData uri="http://schemas.openxmlformats.org/drawingml/2006/table">
             <a:tbl>
               <a:tblPr/>
               <a:tblGrid>
-                <a:gridCol w="2286000"/>
-                <a:gridCol w="4206240"/>
-                <a:gridCol w="4572000"/>
+                <a:gridCol w="1783080"/>
+                <a:gridCol w="2377440"/>
+                <a:gridCol w="2240280"/>
               </a:tblGrid>
               <a:tr h="329184">
                 <a:tc>
@@ -6389,7 +6479,7 @@
                             <a:srgbClr val="FFFFFF"/>
                           </a:solidFill>
                         </a:rPr>
-                        <a:t>Point</a:t>
+                        <a:t>Étape</a:t>
                       </a:r>
                       <a:endParaRPr lang="en-US" sz="1200" dirty="0"/>
                     </a:p>
@@ -6450,7 +6540,7 @@
                             <a:srgbClr val="FFFFFF"/>
                           </a:solidFill>
                         </a:rPr>
-                        <a:t>Agent QC actuel</a:t>
+                        <a:t>Commande</a:t>
                       </a:r>
                       <a:endParaRPr lang="en-US" sz="1200" dirty="0"/>
                     </a:p>
@@ -6493,7 +6583,7 @@
                       <a:tailEnd type="none" w="med" len="med"/>
                     </a:lnB>
                     <a:solidFill>
-                      <a:srgbClr val="B23B3B"/>
+                      <a:srgbClr val="00338D"/>
                     </a:solidFill>
                   </a:tcPr>
                 </a:tc>
@@ -6511,7 +6601,7 @@
                             <a:srgbClr val="FFFFFF"/>
                           </a:solidFill>
                         </a:rPr>
-                        <a:t>Version proposée</a:t>
+                        <a:t>S'arrête après</a:t>
                       </a:r>
                       <a:endParaRPr lang="en-US" sz="1200" dirty="0"/>
                     </a:p>
@@ -6554,12 +6644,12 @@
                       <a:tailEnd type="none" w="med" len="med"/>
                     </a:lnB>
                     <a:solidFill>
-                      <a:srgbClr val="2E7D4F"/>
+                      <a:srgbClr val="00338D"/>
                     </a:solidFill>
                   </a:tcPr>
                 </a:tc>
               </a:tr>
-              <a:tr h="429768">
+              <a:tr h="420624">
                 <a:tc>
                   <a:txBody>
                     <a:bodyPr/>
@@ -6569,14 +6659,14 @@
                         <a:buNone/>
                       </a:pPr>
                       <a:r>
-                        <a:rPr lang="en-US" sz="1100" b="1" dirty="0">
+                        <a:rPr lang="en-US" sz="1150" b="1" dirty="0">
                           <a:solidFill>
                             <a:srgbClr val="1A1A2E"/>
                           </a:solidFill>
                         </a:rPr>
-                        <a:t>Forme</a:t>
+                        <a:t>Une fois par projet</a:t>
                       </a:r>
-                      <a:endParaRPr lang="en-US" sz="1100" dirty="0"/>
+                      <a:endParaRPr lang="en-US" sz="1150" dirty="0"/>
                     </a:p>
                   </a:txBody>
                   <a:tcPr marL="73152" marR="73152" marT="27432" marB="27432" anchor="ctr">
@@ -6630,14 +6720,21 @@
                         <a:buNone/>
                       </a:pPr>
                       <a:r>
-                        <a:rPr lang="en-US" sz="1100" dirty="0">
+                        <a:rPr lang="en-US" sz="1150" dirty="0">
                           <a:solidFill>
-                            <a:srgbClr val="1A1A2E"/>
+                            <a:srgbClr val="00338D"/>
                           </a:solidFill>
+                          <a:latin typeface="Courier New" pitchFamily="34" charset="0"/>
+                          <a:ea typeface="Courier New" pitchFamily="34" charset="-122"/>
+                          <a:cs typeface="Courier New" pitchFamily="34" charset="-120"/>
                         </a:rPr>
-                        <a:t>Une ligne Given, When, Then en anglais par cas ; « Fonctionnel » partout</a:t>
+                        <a:t>/init-contexte</a:t>
                       </a:r>
-                      <a:endParaRPr lang="en-US" sz="1100" dirty="0"/>
+                      <a:endParaRPr lang="en-US" sz="1150" dirty="0">
+                        <a:latin typeface="Courier New" charset="0"/>
+                        <a:ea typeface="Courier New" charset="0"/>
+                        <a:cs typeface="Courier New" charset="0"/>
+                      </a:endParaRPr>
                     </a:p>
                   </a:txBody>
                   <a:tcPr marL="73152" marR="73152" marT="27432" marB="27432" anchor="ctr">
@@ -6691,14 +6788,14 @@
                         <a:buNone/>
                       </a:pPr>
                       <a:r>
-                        <a:rPr lang="en-US" sz="1100" dirty="0">
+                        <a:rPr lang="en-US" sz="1150" dirty="0">
                           <a:solidFill>
-                            <a:srgbClr val="00338D"/>
+                            <a:srgbClr val="1A1A2E"/>
                           </a:solidFill>
                         </a:rPr>
-                        <a:t>Gherkin en français, préconditions, actions et résultats sur des lignes séparées</a:t>
+                        <a:t>Contexte écrit, à relire</a:t>
                       </a:r>
-                      <a:endParaRPr lang="en-US" sz="1100" dirty="0"/>
+                      <a:endParaRPr lang="en-US" sz="1150" dirty="0"/>
                     </a:p>
                   </a:txBody>
                   <a:tcPr marL="73152" marR="73152" marT="27432" marB="27432" anchor="ctr">
@@ -6739,12 +6836,12 @@
                       <a:tailEnd type="none" w="med" len="med"/>
                     </a:lnB>
                     <a:solidFill>
-                      <a:srgbClr val="DCEFE2"/>
+                      <a:srgbClr val="EEF3FA"/>
                     </a:solidFill>
                   </a:tcPr>
                 </a:tc>
               </a:tr>
-              <a:tr h="429768">
+              <a:tr h="420624">
                 <a:tc>
                   <a:txBody>
                     <a:bodyPr/>
@@ -6754,14 +6851,14 @@
                         <a:buNone/>
                       </a:pPr>
                       <a:r>
-                        <a:rPr lang="en-US" sz="1100" b="1" dirty="0">
+                        <a:rPr lang="en-US" sz="1150" b="1" dirty="0">
                           <a:solidFill>
                             <a:srgbClr val="1A1A2E"/>
                           </a:solidFill>
                         </a:rPr>
-                        <a:t>Préconditions</a:t>
+                        <a:t>Analyser l'US</a:t>
                       </a:r>
-                      <a:endParaRPr lang="en-US" sz="1100" dirty="0"/>
+                      <a:endParaRPr lang="en-US" sz="1150" dirty="0"/>
                     </a:p>
                   </a:txBody>
                   <a:tcPr marL="73152" marR="73152" marT="27432" marB="27432" anchor="ctr">
@@ -6815,14 +6912,21 @@
                         <a:buNone/>
                       </a:pPr>
                       <a:r>
-                        <a:rPr lang="en-US" sz="1100" dirty="0">
+                        <a:rPr lang="en-US" sz="1150" dirty="0">
                           <a:solidFill>
-                            <a:srgbClr val="1A1A2E"/>
+                            <a:srgbClr val="00338D"/>
                           </a:solidFill>
+                          <a:latin typeface="Courier New" pitchFamily="34" charset="0"/>
+                          <a:ea typeface="Courier New" pitchFamily="34" charset="-122"/>
+                          <a:cs typeface="Courier New" pitchFamily="34" charset="-120"/>
                         </a:rPr>
-                        <a:t>« Given le formulaire ouvert » : ni rôle, ni écran ; « une entité valide »</a:t>
+                        <a:t>/us-analysis</a:t>
                       </a:r>
-                      <a:endParaRPr lang="en-US" sz="1100" dirty="0"/>
+                      <a:endParaRPr lang="en-US" sz="1150" dirty="0">
+                        <a:latin typeface="Courier New" charset="0"/>
+                        <a:ea typeface="Courier New" charset="0"/>
+                        <a:cs typeface="Courier New" charset="0"/>
+                      </a:endParaRPr>
                     </a:p>
                   </a:txBody>
                   <a:tcPr marL="73152" marR="73152" marT="27432" marB="27432" anchor="ctr">
@@ -6876,14 +6980,14 @@
                         <a:buNone/>
                       </a:pPr>
                       <a:r>
-                        <a:rPr lang="en-US" sz="1100" dirty="0">
+                        <a:rPr lang="en-US" sz="1150" dirty="0">
                           <a:solidFill>
-                            <a:srgbClr val="00338D"/>
+                            <a:srgbClr val="1A1A2E"/>
                           </a:solidFill>
                         </a:rPr>
-                        <a:t>Rôle et compte, écran de départ, entité et statut de sa demande, documents joints</a:t>
+                        <a:t>Analyse et propositions pour le contexte</a:t>
                       </a:r>
-                      <a:endParaRPr lang="en-US" sz="1100" dirty="0"/>
+                      <a:endParaRPr lang="en-US" sz="1150" dirty="0"/>
                     </a:p>
                   </a:txBody>
                   <a:tcPr marL="73152" marR="73152" marT="27432" marB="27432" anchor="ctr">
@@ -6929,7 +7033,7 @@
                   </a:tcPr>
                 </a:tc>
               </a:tr>
-              <a:tr h="429768">
+              <a:tr h="420624">
                 <a:tc>
                   <a:txBody>
                     <a:bodyPr/>
@@ -6939,14 +7043,14 @@
                         <a:buNone/>
                       </a:pPr>
                       <a:r>
-                        <a:rPr lang="en-US" sz="1100" b="1" dirty="0">
+                        <a:rPr lang="en-US" sz="1150" b="1" dirty="0">
                           <a:solidFill>
                             <a:srgbClr val="1A1A2E"/>
                           </a:solidFill>
                         </a:rPr>
-                        <a:t>Rôles</a:t>
+                        <a:t>Écrire les scénarios</a:t>
                       </a:r>
-                      <a:endParaRPr lang="en-US" sz="1100" dirty="0"/>
+                      <a:endParaRPr lang="en-US" sz="1150" dirty="0"/>
                     </a:p>
                   </a:txBody>
                   <a:tcPr marL="73152" marR="73152" marT="27432" marB="27432" anchor="ctr">
@@ -7000,14 +7104,21 @@
                         <a:buNone/>
                       </a:pPr>
                       <a:r>
-                        <a:rPr lang="en-US" sz="1100" dirty="0">
+                        <a:rPr lang="en-US" sz="1150" dirty="0">
                           <a:solidFill>
-                            <a:srgbClr val="1A1A2E"/>
+                            <a:srgbClr val="00338D"/>
                           </a:solidFill>
+                          <a:latin typeface="Courier New" pitchFamily="34" charset="0"/>
+                          <a:ea typeface="Courier New" pitchFamily="34" charset="-122"/>
+                          <a:cs typeface="Courier New" pitchFamily="34" charset="-120"/>
                         </a:rPr>
-                        <a:t>« un rôle autre qu'Admin ou SuperAdmin »</a:t>
+                        <a:t>/gherkin-test-generation</a:t>
                       </a:r>
-                      <a:endParaRPr lang="en-US" sz="1100" dirty="0"/>
+                      <a:endParaRPr lang="en-US" sz="1150" dirty="0">
+                        <a:latin typeface="Courier New" charset="0"/>
+                        <a:ea typeface="Courier New" charset="0"/>
+                        <a:cs typeface="Courier New" charset="0"/>
+                      </a:endParaRPr>
                     </a:p>
                   </a:txBody>
                   <a:tcPr marL="73152" marR="73152" marT="27432" marB="27432" anchor="ctr">
@@ -7061,14 +7172,14 @@
                         <a:buNone/>
                       </a:pPr>
                       <a:r>
-                        <a:rPr lang="en-US" sz="1100" dirty="0">
+                        <a:rPr lang="en-US" sz="1150" dirty="0">
                           <a:solidFill>
-                            <a:srgbClr val="00338D"/>
+                            <a:srgbClr val="1A1A2E"/>
                           </a:solidFill>
                         </a:rPr>
-                        <a:t>Rôle User nommé, avec son compte de test</a:t>
+                        <a:t>Scénarios contrôlés par script</a:t>
                       </a:r>
-                      <a:endParaRPr lang="en-US" sz="1100" dirty="0"/>
+                      <a:endParaRPr lang="en-US" sz="1150" dirty="0"/>
                     </a:p>
                   </a:txBody>
                   <a:tcPr marL="73152" marR="73152" marT="27432" marB="27432" anchor="ctr">
@@ -7109,12 +7220,12 @@
                       <a:tailEnd type="none" w="med" len="med"/>
                     </a:lnB>
                     <a:solidFill>
-                      <a:srgbClr val="DCEFE2"/>
+                      <a:srgbClr val="EEF3FA"/>
                     </a:solidFill>
                   </a:tcPr>
                 </a:tc>
               </a:tr>
-              <a:tr h="429768">
+              <a:tr h="420624">
                 <a:tc>
                   <a:txBody>
                     <a:bodyPr/>
@@ -7124,14 +7235,14 @@
                         <a:buNone/>
                       </a:pPr>
                       <a:r>
-                        <a:rPr lang="en-US" sz="1100" b="1" dirty="0">
+                        <a:rPr lang="en-US" sz="1150" b="1" dirty="0">
                           <a:solidFill>
                             <a:srgbClr val="1A1A2E"/>
                           </a:solidFill>
                         </a:rPr>
-                        <a:t>Règle de validation : statut de l'entité</a:t>
+                        <a:t>Enrichir le contexte</a:t>
                       </a:r>
-                      <a:endParaRPr lang="en-US" sz="1100" dirty="0"/>
+                      <a:endParaRPr lang="en-US" sz="1150" dirty="0"/>
                     </a:p>
                   </a:txBody>
                   <a:tcPr marL="73152" marR="73152" marT="27432" marB="27432" anchor="ctr">
@@ -7185,14 +7296,21 @@
                         <a:buNone/>
                       </a:pPr>
                       <a:r>
-                        <a:rPr lang="en-US" sz="1100" dirty="0">
+                        <a:rPr lang="en-US" sz="1150" dirty="0">
                           <a:solidFill>
-                            <a:srgbClr val="1A1A2E"/>
+                            <a:srgbClr val="00338D"/>
                           </a:solidFill>
+                          <a:latin typeface="Courier New" pitchFamily="34" charset="0"/>
+                          <a:ea typeface="Courier New" pitchFamily="34" charset="-122"/>
+                          <a:cs typeface="Courier New" pitchFamily="34" charset="-120"/>
                         </a:rPr>
-                        <a:t>1 cas sur 5 : entité sans demande</a:t>
+                        <a:t>/maj-contexte</a:t>
                       </a:r>
-                      <a:endParaRPr lang="en-US" sz="1100" dirty="0"/>
+                      <a:endParaRPr lang="en-US" sz="1150" dirty="0">
+                        <a:latin typeface="Courier New" charset="0"/>
+                        <a:ea typeface="Courier New" charset="0"/>
+                        <a:cs typeface="Courier New" charset="0"/>
+                      </a:endParaRPr>
                     </a:p>
                   </a:txBody>
                   <a:tcPr marL="73152" marR="73152" marT="27432" marB="27432" anchor="ctr">
@@ -7246,14 +7364,14 @@
                         <a:buNone/>
                       </a:pPr>
                       <a:r>
-                        <a:rPr lang="en-US" sz="1100" dirty="0">
+                        <a:rPr lang="en-US" sz="1150" dirty="0">
                           <a:solidFill>
-                            <a:srgbClr val="00338D"/>
+                            <a:srgbClr val="1A1A2E"/>
                           </a:solidFill>
                         </a:rPr>
-                        <a:t>5 cas : aucune demande et Validé acceptés ; En cours, Retard, Révision refusés</a:t>
+                        <a:t>Aperçu, puis « oui »</a:t>
                       </a:r>
-                      <a:endParaRPr lang="en-US" sz="1100" dirty="0"/>
+                      <a:endParaRPr lang="en-US" sz="1150" dirty="0"/>
                     </a:p>
                   </a:txBody>
                   <a:tcPr marL="73152" marR="73152" marT="27432" marB="27432" anchor="ctr">
@@ -7299,7 +7417,7 @@
                   </a:tcPr>
                 </a:tc>
               </a:tr>
-              <a:tr h="429768">
+              <a:tr h="420624">
                 <a:tc>
                   <a:txBody>
                     <a:bodyPr/>
@@ -7309,14 +7427,14 @@
                         <a:buNone/>
                       </a:pPr>
                       <a:r>
-                        <a:rPr lang="en-US" sz="1100" b="1" dirty="0">
+                        <a:rPr lang="en-US" sz="1150" b="1" dirty="0">
                           <a:solidFill>
                             <a:srgbClr val="1A1A2E"/>
                           </a:solidFill>
                         </a:rPr>
-                        <a:t>Champs obligatoires</a:t>
+                        <a:t>Publier</a:t>
                       </a:r>
-                      <a:endParaRPr lang="en-US" sz="1100" dirty="0"/>
+                      <a:endParaRPr lang="en-US" sz="1150" dirty="0"/>
                     </a:p>
                   </a:txBody>
                   <a:tcPr marL="73152" marR="73152" marT="27432" marB="27432" anchor="ctr">
@@ -7370,14 +7488,21 @@
                         <a:buNone/>
                       </a:pPr>
                       <a:r>
-                        <a:rPr lang="en-US" sz="1100" dirty="0">
+                        <a:rPr lang="en-US" sz="1150" dirty="0">
                           <a:solidFill>
-                            <a:srgbClr val="1A1A2E"/>
+                            <a:srgbClr val="00338D"/>
                           </a:solidFill>
+                          <a:latin typeface="Courier New" pitchFamily="34" charset="0"/>
+                          <a:ea typeface="Courier New" pitchFamily="34" charset="-122"/>
+                          <a:cs typeface="Courier New" pitchFamily="34" charset="-120"/>
                         </a:rPr>
-                        <a:t>1 cas générique</a:t>
+                        <a:t>/publication-ado</a:t>
                       </a:r>
-                      <a:endParaRPr lang="en-US" sz="1100" dirty="0"/>
+                      <a:endParaRPr lang="en-US" sz="1150" dirty="0">
+                        <a:latin typeface="Courier New" charset="0"/>
+                        <a:ea typeface="Courier New" charset="0"/>
+                        <a:cs typeface="Courier New" charset="0"/>
+                      </a:endParaRPr>
                     </a:p>
                   </a:txBody>
                   <a:tcPr marL="73152" marR="73152" marT="27432" marB="27432" anchor="ctr">
@@ -7431,14 +7556,14 @@
                         <a:buNone/>
                       </a:pPr>
                       <a:r>
-                        <a:rPr lang="en-US" sz="1100" dirty="0">
+                        <a:rPr lang="en-US" sz="1150" dirty="0">
                           <a:solidFill>
-                            <a:srgbClr val="00338D"/>
+                            <a:srgbClr val="1A1A2E"/>
                           </a:solidFill>
                         </a:rPr>
-                        <a:t>1 cas par champ, avec « aucune demande créée »</a:t>
+                        <a:t>Aperçu, puis « oui » ; ou un CSV</a:t>
                       </a:r>
-                      <a:endParaRPr lang="en-US" sz="1100" dirty="0"/>
+                      <a:endParaRPr lang="en-US" sz="1150" dirty="0"/>
                     </a:p>
                   </a:txBody>
                   <a:tcPr marL="73152" marR="73152" marT="27432" marB="27432" anchor="ctr">
@@ -7479,12 +7604,12 @@
                       <a:tailEnd type="none" w="med" len="med"/>
                     </a:lnB>
                     <a:solidFill>
-                      <a:srgbClr val="DCEFE2"/>
+                      <a:srgbClr val="EEF3FA"/>
                     </a:solidFill>
                   </a:tcPr>
                 </a:tc>
               </a:tr>
-              <a:tr h="429768">
+              <a:tr h="420624">
                 <a:tc>
                   <a:txBody>
                     <a:bodyPr/>
@@ -7494,14 +7619,14 @@
                         <a:buNone/>
                       </a:pPr>
                       <a:r>
-                        <a:rPr lang="en-US" sz="1100" b="1" dirty="0">
+                        <a:rPr lang="en-US" sz="1150" b="1" dirty="0">
                           <a:solidFill>
                             <a:srgbClr val="1A1A2E"/>
                           </a:solidFill>
                         </a:rPr>
-                        <a:t>Bornes du millésime</a:t>
+                        <a:t>Rédiger un bug</a:t>
                       </a:r>
-                      <a:endParaRPr lang="en-US" sz="1100" dirty="0"/>
+                      <a:endParaRPr lang="en-US" sz="1150" dirty="0"/>
                     </a:p>
                   </a:txBody>
                   <a:tcPr marL="73152" marR="73152" marT="27432" marB="27432" anchor="ctr">
@@ -7555,14 +7680,21 @@
                         <a:buNone/>
                       </a:pPr>
                       <a:r>
-                        <a:rPr lang="en-US" sz="1100" dirty="0">
+                        <a:rPr lang="en-US" sz="1150" dirty="0">
                           <a:solidFill>
-                            <a:srgbClr val="1A1A2E"/>
+                            <a:srgbClr val="00338D"/>
                           </a:solidFill>
+                          <a:latin typeface="Courier New" pitchFamily="34" charset="0"/>
+                          <a:ea typeface="Courier New" pitchFamily="34" charset="-122"/>
+                          <a:cs typeface="Courier New" pitchFamily="34" charset="-120"/>
                         </a:rPr>
-                        <a:t>1 cas « de -20 à +10 »</a:t>
+                        <a:t>/redaction-anomalie</a:t>
                       </a:r>
-                      <a:endParaRPr lang="en-US" sz="1100" dirty="0"/>
+                      <a:endParaRPr lang="en-US" sz="1150" dirty="0">
+                        <a:latin typeface="Courier New" charset="0"/>
+                        <a:ea typeface="Courier New" charset="0"/>
+                        <a:cs typeface="Courier New" charset="0"/>
+                      </a:endParaRPr>
                     </a:p>
                   </a:txBody>
                   <a:tcPr marL="73152" marR="73152" marT="27432" marB="27432" anchor="ctr">
@@ -7616,14 +7748,14 @@
                         <a:buNone/>
                       </a:pPr>
                       <a:r>
-                        <a:rPr lang="en-US" sz="1100" dirty="0">
+                        <a:rPr lang="en-US" sz="1150" dirty="0">
                           <a:solidFill>
-                            <a:srgbClr val="00338D"/>
+                            <a:srgbClr val="1A1A2E"/>
                           </a:solidFill>
                         </a:rPr>
-                        <a:t>4 cas : les bornes et les valeurs juste au-delà</a:t>
+                        <a:t>Aperçu, puis « oui »</a:t>
                       </a:r>
-                      <a:endParaRPr lang="en-US" sz="1100" dirty="0"/>
+                      <a:endParaRPr lang="en-US" sz="1150" dirty="0"/>
                     </a:p>
                   </a:txBody>
                   <a:tcPr marL="73152" marR="73152" marT="27432" marB="27432" anchor="ctr">
@@ -7665,561 +7797,6 @@
                     </a:lnB>
                     <a:solidFill>
                       <a:srgbClr val="FFFFFF"/>
-                    </a:solidFill>
-                  </a:tcPr>
-                </a:tc>
-              </a:tr>
-              <a:tr h="429768">
-                <a:tc>
-                  <a:txBody>
-                    <a:bodyPr/>
-                    <a:lstStyle/>
-                    <a:p>
-                      <a:pPr indent="0" marL="0">
-                        <a:buNone/>
-                      </a:pPr>
-                      <a:r>
-                        <a:rPr lang="en-US" sz="1100" b="1" dirty="0">
-                          <a:solidFill>
-                            <a:srgbClr val="1A1A2E"/>
-                          </a:solidFill>
-                        </a:rPr>
-                        <a:t>Doublons</a:t>
-                      </a:r>
-                      <a:endParaRPr lang="en-US" sz="1100" dirty="0"/>
-                    </a:p>
-                  </a:txBody>
-                  <a:tcPr marL="73152" marR="73152" marT="27432" marB="27432" anchor="ctr">
-                    <a:lnL w="6350" cap="flat" cmpd="sng" algn="ctr">
-                      <a:solidFill>
-                        <a:srgbClr val="B8D4F0"/>
-                      </a:solidFill>
-                      <a:prstDash val="solid"/>
-                      <a:round/>
-                      <a:headEnd type="none" w="med" len="med"/>
-                      <a:tailEnd type="none" w="med" len="med"/>
-                    </a:lnL>
-                    <a:lnR w="6350" cap="flat" cmpd="sng" algn="ctr">
-                      <a:solidFill>
-                        <a:srgbClr val="B8D4F0"/>
-                      </a:solidFill>
-                      <a:prstDash val="solid"/>
-                      <a:round/>
-                      <a:headEnd type="none" w="med" len="med"/>
-                      <a:tailEnd type="none" w="med" len="med"/>
-                    </a:lnR>
-                    <a:lnT w="6350" cap="flat" cmpd="sng" algn="ctr">
-                      <a:solidFill>
-                        <a:srgbClr val="B8D4F0"/>
-                      </a:solidFill>
-                      <a:prstDash val="solid"/>
-                      <a:round/>
-                      <a:headEnd type="none" w="med" len="med"/>
-                      <a:tailEnd type="none" w="med" len="med"/>
-                    </a:lnT>
-                    <a:lnB w="6350" cap="flat" cmpd="sng" algn="ctr">
-                      <a:solidFill>
-                        <a:srgbClr val="B8D4F0"/>
-                      </a:solidFill>
-                      <a:prstDash val="solid"/>
-                      <a:round/>
-                      <a:headEnd type="none" w="med" len="med"/>
-                      <a:tailEnd type="none" w="med" len="med"/>
-                    </a:lnB>
-                    <a:solidFill>
-                      <a:srgbClr val="EEF3FA"/>
-                    </a:solidFill>
-                  </a:tcPr>
-                </a:tc>
-                <a:tc>
-                  <a:txBody>
-                    <a:bodyPr/>
-                    <a:lstStyle/>
-                    <a:p>
-                      <a:pPr indent="0" marL="0">
-                        <a:buNone/>
-                      </a:pPr>
-                      <a:r>
-                        <a:rPr lang="en-US" sz="1100" dirty="0">
-                          <a:solidFill>
-                            <a:srgbClr val="1A1A2E"/>
-                          </a:solidFill>
-                        </a:rPr>
-                        <a:t>Reprise Oui et Reprise Non : même résultat</a:t>
-                      </a:r>
-                      <a:endParaRPr lang="en-US" sz="1100" dirty="0"/>
-                    </a:p>
-                  </a:txBody>
-                  <a:tcPr marL="73152" marR="73152" marT="27432" marB="27432" anchor="ctr">
-                    <a:lnL w="6350" cap="flat" cmpd="sng" algn="ctr">
-                      <a:solidFill>
-                        <a:srgbClr val="B8D4F0"/>
-                      </a:solidFill>
-                      <a:prstDash val="solid"/>
-                      <a:round/>
-                      <a:headEnd type="none" w="med" len="med"/>
-                      <a:tailEnd type="none" w="med" len="med"/>
-                    </a:lnL>
-                    <a:lnR w="6350" cap="flat" cmpd="sng" algn="ctr">
-                      <a:solidFill>
-                        <a:srgbClr val="B8D4F0"/>
-                      </a:solidFill>
-                      <a:prstDash val="solid"/>
-                      <a:round/>
-                      <a:headEnd type="none" w="med" len="med"/>
-                      <a:tailEnd type="none" w="med" len="med"/>
-                    </a:lnR>
-                    <a:lnT w="6350" cap="flat" cmpd="sng" algn="ctr">
-                      <a:solidFill>
-                        <a:srgbClr val="B8D4F0"/>
-                      </a:solidFill>
-                      <a:prstDash val="solid"/>
-                      <a:round/>
-                      <a:headEnd type="none" w="med" len="med"/>
-                      <a:tailEnd type="none" w="med" len="med"/>
-                    </a:lnT>
-                    <a:lnB w="6350" cap="flat" cmpd="sng" algn="ctr">
-                      <a:solidFill>
-                        <a:srgbClr val="B8D4F0"/>
-                      </a:solidFill>
-                      <a:prstDash val="solid"/>
-                      <a:round/>
-                      <a:headEnd type="none" w="med" len="med"/>
-                      <a:tailEnd type="none" w="med" len="med"/>
-                    </a:lnB>
-                    <a:solidFill>
-                      <a:srgbClr val="EEF3FA"/>
-                    </a:solidFill>
-                  </a:tcPr>
-                </a:tc>
-                <a:tc>
-                  <a:txBody>
-                    <a:bodyPr/>
-                    <a:lstStyle/>
-                    <a:p>
-                      <a:pPr indent="0" marL="0">
-                        <a:buNone/>
-                      </a:pPr>
-                      <a:r>
-                        <a:rPr lang="en-US" sz="1100" dirty="0">
-                          <a:solidFill>
-                            <a:srgbClr val="00338D"/>
-                          </a:solidFill>
-                        </a:rPr>
-                        <a:t>Aucun</a:t>
-                      </a:r>
-                      <a:endParaRPr lang="en-US" sz="1100" dirty="0"/>
-                    </a:p>
-                  </a:txBody>
-                  <a:tcPr marL="73152" marR="73152" marT="27432" marB="27432" anchor="ctr">
-                    <a:lnL w="6350" cap="flat" cmpd="sng" algn="ctr">
-                      <a:solidFill>
-                        <a:srgbClr val="B8D4F0"/>
-                      </a:solidFill>
-                      <a:prstDash val="solid"/>
-                      <a:round/>
-                      <a:headEnd type="none" w="med" len="med"/>
-                      <a:tailEnd type="none" w="med" len="med"/>
-                    </a:lnL>
-                    <a:lnR w="6350" cap="flat" cmpd="sng" algn="ctr">
-                      <a:solidFill>
-                        <a:srgbClr val="B8D4F0"/>
-                      </a:solidFill>
-                      <a:prstDash val="solid"/>
-                      <a:round/>
-                      <a:headEnd type="none" w="med" len="med"/>
-                      <a:tailEnd type="none" w="med" len="med"/>
-                    </a:lnR>
-                    <a:lnT w="6350" cap="flat" cmpd="sng" algn="ctr">
-                      <a:solidFill>
-                        <a:srgbClr val="B8D4F0"/>
-                      </a:solidFill>
-                      <a:prstDash val="solid"/>
-                      <a:round/>
-                      <a:headEnd type="none" w="med" len="med"/>
-                      <a:tailEnd type="none" w="med" len="med"/>
-                    </a:lnT>
-                    <a:lnB w="6350" cap="flat" cmpd="sng" algn="ctr">
-                      <a:solidFill>
-                        <a:srgbClr val="B8D4F0"/>
-                      </a:solidFill>
-                      <a:prstDash val="solid"/>
-                      <a:round/>
-                      <a:headEnd type="none" w="med" len="med"/>
-                      <a:tailEnd type="none" w="med" len="med"/>
-                    </a:lnB>
-                    <a:solidFill>
-                      <a:srgbClr val="DCEFE2"/>
-                    </a:solidFill>
-                  </a:tcPr>
-                </a:tc>
-              </a:tr>
-              <a:tr h="429768">
-                <a:tc>
-                  <a:txBody>
-                    <a:bodyPr/>
-                    <a:lstStyle/>
-                    <a:p>
-                      <a:pPr indent="0" marL="0">
-                        <a:buNone/>
-                      </a:pPr>
-                      <a:r>
-                        <a:rPr lang="en-US" sz="1100" b="1" dirty="0">
-                          <a:solidFill>
-                            <a:srgbClr val="1A1A2E"/>
-                          </a:solidFill>
-                        </a:rPr>
-                        <a:t>Ce que l'US ne dit pas</a:t>
-                      </a:r>
-                      <a:endParaRPr lang="en-US" sz="1100" dirty="0"/>
-                    </a:p>
-                  </a:txBody>
-                  <a:tcPr marL="73152" marR="73152" marT="27432" marB="27432" anchor="ctr">
-                    <a:lnL w="6350" cap="flat" cmpd="sng" algn="ctr">
-                      <a:solidFill>
-                        <a:srgbClr val="B8D4F0"/>
-                      </a:solidFill>
-                      <a:prstDash val="solid"/>
-                      <a:round/>
-                      <a:headEnd type="none" w="med" len="med"/>
-                      <a:tailEnd type="none" w="med" len="med"/>
-                    </a:lnL>
-                    <a:lnR w="6350" cap="flat" cmpd="sng" algn="ctr">
-                      <a:solidFill>
-                        <a:srgbClr val="B8D4F0"/>
-                      </a:solidFill>
-                      <a:prstDash val="solid"/>
-                      <a:round/>
-                      <a:headEnd type="none" w="med" len="med"/>
-                      <a:tailEnd type="none" w="med" len="med"/>
-                    </a:lnR>
-                    <a:lnT w="6350" cap="flat" cmpd="sng" algn="ctr">
-                      <a:solidFill>
-                        <a:srgbClr val="B8D4F0"/>
-                      </a:solidFill>
-                      <a:prstDash val="solid"/>
-                      <a:round/>
-                      <a:headEnd type="none" w="med" len="med"/>
-                      <a:tailEnd type="none" w="med" len="med"/>
-                    </a:lnT>
-                    <a:lnB w="6350" cap="flat" cmpd="sng" algn="ctr">
-                      <a:solidFill>
-                        <a:srgbClr val="B8D4F0"/>
-                      </a:solidFill>
-                      <a:prstDash val="solid"/>
-                      <a:round/>
-                      <a:headEnd type="none" w="med" len="med"/>
-                      <a:tailEnd type="none" w="med" len="med"/>
-                    </a:lnB>
-                    <a:solidFill>
-                      <a:srgbClr val="FFFFFF"/>
-                    </a:solidFill>
-                  </a:tcPr>
-                </a:tc>
-                <a:tc>
-                  <a:txBody>
-                    <a:bodyPr/>
-                    <a:lstStyle/>
-                    <a:p>
-                      <a:pPr indent="0" marL="0">
-                        <a:buNone/>
-                      </a:pPr>
-                      <a:r>
-                        <a:rPr lang="en-US" sz="1100" dirty="0">
-                          <a:solidFill>
-                            <a:srgbClr val="1A1A2E"/>
-                          </a:solidFill>
-                        </a:rPr>
-                        <a:t>Aucune question ; la contradiction sur l'entité inconnue n'est pas vue</a:t>
-                      </a:r>
-                      <a:endParaRPr lang="en-US" sz="1100" dirty="0"/>
-                    </a:p>
-                  </a:txBody>
-                  <a:tcPr marL="73152" marR="73152" marT="27432" marB="27432" anchor="ctr">
-                    <a:lnL w="6350" cap="flat" cmpd="sng" algn="ctr">
-                      <a:solidFill>
-                        <a:srgbClr val="B8D4F0"/>
-                      </a:solidFill>
-                      <a:prstDash val="solid"/>
-                      <a:round/>
-                      <a:headEnd type="none" w="med" len="med"/>
-                      <a:tailEnd type="none" w="med" len="med"/>
-                    </a:lnL>
-                    <a:lnR w="6350" cap="flat" cmpd="sng" algn="ctr">
-                      <a:solidFill>
-                        <a:srgbClr val="B8D4F0"/>
-                      </a:solidFill>
-                      <a:prstDash val="solid"/>
-                      <a:round/>
-                      <a:headEnd type="none" w="med" len="med"/>
-                      <a:tailEnd type="none" w="med" len="med"/>
-                    </a:lnR>
-                    <a:lnT w="6350" cap="flat" cmpd="sng" algn="ctr">
-                      <a:solidFill>
-                        <a:srgbClr val="B8D4F0"/>
-                      </a:solidFill>
-                      <a:prstDash val="solid"/>
-                      <a:round/>
-                      <a:headEnd type="none" w="med" len="med"/>
-                      <a:tailEnd type="none" w="med" len="med"/>
-                    </a:lnT>
-                    <a:lnB w="6350" cap="flat" cmpd="sng" algn="ctr">
-                      <a:solidFill>
-                        <a:srgbClr val="B8D4F0"/>
-                      </a:solidFill>
-                      <a:prstDash val="solid"/>
-                      <a:round/>
-                      <a:headEnd type="none" w="med" len="med"/>
-                      <a:tailEnd type="none" w="med" len="med"/>
-                    </a:lnB>
-                    <a:solidFill>
-                      <a:srgbClr val="FFFFFF"/>
-                    </a:solidFill>
-                  </a:tcPr>
-                </a:tc>
-                <a:tc>
-                  <a:txBody>
-                    <a:bodyPr/>
-                    <a:lstStyle/>
-                    <a:p>
-                      <a:pPr indent="0" marL="0">
-                        <a:buNone/>
-                      </a:pPr>
-                      <a:r>
-                        <a:rPr lang="en-US" sz="1100" dirty="0">
-                          <a:solidFill>
-                            <a:srgbClr val="00338D"/>
-                          </a:solidFill>
-                        </a:rPr>
-                        <a:t>9 questions au PO, dont 2 bloquantes (entité inconnue, documents)</a:t>
-                      </a:r>
-                      <a:endParaRPr lang="en-US" sz="1100" dirty="0"/>
-                    </a:p>
-                  </a:txBody>
-                  <a:tcPr marL="73152" marR="73152" marT="27432" marB="27432" anchor="ctr">
-                    <a:lnL w="6350" cap="flat" cmpd="sng" algn="ctr">
-                      <a:solidFill>
-                        <a:srgbClr val="B8D4F0"/>
-                      </a:solidFill>
-                      <a:prstDash val="solid"/>
-                      <a:round/>
-                      <a:headEnd type="none" w="med" len="med"/>
-                      <a:tailEnd type="none" w="med" len="med"/>
-                    </a:lnL>
-                    <a:lnR w="6350" cap="flat" cmpd="sng" algn="ctr">
-                      <a:solidFill>
-                        <a:srgbClr val="B8D4F0"/>
-                      </a:solidFill>
-                      <a:prstDash val="solid"/>
-                      <a:round/>
-                      <a:headEnd type="none" w="med" len="med"/>
-                      <a:tailEnd type="none" w="med" len="med"/>
-                    </a:lnR>
-                    <a:lnT w="6350" cap="flat" cmpd="sng" algn="ctr">
-                      <a:solidFill>
-                        <a:srgbClr val="B8D4F0"/>
-                      </a:solidFill>
-                      <a:prstDash val="solid"/>
-                      <a:round/>
-                      <a:headEnd type="none" w="med" len="med"/>
-                      <a:tailEnd type="none" w="med" len="med"/>
-                    </a:lnT>
-                    <a:lnB w="6350" cap="flat" cmpd="sng" algn="ctr">
-                      <a:solidFill>
-                        <a:srgbClr val="B8D4F0"/>
-                      </a:solidFill>
-                      <a:prstDash val="solid"/>
-                      <a:round/>
-                      <a:headEnd type="none" w="med" len="med"/>
-                      <a:tailEnd type="none" w="med" len="med"/>
-                    </a:lnB>
-                    <a:solidFill>
-                      <a:srgbClr val="FFFFFF"/>
-                    </a:solidFill>
-                  </a:tcPr>
-                </a:tc>
-              </a:tr>
-              <a:tr h="429768">
-                <a:tc>
-                  <a:txBody>
-                    <a:bodyPr/>
-                    <a:lstStyle/>
-                    <a:p>
-                      <a:pPr indent="0" marL="0">
-                        <a:buNone/>
-                      </a:pPr>
-                      <a:r>
-                        <a:rPr lang="en-US" sz="1100" b="1" dirty="0">
-                          <a:solidFill>
-                            <a:srgbClr val="1A1A2E"/>
-                          </a:solidFill>
-                        </a:rPr>
-                        <a:t>Volume</a:t>
-                      </a:r>
-                      <a:endParaRPr lang="en-US" sz="1100" dirty="0"/>
-                    </a:p>
-                  </a:txBody>
-                  <a:tcPr marL="73152" marR="73152" marT="27432" marB="27432" anchor="ctr">
-                    <a:lnL w="6350" cap="flat" cmpd="sng" algn="ctr">
-                      <a:solidFill>
-                        <a:srgbClr val="B8D4F0"/>
-                      </a:solidFill>
-                      <a:prstDash val="solid"/>
-                      <a:round/>
-                      <a:headEnd type="none" w="med" len="med"/>
-                      <a:tailEnd type="none" w="med" len="med"/>
-                    </a:lnL>
-                    <a:lnR w="6350" cap="flat" cmpd="sng" algn="ctr">
-                      <a:solidFill>
-                        <a:srgbClr val="B8D4F0"/>
-                      </a:solidFill>
-                      <a:prstDash val="solid"/>
-                      <a:round/>
-                      <a:headEnd type="none" w="med" len="med"/>
-                      <a:tailEnd type="none" w="med" len="med"/>
-                    </a:lnR>
-                    <a:lnT w="6350" cap="flat" cmpd="sng" algn="ctr">
-                      <a:solidFill>
-                        <a:srgbClr val="B8D4F0"/>
-                      </a:solidFill>
-                      <a:prstDash val="solid"/>
-                      <a:round/>
-                      <a:headEnd type="none" w="med" len="med"/>
-                      <a:tailEnd type="none" w="med" len="med"/>
-                    </a:lnT>
-                    <a:lnB w="6350" cap="flat" cmpd="sng" algn="ctr">
-                      <a:solidFill>
-                        <a:srgbClr val="B8D4F0"/>
-                      </a:solidFill>
-                      <a:prstDash val="solid"/>
-                      <a:round/>
-                      <a:headEnd type="none" w="med" len="med"/>
-                      <a:tailEnd type="none" w="med" len="med"/>
-                    </a:lnB>
-                    <a:solidFill>
-                      <a:srgbClr val="EEF3FA"/>
-                    </a:solidFill>
-                  </a:tcPr>
-                </a:tc>
-                <a:tc>
-                  <a:txBody>
-                    <a:bodyPr/>
-                    <a:lstStyle/>
-                    <a:p>
-                      <a:pPr indent="0" marL="0">
-                        <a:buNone/>
-                      </a:pPr>
-                      <a:r>
-                        <a:rPr lang="en-US" sz="1100" dirty="0">
-                          <a:solidFill>
-                            <a:srgbClr val="1A1A2E"/>
-                          </a:solidFill>
-                        </a:rPr>
-                        <a:t>Au moins 15 cas</a:t>
-                      </a:r>
-                      <a:endParaRPr lang="en-US" sz="1100" dirty="0"/>
-                    </a:p>
-                  </a:txBody>
-                  <a:tcPr marL="73152" marR="73152" marT="27432" marB="27432" anchor="ctr">
-                    <a:lnL w="6350" cap="flat" cmpd="sng" algn="ctr">
-                      <a:solidFill>
-                        <a:srgbClr val="B8D4F0"/>
-                      </a:solidFill>
-                      <a:prstDash val="solid"/>
-                      <a:round/>
-                      <a:headEnd type="none" w="med" len="med"/>
-                      <a:tailEnd type="none" w="med" len="med"/>
-                    </a:lnL>
-                    <a:lnR w="6350" cap="flat" cmpd="sng" algn="ctr">
-                      <a:solidFill>
-                        <a:srgbClr val="B8D4F0"/>
-                      </a:solidFill>
-                      <a:prstDash val="solid"/>
-                      <a:round/>
-                      <a:headEnd type="none" w="med" len="med"/>
-                      <a:tailEnd type="none" w="med" len="med"/>
-                    </a:lnR>
-                    <a:lnT w="6350" cap="flat" cmpd="sng" algn="ctr">
-                      <a:solidFill>
-                        <a:srgbClr val="B8D4F0"/>
-                      </a:solidFill>
-                      <a:prstDash val="solid"/>
-                      <a:round/>
-                      <a:headEnd type="none" w="med" len="med"/>
-                      <a:tailEnd type="none" w="med" len="med"/>
-                    </a:lnT>
-                    <a:lnB w="6350" cap="flat" cmpd="sng" algn="ctr">
-                      <a:solidFill>
-                        <a:srgbClr val="B8D4F0"/>
-                      </a:solidFill>
-                      <a:prstDash val="solid"/>
-                      <a:round/>
-                      <a:headEnd type="none" w="med" len="med"/>
-                      <a:tailEnd type="none" w="med" len="med"/>
-                    </a:lnB>
-                    <a:solidFill>
-                      <a:srgbClr val="EEF3FA"/>
-                    </a:solidFill>
-                  </a:tcPr>
-                </a:tc>
-                <a:tc>
-                  <a:txBody>
-                    <a:bodyPr/>
-                    <a:lstStyle/>
-                    <a:p>
-                      <a:pPr indent="0" marL="0">
-                        <a:buNone/>
-                      </a:pPr>
-                      <a:r>
-                        <a:rPr lang="en-US" sz="1100" dirty="0">
-                          <a:solidFill>
-                            <a:srgbClr val="00338D"/>
-                          </a:solidFill>
-                        </a:rPr>
-                        <a:t>23 lignes exécutables, chacune avec sa raison</a:t>
-                      </a:r>
-                      <a:endParaRPr lang="en-US" sz="1100" dirty="0"/>
-                    </a:p>
-                  </a:txBody>
-                  <a:tcPr marL="73152" marR="73152" marT="27432" marB="27432" anchor="ctr">
-                    <a:lnL w="6350" cap="flat" cmpd="sng" algn="ctr">
-                      <a:solidFill>
-                        <a:srgbClr val="B8D4F0"/>
-                      </a:solidFill>
-                      <a:prstDash val="solid"/>
-                      <a:round/>
-                      <a:headEnd type="none" w="med" len="med"/>
-                      <a:tailEnd type="none" w="med" len="med"/>
-                    </a:lnL>
-                    <a:lnR w="6350" cap="flat" cmpd="sng" algn="ctr">
-                      <a:solidFill>
-                        <a:srgbClr val="B8D4F0"/>
-                      </a:solidFill>
-                      <a:prstDash val="solid"/>
-                      <a:round/>
-                      <a:headEnd type="none" w="med" len="med"/>
-                      <a:tailEnd type="none" w="med" len="med"/>
-                    </a:lnR>
-                    <a:lnT w="6350" cap="flat" cmpd="sng" algn="ctr">
-                      <a:solidFill>
-                        <a:srgbClr val="B8D4F0"/>
-                      </a:solidFill>
-                      <a:prstDash val="solid"/>
-                      <a:round/>
-                      <a:headEnd type="none" w="med" len="med"/>
-                      <a:tailEnd type="none" w="med" len="med"/>
-                    </a:lnT>
-                    <a:lnB w="6350" cap="flat" cmpd="sng" algn="ctr">
-                      <a:solidFill>
-                        <a:srgbClr val="B8D4F0"/>
-                      </a:solidFill>
-                      <a:prstDash val="solid"/>
-                      <a:round/>
-                      <a:headEnd type="none" w="med" len="med"/>
-                      <a:tailEnd type="none" w="med" len="med"/>
-                    </a:lnB>
-                    <a:solidFill>
-                      <a:srgbClr val="DCEFE2"/>
                     </a:solidFill>
                   </a:tcPr>
                 </a:tc>
@@ -8236,8 +7813,8 @@
         </p:nvSpPr>
         <p:spPr>
           <a:xfrm>
-            <a:off x="548640" y="5943600"/>
-            <a:ext cx="11064240" cy="310896"/>
+            <a:off x="548640" y="4526280"/>
+            <a:ext cx="6400800" cy="365760"/>
           </a:xfrm>
           <a:prstGeom prst="rect">
             <a:avLst/>
@@ -8258,7 +7835,7 @@
                   <a:srgbClr val="00338D"/>
                 </a:solidFill>
               </a:rPr>
-              <a:t>Gardé de l'agent actuel : </a:t>
+              <a:t>Sans commande, rien : </a:t>
             </a:r>
             <a:pPr indent="0" marL="0">
               <a:buNone/>
@@ -8269,7 +7846,337 @@
                   <a:schemeClr val="tx1"/>
                 </a:solidFill>
               </a:rPr>
-              <a:t>Reprise absente en Renouvellement, valeur par défaut concrète, ouverture du panneau, recherche d'un collaborateur.</a:t>
+              <a:t>un document déposé ne lance aucune analyse ; l'agent dit ce qu'il a reçu et attend.</a:t>
+            </a:r>
+            <a:endParaRPr lang="en-US" sz="1200" dirty="0"/>
+          </a:p>
+        </p:txBody>
+      </p:sp>
+      <p:sp>
+        <p:nvSpPr>
+          <p:cNvPr id="6" name="card"/>
+          <p:cNvSpPr/>
+          <p:nvPr/>
+        </p:nvSpPr>
+        <p:spPr>
+          <a:xfrm>
+            <a:off x="7178040" y="1572768"/>
+            <a:ext cx="4434840" cy="3319272"/>
+          </a:xfrm>
+          <a:prstGeom prst="roundRect">
+            <a:avLst>
+              <a:gd name="adj" fmla="val 2755"/>
+            </a:avLst>
+          </a:prstGeom>
+          <a:solidFill>
+            <a:schemeClr val="tx2"/>
+          </a:solidFill>
+          <a:ln/>
+        </p:spPr>
+      </p:sp>
+      <p:sp>
+        <p:nvSpPr>
+          <p:cNvPr id="7" name="Text 4"/>
+          <p:cNvSpPr txBox="1"/>
+          <p:nvPr/>
+        </p:nvSpPr>
+        <p:spPr>
+          <a:xfrm>
+            <a:off x="7406640" y="1691640"/>
+            <a:ext cx="4023360" cy="347472"/>
+          </a:xfrm>
+          <a:prstGeom prst="rect">
+            <a:avLst/>
+          </a:prstGeom>
+          <a:noFill/>
+          <a:ln/>
+        </p:spPr>
+        <p:txBody>
+          <a:bodyPr wrap="square" lIns="0" tIns="0" rIns="0" bIns="0" rtlCol="0" anchor="t"/>
+          <a:lstStyle/>
+          <a:p>
+            <a:pPr indent="0" marL="0">
+              <a:buNone/>
+            </a:pPr>
+            <a:r>
+              <a:rPr lang="en-US" sz="1500" b="1" dirty="0">
+                <a:solidFill>
+                  <a:schemeClr val="bg1"/>
+                </a:solidFill>
+              </a:rPr>
+              <a:t>Le contexte apprend le projet</a:t>
+            </a:r>
+            <a:endParaRPr lang="en-US" sz="1500" dirty="0"/>
+          </a:p>
+        </p:txBody>
+      </p:sp>
+      <p:sp>
+        <p:nvSpPr>
+          <p:cNvPr id="8" name="Text 5"/>
+          <p:cNvSpPr txBox="1"/>
+          <p:nvPr/>
+        </p:nvSpPr>
+        <p:spPr>
+          <a:xfrm>
+            <a:off x="7406640" y="2148840"/>
+            <a:ext cx="4023360" cy="1965960"/>
+          </a:xfrm>
+          <a:prstGeom prst="rect">
+            <a:avLst/>
+          </a:prstGeom>
+          <a:noFill/>
+          <a:ln/>
+        </p:spPr>
+        <p:txBody>
+          <a:bodyPr wrap="square" lIns="0" tIns="0" rIns="0" bIns="0" rtlCol="0" anchor="t"/>
+          <a:lstStyle/>
+          <a:p>
+            <a:pPr marL="342900" indent="-342900">
+              <a:spcAft>
+                <a:spcPts val="1200"/>
+              </a:spcAft>
+              <a:buSzPct val="100000"/>
+              <a:buFont typeface="+mj-lt"/>
+              <a:buAutoNum type="arabicPeriod" startAt="1"/>
+            </a:pPr>
+            <a:r>
+              <a:rPr lang="en-US" sz="1350" dirty="0">
+                <a:solidFill>
+                  <a:schemeClr val="bg1"/>
+                </a:solidFill>
+              </a:rPr>
+              <a:t>L'analyse d'une US propose des lignes, chacune avec sa source</a:t>
+            </a:r>
+            <a:endParaRPr lang="en-US" sz="1350" dirty="0"/>
+          </a:p>
+          <a:p>
+            <a:pPr marL="342900" indent="-342900">
+              <a:spcAft>
+                <a:spcPts val="1200"/>
+              </a:spcAft>
+              <a:buSzPct val="100000"/>
+              <a:buFont typeface="+mj-lt"/>
+              <a:buAutoNum type="arabicPeriod" startAt="1"/>
+            </a:pPr>
+            <a:r>
+              <a:rPr lang="en-US" sz="1350" dirty="0">
+                <a:solidFill>
+                  <a:schemeClr val="bg1"/>
+                </a:solidFill>
+              </a:rPr>
+              <a:t>La QC choisit ce qui entre</a:t>
+            </a:r>
+            <a:endParaRPr lang="en-US" sz="1350" dirty="0"/>
+          </a:p>
+          <a:p>
+            <a:pPr marL="342900" indent="-342900">
+              <a:spcAft>
+                <a:spcPts val="1200"/>
+              </a:spcAft>
+              <a:buSzPct val="100000"/>
+              <a:buFont typeface="+mj-lt"/>
+              <a:buAutoNum type="arabicPeriod" startAt="1"/>
+            </a:pPr>
+            <a:r>
+              <a:rPr lang="en-US" sz="1350" dirty="0">
+                <a:solidFill>
+                  <a:schemeClr val="bg1"/>
+                </a:solidFill>
+              </a:rPr>
+              <a:t>/maj-contexte l'écrit ; Git garde l'historique</a:t>
+            </a:r>
+            <a:endParaRPr lang="en-US" sz="1350" dirty="0"/>
+          </a:p>
+          <a:p>
+            <a:pPr marL="342900" indent="-342900">
+              <a:spcAft>
+                <a:spcPts val="1200"/>
+              </a:spcAft>
+              <a:buSzPct val="100000"/>
+              <a:buFont typeface="+mj-lt"/>
+              <a:buAutoNum type="arabicPeriod" startAt="1"/>
+            </a:pPr>
+            <a:r>
+              <a:rPr lang="en-US" sz="1350" dirty="0">
+                <a:solidFill>
+                  <a:schemeClr val="bg1"/>
+                </a:solidFill>
+              </a:rPr>
+              <a:t>L'US suivante en profite</a:t>
+            </a:r>
+            <a:endParaRPr lang="en-US" sz="1350" dirty="0"/>
+          </a:p>
+        </p:txBody>
+      </p:sp>
+      <p:sp>
+        <p:nvSpPr>
+          <p:cNvPr id="9" name="Text 6"/>
+          <p:cNvSpPr txBox="1"/>
+          <p:nvPr/>
+        </p:nvSpPr>
+        <p:spPr>
+          <a:xfrm>
+            <a:off x="7406640" y="4206240"/>
+            <a:ext cx="4023360" cy="548640"/>
+          </a:xfrm>
+          <a:prstGeom prst="rect">
+            <a:avLst/>
+          </a:prstGeom>
+          <a:noFill/>
+          <a:ln/>
+        </p:spPr>
+        <p:txBody>
+          <a:bodyPr wrap="square" lIns="0" tIns="0" rIns="0" bIns="0" rtlCol="0" anchor="t"/>
+          <a:lstStyle/>
+          <a:p>
+            <a:pPr indent="0" marL="0">
+              <a:buNone/>
+            </a:pPr>
+            <a:r>
+              <a:rPr lang="en-US" sz="1200" i="1" dirty="0">
+                <a:solidFill>
+                  <a:schemeClr val="accent3"/>
+                </a:solidFill>
+              </a:rPr>
+              <a:t>Une hypothèse ou une question encore ouverte n'entre jamais.</a:t>
+            </a:r>
+            <a:endParaRPr lang="en-US" sz="1200" dirty="0"/>
+          </a:p>
+        </p:txBody>
+      </p:sp>
+      <p:sp>
+        <p:nvSpPr>
+          <p:cNvPr id="10" name="card"/>
+          <p:cNvSpPr/>
+          <p:nvPr/>
+        </p:nvSpPr>
+        <p:spPr>
+          <a:xfrm>
+            <a:off x="548640" y="5074920"/>
+            <a:ext cx="11064240" cy="868680"/>
+          </a:xfrm>
+          <a:prstGeom prst="roundRect">
+            <a:avLst>
+              <a:gd name="adj" fmla="val 10526"/>
+            </a:avLst>
+          </a:prstGeom>
+          <a:solidFill>
+            <a:schemeClr val="accent5"/>
+          </a:solidFill>
+          <a:ln/>
+        </p:spPr>
+      </p:sp>
+      <p:sp>
+        <p:nvSpPr>
+          <p:cNvPr id="11" name="icon-circle"/>
+          <p:cNvSpPr/>
+          <p:nvPr/>
+        </p:nvSpPr>
+        <p:spPr>
+          <a:xfrm>
+            <a:off x="685800" y="5257800"/>
+            <a:ext cx="493776" cy="493776"/>
+          </a:xfrm>
+          <a:prstGeom prst="ellipse">
+            <a:avLst/>
+          </a:prstGeom>
+          <a:solidFill>
+            <a:schemeClr val="accent1"/>
+          </a:solidFill>
+          <a:ln/>
+        </p:spPr>
+      </p:sp>
+      <p:pic>
+        <p:nvPicPr>
+          <p:cNvPr id="12" name="icon" descr="preencoded.png">    </p:cNvPr>
+          <p:cNvPicPr>
+            <a:picLocks noChangeAspect="1"/>
+          </p:cNvPicPr>
+          <p:nvPr/>
+        </p:nvPicPr>
+        <p:blipFill>
+          <a:blip r:embed="rId1"/>
+          <a:stretch>
+            <a:fillRect/>
+          </a:stretch>
+        </p:blipFill>
+        <p:spPr>
+          <a:xfrm>
+            <a:off x="794431" y="5366431"/>
+            <a:ext cx="276515" cy="276515"/>
+          </a:xfrm>
+          <a:prstGeom prst="rect">
+            <a:avLst/>
+          </a:prstGeom>
+        </p:spPr>
+      </p:pic>
+      <p:sp>
+        <p:nvSpPr>
+          <p:cNvPr id="13" name="Text 9"/>
+          <p:cNvSpPr txBox="1"/>
+          <p:nvPr/>
+        </p:nvSpPr>
+        <p:spPr>
+          <a:xfrm>
+            <a:off x="1325880" y="5074920"/>
+            <a:ext cx="10149840" cy="868680"/>
+          </a:xfrm>
+          <a:prstGeom prst="rect">
+            <a:avLst/>
+          </a:prstGeom>
+          <a:noFill/>
+          <a:ln/>
+        </p:spPr>
+        <p:txBody>
+          <a:bodyPr wrap="square" lIns="0" tIns="0" rIns="0" bIns="0" rtlCol="0" anchor="ctr"/>
+          <a:lstStyle/>
+          <a:p>
+            <a:pPr indent="0" marL="0">
+              <a:buNone/>
+            </a:pPr>
+            <a:r>
+              <a:rPr lang="en-US" sz="1200" b="1" dirty="0">
+                <a:solidFill>
+                  <a:srgbClr val="00338D"/>
+                </a:solidFill>
+              </a:rPr>
+              <a:t>Contrôlé par script : </a:t>
+            </a:r>
+            <a:pPr indent="0" marL="0">
+              <a:buNone/>
+            </a:pPr>
+            <a:r>
+              <a:rPr lang="en-US" sz="1200" dirty="0">
+                <a:solidFill>
+                  <a:schemeClr val="tx1"/>
+                </a:solidFill>
+              </a:rPr>
+              <a:t>écriture dans Azure DevOps, commit et push demandent confirmation ; suppression et affichage du PAT sont refusés.</a:t>
+            </a:r>
+            <a:endParaRPr lang="en-US" sz="1200" dirty="0"/>
+          </a:p>
+          <a:p>
+            <a:pPr indent="0" marL="0">
+              <a:buNone/>
+            </a:pPr>
+            <a:r>
+              <a:rPr lang="en-US" sz="1200" b="1" dirty="0">
+                <a:solidFill>
+                  <a:srgbClr val="00338D"/>
+                </a:solidFill>
+              </a:rPr>
+              <a:t>Outils : </a:t>
+            </a:r>
+            <a:pPr indent="0" marL="0">
+              <a:buNone/>
+            </a:pPr>
+            <a:r>
+              <a:rPr lang="en-US" sz="1200" dirty="0">
+                <a:solidFill>
+                  <a:schemeClr val="tx1"/>
+                </a:solidFill>
+              </a:rPr>
+              <a:t>complet dans Claude Code ; dans VS Code avec Copilot, l'agent et les skills sont lus, pas ces contrôles.</a:t>
             </a:r>
             <a:endParaRPr lang="en-US" sz="1200" dirty="0"/>
           </a:p>
@@ -8377,6 +8284,2080 @@
                   <a:schemeClr val="tx2"/>
                 </a:solidFill>
               </a:rPr>
+              <a:t>Les résultats comparés sur l'US 417829</a:t>
+            </a:r>
+            <a:endParaRPr lang="en-US" sz="2800" dirty="0"/>
+          </a:p>
+        </p:txBody>
+      </p:sp>
+      <p:sp>
+        <p:nvSpPr>
+          <p:cNvPr id="3" name="Text 0"/>
+          <p:cNvSpPr/>
+          <p:nvPr>
+            <p:ph idx="101" type="body" hasCustomPrompt="1"/>
+          </p:nvPr>
+        </p:nvSpPr>
+        <p:spPr>
+          <a:xfrm>
+            <a:off x="548640" y="960120"/>
+            <a:ext cx="11064240" cy="502920"/>
+          </a:xfrm>
+          <a:prstGeom prst="rect">
+            <a:avLst/>
+          </a:prstGeom>
+          <a:noFill/>
+          <a:ln/>
+        </p:spPr>
+        <p:txBody>
+          <a:bodyPr wrap="square" lIns="0" tIns="0" rIns="0" bIns="0" rtlCol="0" anchor="t"/>
+          <a:lstStyle/>
+          <a:p>
+            <a:pPr algn="l" indent="0" marL="0">
+              <a:buNone/>
+            </a:pPr>
+            <a:r>
+              <a:rPr lang="en-US" sz="1600" i="1" dirty="0">
+                <a:solidFill>
+                  <a:schemeClr val="accent1"/>
+                </a:solidFill>
+              </a:rPr>
+              <a:t>Même US « Créer une nouvelle demande ». Notre résultat est un premier essai, à rejouer avec le nouvel agent dans l'outil de l'équipe.</a:t>
+            </a:r>
+            <a:endParaRPr lang="en-US" sz="1600" dirty="0"/>
+          </a:p>
+        </p:txBody>
+      </p:sp>
+      <p:graphicFrame>
+        <p:nvGraphicFramePr>
+          <p:cNvPr id="7" name="table-comparaison"/>
+          <p:cNvGraphicFramePr>
+            <a:graphicFrameLocks noGrp="1"/>
+          </p:cNvGraphicFramePr>
+          <p:nvPr>
+            <p:extLst>
+              <p:ext uri="{D42A27DB-BD31-4B8C-83A1-F6EECF244321}">
+                <p14:modId xmlns:p14="http://schemas.microsoft.com/office/powerpoint/2010/main" val="1579011935"/>
+              </p:ext>
+            </p:extLst>
+          </p:nvPr>
+        </p:nvGraphicFramePr>
+        <p:xfrm>
+          <a:off x="548640" y="1572768"/>
+          <a:ext cx="11064240" cy="914400"/>
+        </p:xfrm>
+        <a:graphic>
+          <a:graphicData uri="http://schemas.openxmlformats.org/drawingml/2006/table">
+            <a:tbl>
+              <a:tblPr/>
+              <a:tblGrid>
+                <a:gridCol w="2286000"/>
+                <a:gridCol w="4206240"/>
+                <a:gridCol w="4572000"/>
+              </a:tblGrid>
+              <a:tr h="329184">
+                <a:tc>
+                  <a:txBody>
+                    <a:bodyPr/>
+                    <a:lstStyle/>
+                    <a:p>
+                      <a:pPr indent="0" marL="0">
+                        <a:buNone/>
+                      </a:pPr>
+                      <a:r>
+                        <a:rPr lang="en-US" sz="1200" b="1" dirty="0">
+                          <a:solidFill>
+                            <a:srgbClr val="FFFFFF"/>
+                          </a:solidFill>
+                        </a:rPr>
+                        <a:t>Point</a:t>
+                      </a:r>
+                      <a:endParaRPr lang="en-US" sz="1200" dirty="0"/>
+                    </a:p>
+                  </a:txBody>
+                  <a:tcPr marL="73152" marR="73152" marT="27432" marB="27432" anchor="ctr">
+                    <a:lnL w="6350" cap="flat" cmpd="sng" algn="ctr">
+                      <a:solidFill>
+                        <a:srgbClr val="B8D4F0"/>
+                      </a:solidFill>
+                      <a:prstDash val="solid"/>
+                      <a:round/>
+                      <a:headEnd type="none" w="med" len="med"/>
+                      <a:tailEnd type="none" w="med" len="med"/>
+                    </a:lnL>
+                    <a:lnR w="6350" cap="flat" cmpd="sng" algn="ctr">
+                      <a:solidFill>
+                        <a:srgbClr val="B8D4F0"/>
+                      </a:solidFill>
+                      <a:prstDash val="solid"/>
+                      <a:round/>
+                      <a:headEnd type="none" w="med" len="med"/>
+                      <a:tailEnd type="none" w="med" len="med"/>
+                    </a:lnR>
+                    <a:lnT w="6350" cap="flat" cmpd="sng" algn="ctr">
+                      <a:solidFill>
+                        <a:srgbClr val="B8D4F0"/>
+                      </a:solidFill>
+                      <a:prstDash val="solid"/>
+                      <a:round/>
+                      <a:headEnd type="none" w="med" len="med"/>
+                      <a:tailEnd type="none" w="med" len="med"/>
+                    </a:lnT>
+                    <a:lnB w="6350" cap="flat" cmpd="sng" algn="ctr">
+                      <a:solidFill>
+                        <a:srgbClr val="B8D4F0"/>
+                      </a:solidFill>
+                      <a:prstDash val="solid"/>
+                      <a:round/>
+                      <a:headEnd type="none" w="med" len="med"/>
+                      <a:tailEnd type="none" w="med" len="med"/>
+                    </a:lnB>
+                    <a:solidFill>
+                      <a:srgbClr val="00338D"/>
+                    </a:solidFill>
+                  </a:tcPr>
+                </a:tc>
+                <a:tc>
+                  <a:txBody>
+                    <a:bodyPr/>
+                    <a:lstStyle/>
+                    <a:p>
+                      <a:pPr indent="0" marL="0">
+                        <a:buNone/>
+                      </a:pPr>
+                      <a:r>
+                        <a:rPr lang="en-US" sz="1200" b="1" dirty="0">
+                          <a:solidFill>
+                            <a:srgbClr val="FFFFFF"/>
+                          </a:solidFill>
+                        </a:rPr>
+                        <a:t>Agent QC actuel</a:t>
+                      </a:r>
+                      <a:endParaRPr lang="en-US" sz="1200" dirty="0"/>
+                    </a:p>
+                  </a:txBody>
+                  <a:tcPr marL="73152" marR="73152" marT="27432" marB="27432" anchor="ctr">
+                    <a:lnL w="6350" cap="flat" cmpd="sng" algn="ctr">
+                      <a:solidFill>
+                        <a:srgbClr val="B8D4F0"/>
+                      </a:solidFill>
+                      <a:prstDash val="solid"/>
+                      <a:round/>
+                      <a:headEnd type="none" w="med" len="med"/>
+                      <a:tailEnd type="none" w="med" len="med"/>
+                    </a:lnL>
+                    <a:lnR w="6350" cap="flat" cmpd="sng" algn="ctr">
+                      <a:solidFill>
+                        <a:srgbClr val="B8D4F0"/>
+                      </a:solidFill>
+                      <a:prstDash val="solid"/>
+                      <a:round/>
+                      <a:headEnd type="none" w="med" len="med"/>
+                      <a:tailEnd type="none" w="med" len="med"/>
+                    </a:lnR>
+                    <a:lnT w="6350" cap="flat" cmpd="sng" algn="ctr">
+                      <a:solidFill>
+                        <a:srgbClr val="B8D4F0"/>
+                      </a:solidFill>
+                      <a:prstDash val="solid"/>
+                      <a:round/>
+                      <a:headEnd type="none" w="med" len="med"/>
+                      <a:tailEnd type="none" w="med" len="med"/>
+                    </a:lnT>
+                    <a:lnB w="6350" cap="flat" cmpd="sng" algn="ctr">
+                      <a:solidFill>
+                        <a:srgbClr val="B8D4F0"/>
+                      </a:solidFill>
+                      <a:prstDash val="solid"/>
+                      <a:round/>
+                      <a:headEnd type="none" w="med" len="med"/>
+                      <a:tailEnd type="none" w="med" len="med"/>
+                    </a:lnB>
+                    <a:solidFill>
+                      <a:srgbClr val="B23B3B"/>
+                    </a:solidFill>
+                  </a:tcPr>
+                </a:tc>
+                <a:tc>
+                  <a:txBody>
+                    <a:bodyPr/>
+                    <a:lstStyle/>
+                    <a:p>
+                      <a:pPr indent="0" marL="0">
+                        <a:buNone/>
+                      </a:pPr>
+                      <a:r>
+                        <a:rPr lang="en-US" sz="1200" b="1" dirty="0">
+                          <a:solidFill>
+                            <a:srgbClr val="FFFFFF"/>
+                          </a:solidFill>
+                        </a:rPr>
+                        <a:t>Version proposée</a:t>
+                      </a:r>
+                      <a:endParaRPr lang="en-US" sz="1200" dirty="0"/>
+                    </a:p>
+                  </a:txBody>
+                  <a:tcPr marL="73152" marR="73152" marT="27432" marB="27432" anchor="ctr">
+                    <a:lnL w="6350" cap="flat" cmpd="sng" algn="ctr">
+                      <a:solidFill>
+                        <a:srgbClr val="B8D4F0"/>
+                      </a:solidFill>
+                      <a:prstDash val="solid"/>
+                      <a:round/>
+                      <a:headEnd type="none" w="med" len="med"/>
+                      <a:tailEnd type="none" w="med" len="med"/>
+                    </a:lnL>
+                    <a:lnR w="6350" cap="flat" cmpd="sng" algn="ctr">
+                      <a:solidFill>
+                        <a:srgbClr val="B8D4F0"/>
+                      </a:solidFill>
+                      <a:prstDash val="solid"/>
+                      <a:round/>
+                      <a:headEnd type="none" w="med" len="med"/>
+                      <a:tailEnd type="none" w="med" len="med"/>
+                    </a:lnR>
+                    <a:lnT w="6350" cap="flat" cmpd="sng" algn="ctr">
+                      <a:solidFill>
+                        <a:srgbClr val="B8D4F0"/>
+                      </a:solidFill>
+                      <a:prstDash val="solid"/>
+                      <a:round/>
+                      <a:headEnd type="none" w="med" len="med"/>
+                      <a:tailEnd type="none" w="med" len="med"/>
+                    </a:lnT>
+                    <a:lnB w="6350" cap="flat" cmpd="sng" algn="ctr">
+                      <a:solidFill>
+                        <a:srgbClr val="B8D4F0"/>
+                      </a:solidFill>
+                      <a:prstDash val="solid"/>
+                      <a:round/>
+                      <a:headEnd type="none" w="med" len="med"/>
+                      <a:tailEnd type="none" w="med" len="med"/>
+                    </a:lnB>
+                    <a:solidFill>
+                      <a:srgbClr val="2E7D4F"/>
+                    </a:solidFill>
+                  </a:tcPr>
+                </a:tc>
+              </a:tr>
+              <a:tr h="429768">
+                <a:tc>
+                  <a:txBody>
+                    <a:bodyPr/>
+                    <a:lstStyle/>
+                    <a:p>
+                      <a:pPr indent="0" marL="0">
+                        <a:buNone/>
+                      </a:pPr>
+                      <a:r>
+                        <a:rPr lang="en-US" sz="1100" b="1" dirty="0">
+                          <a:solidFill>
+                            <a:srgbClr val="1A1A2E"/>
+                          </a:solidFill>
+                        </a:rPr>
+                        <a:t>Forme</a:t>
+                      </a:r>
+                      <a:endParaRPr lang="en-US" sz="1100" dirty="0"/>
+                    </a:p>
+                  </a:txBody>
+                  <a:tcPr marL="73152" marR="73152" marT="27432" marB="27432" anchor="ctr">
+                    <a:lnL w="6350" cap="flat" cmpd="sng" algn="ctr">
+                      <a:solidFill>
+                        <a:srgbClr val="B8D4F0"/>
+                      </a:solidFill>
+                      <a:prstDash val="solid"/>
+                      <a:round/>
+                      <a:headEnd type="none" w="med" len="med"/>
+                      <a:tailEnd type="none" w="med" len="med"/>
+                    </a:lnL>
+                    <a:lnR w="6350" cap="flat" cmpd="sng" algn="ctr">
+                      <a:solidFill>
+                        <a:srgbClr val="B8D4F0"/>
+                      </a:solidFill>
+                      <a:prstDash val="solid"/>
+                      <a:round/>
+                      <a:headEnd type="none" w="med" len="med"/>
+                      <a:tailEnd type="none" w="med" len="med"/>
+                    </a:lnR>
+                    <a:lnT w="6350" cap="flat" cmpd="sng" algn="ctr">
+                      <a:solidFill>
+                        <a:srgbClr val="B8D4F0"/>
+                      </a:solidFill>
+                      <a:prstDash val="solid"/>
+                      <a:round/>
+                      <a:headEnd type="none" w="med" len="med"/>
+                      <a:tailEnd type="none" w="med" len="med"/>
+                    </a:lnT>
+                    <a:lnB w="6350" cap="flat" cmpd="sng" algn="ctr">
+                      <a:solidFill>
+                        <a:srgbClr val="B8D4F0"/>
+                      </a:solidFill>
+                      <a:prstDash val="solid"/>
+                      <a:round/>
+                      <a:headEnd type="none" w="med" len="med"/>
+                      <a:tailEnd type="none" w="med" len="med"/>
+                    </a:lnB>
+                    <a:solidFill>
+                      <a:srgbClr val="EEF3FA"/>
+                    </a:solidFill>
+                  </a:tcPr>
+                </a:tc>
+                <a:tc>
+                  <a:txBody>
+                    <a:bodyPr/>
+                    <a:lstStyle/>
+                    <a:p>
+                      <a:pPr indent="0" marL="0">
+                        <a:buNone/>
+                      </a:pPr>
+                      <a:r>
+                        <a:rPr lang="en-US" sz="1100" dirty="0">
+                          <a:solidFill>
+                            <a:srgbClr val="1A1A2E"/>
+                          </a:solidFill>
+                        </a:rPr>
+                        <a:t>Une ligne Given, When, Then en anglais par cas ; « Fonctionnel » partout</a:t>
+                      </a:r>
+                      <a:endParaRPr lang="en-US" sz="1100" dirty="0"/>
+                    </a:p>
+                  </a:txBody>
+                  <a:tcPr marL="73152" marR="73152" marT="27432" marB="27432" anchor="ctr">
+                    <a:lnL w="6350" cap="flat" cmpd="sng" algn="ctr">
+                      <a:solidFill>
+                        <a:srgbClr val="B8D4F0"/>
+                      </a:solidFill>
+                      <a:prstDash val="solid"/>
+                      <a:round/>
+                      <a:headEnd type="none" w="med" len="med"/>
+                      <a:tailEnd type="none" w="med" len="med"/>
+                    </a:lnL>
+                    <a:lnR w="6350" cap="flat" cmpd="sng" algn="ctr">
+                      <a:solidFill>
+                        <a:srgbClr val="B8D4F0"/>
+                      </a:solidFill>
+                      <a:prstDash val="solid"/>
+                      <a:round/>
+                      <a:headEnd type="none" w="med" len="med"/>
+                      <a:tailEnd type="none" w="med" len="med"/>
+                    </a:lnR>
+                    <a:lnT w="6350" cap="flat" cmpd="sng" algn="ctr">
+                      <a:solidFill>
+                        <a:srgbClr val="B8D4F0"/>
+                      </a:solidFill>
+                      <a:prstDash val="solid"/>
+                      <a:round/>
+                      <a:headEnd type="none" w="med" len="med"/>
+                      <a:tailEnd type="none" w="med" len="med"/>
+                    </a:lnT>
+                    <a:lnB w="6350" cap="flat" cmpd="sng" algn="ctr">
+                      <a:solidFill>
+                        <a:srgbClr val="B8D4F0"/>
+                      </a:solidFill>
+                      <a:prstDash val="solid"/>
+                      <a:round/>
+                      <a:headEnd type="none" w="med" len="med"/>
+                      <a:tailEnd type="none" w="med" len="med"/>
+                    </a:lnB>
+                    <a:solidFill>
+                      <a:srgbClr val="EEF3FA"/>
+                    </a:solidFill>
+                  </a:tcPr>
+                </a:tc>
+                <a:tc>
+                  <a:txBody>
+                    <a:bodyPr/>
+                    <a:lstStyle/>
+                    <a:p>
+                      <a:pPr indent="0" marL="0">
+                        <a:buNone/>
+                      </a:pPr>
+                      <a:r>
+                        <a:rPr lang="en-US" sz="1100" dirty="0">
+                          <a:solidFill>
+                            <a:srgbClr val="00338D"/>
+                          </a:solidFill>
+                        </a:rPr>
+                        <a:t>Gherkin en français, préconditions, actions et résultats sur des lignes séparées</a:t>
+                      </a:r>
+                      <a:endParaRPr lang="en-US" sz="1100" dirty="0"/>
+                    </a:p>
+                  </a:txBody>
+                  <a:tcPr marL="73152" marR="73152" marT="27432" marB="27432" anchor="ctr">
+                    <a:lnL w="6350" cap="flat" cmpd="sng" algn="ctr">
+                      <a:solidFill>
+                        <a:srgbClr val="B8D4F0"/>
+                      </a:solidFill>
+                      <a:prstDash val="solid"/>
+                      <a:round/>
+                      <a:headEnd type="none" w="med" len="med"/>
+                      <a:tailEnd type="none" w="med" len="med"/>
+                    </a:lnL>
+                    <a:lnR w="6350" cap="flat" cmpd="sng" algn="ctr">
+                      <a:solidFill>
+                        <a:srgbClr val="B8D4F0"/>
+                      </a:solidFill>
+                      <a:prstDash val="solid"/>
+                      <a:round/>
+                      <a:headEnd type="none" w="med" len="med"/>
+                      <a:tailEnd type="none" w="med" len="med"/>
+                    </a:lnR>
+                    <a:lnT w="6350" cap="flat" cmpd="sng" algn="ctr">
+                      <a:solidFill>
+                        <a:srgbClr val="B8D4F0"/>
+                      </a:solidFill>
+                      <a:prstDash val="solid"/>
+                      <a:round/>
+                      <a:headEnd type="none" w="med" len="med"/>
+                      <a:tailEnd type="none" w="med" len="med"/>
+                    </a:lnT>
+                    <a:lnB w="6350" cap="flat" cmpd="sng" algn="ctr">
+                      <a:solidFill>
+                        <a:srgbClr val="B8D4F0"/>
+                      </a:solidFill>
+                      <a:prstDash val="solid"/>
+                      <a:round/>
+                      <a:headEnd type="none" w="med" len="med"/>
+                      <a:tailEnd type="none" w="med" len="med"/>
+                    </a:lnB>
+                    <a:solidFill>
+                      <a:srgbClr val="DCEFE2"/>
+                    </a:solidFill>
+                  </a:tcPr>
+                </a:tc>
+              </a:tr>
+              <a:tr h="429768">
+                <a:tc>
+                  <a:txBody>
+                    <a:bodyPr/>
+                    <a:lstStyle/>
+                    <a:p>
+                      <a:pPr indent="0" marL="0">
+                        <a:buNone/>
+                      </a:pPr>
+                      <a:r>
+                        <a:rPr lang="en-US" sz="1100" b="1" dirty="0">
+                          <a:solidFill>
+                            <a:srgbClr val="1A1A2E"/>
+                          </a:solidFill>
+                        </a:rPr>
+                        <a:t>Préconditions</a:t>
+                      </a:r>
+                      <a:endParaRPr lang="en-US" sz="1100" dirty="0"/>
+                    </a:p>
+                  </a:txBody>
+                  <a:tcPr marL="73152" marR="73152" marT="27432" marB="27432" anchor="ctr">
+                    <a:lnL w="6350" cap="flat" cmpd="sng" algn="ctr">
+                      <a:solidFill>
+                        <a:srgbClr val="B8D4F0"/>
+                      </a:solidFill>
+                      <a:prstDash val="solid"/>
+                      <a:round/>
+                      <a:headEnd type="none" w="med" len="med"/>
+                      <a:tailEnd type="none" w="med" len="med"/>
+                    </a:lnL>
+                    <a:lnR w="6350" cap="flat" cmpd="sng" algn="ctr">
+                      <a:solidFill>
+                        <a:srgbClr val="B8D4F0"/>
+                      </a:solidFill>
+                      <a:prstDash val="solid"/>
+                      <a:round/>
+                      <a:headEnd type="none" w="med" len="med"/>
+                      <a:tailEnd type="none" w="med" len="med"/>
+                    </a:lnR>
+                    <a:lnT w="6350" cap="flat" cmpd="sng" algn="ctr">
+                      <a:solidFill>
+                        <a:srgbClr val="B8D4F0"/>
+                      </a:solidFill>
+                      <a:prstDash val="solid"/>
+                      <a:round/>
+                      <a:headEnd type="none" w="med" len="med"/>
+                      <a:tailEnd type="none" w="med" len="med"/>
+                    </a:lnT>
+                    <a:lnB w="6350" cap="flat" cmpd="sng" algn="ctr">
+                      <a:solidFill>
+                        <a:srgbClr val="B8D4F0"/>
+                      </a:solidFill>
+                      <a:prstDash val="solid"/>
+                      <a:round/>
+                      <a:headEnd type="none" w="med" len="med"/>
+                      <a:tailEnd type="none" w="med" len="med"/>
+                    </a:lnB>
+                    <a:solidFill>
+                      <a:srgbClr val="FFFFFF"/>
+                    </a:solidFill>
+                  </a:tcPr>
+                </a:tc>
+                <a:tc>
+                  <a:txBody>
+                    <a:bodyPr/>
+                    <a:lstStyle/>
+                    <a:p>
+                      <a:pPr indent="0" marL="0">
+                        <a:buNone/>
+                      </a:pPr>
+                      <a:r>
+                        <a:rPr lang="en-US" sz="1100" dirty="0">
+                          <a:solidFill>
+                            <a:srgbClr val="1A1A2E"/>
+                          </a:solidFill>
+                        </a:rPr>
+                        <a:t>« Given le formulaire ouvert » : ni rôle, ni écran ; « une entité valide »</a:t>
+                      </a:r>
+                      <a:endParaRPr lang="en-US" sz="1100" dirty="0"/>
+                    </a:p>
+                  </a:txBody>
+                  <a:tcPr marL="73152" marR="73152" marT="27432" marB="27432" anchor="ctr">
+                    <a:lnL w="6350" cap="flat" cmpd="sng" algn="ctr">
+                      <a:solidFill>
+                        <a:srgbClr val="B8D4F0"/>
+                      </a:solidFill>
+                      <a:prstDash val="solid"/>
+                      <a:round/>
+                      <a:headEnd type="none" w="med" len="med"/>
+                      <a:tailEnd type="none" w="med" len="med"/>
+                    </a:lnL>
+                    <a:lnR w="6350" cap="flat" cmpd="sng" algn="ctr">
+                      <a:solidFill>
+                        <a:srgbClr val="B8D4F0"/>
+                      </a:solidFill>
+                      <a:prstDash val="solid"/>
+                      <a:round/>
+                      <a:headEnd type="none" w="med" len="med"/>
+                      <a:tailEnd type="none" w="med" len="med"/>
+                    </a:lnR>
+                    <a:lnT w="6350" cap="flat" cmpd="sng" algn="ctr">
+                      <a:solidFill>
+                        <a:srgbClr val="B8D4F0"/>
+                      </a:solidFill>
+                      <a:prstDash val="solid"/>
+                      <a:round/>
+                      <a:headEnd type="none" w="med" len="med"/>
+                      <a:tailEnd type="none" w="med" len="med"/>
+                    </a:lnT>
+                    <a:lnB w="6350" cap="flat" cmpd="sng" algn="ctr">
+                      <a:solidFill>
+                        <a:srgbClr val="B8D4F0"/>
+                      </a:solidFill>
+                      <a:prstDash val="solid"/>
+                      <a:round/>
+                      <a:headEnd type="none" w="med" len="med"/>
+                      <a:tailEnd type="none" w="med" len="med"/>
+                    </a:lnB>
+                    <a:solidFill>
+                      <a:srgbClr val="FFFFFF"/>
+                    </a:solidFill>
+                  </a:tcPr>
+                </a:tc>
+                <a:tc>
+                  <a:txBody>
+                    <a:bodyPr/>
+                    <a:lstStyle/>
+                    <a:p>
+                      <a:pPr indent="0" marL="0">
+                        <a:buNone/>
+                      </a:pPr>
+                      <a:r>
+                        <a:rPr lang="en-US" sz="1100" dirty="0">
+                          <a:solidFill>
+                            <a:srgbClr val="00338D"/>
+                          </a:solidFill>
+                        </a:rPr>
+                        <a:t>Rôle et compte, écran de départ, entité et statut de sa demande, documents joints</a:t>
+                      </a:r>
+                      <a:endParaRPr lang="en-US" sz="1100" dirty="0"/>
+                    </a:p>
+                  </a:txBody>
+                  <a:tcPr marL="73152" marR="73152" marT="27432" marB="27432" anchor="ctr">
+                    <a:lnL w="6350" cap="flat" cmpd="sng" algn="ctr">
+                      <a:solidFill>
+                        <a:srgbClr val="B8D4F0"/>
+                      </a:solidFill>
+                      <a:prstDash val="solid"/>
+                      <a:round/>
+                      <a:headEnd type="none" w="med" len="med"/>
+                      <a:tailEnd type="none" w="med" len="med"/>
+                    </a:lnL>
+                    <a:lnR w="6350" cap="flat" cmpd="sng" algn="ctr">
+                      <a:solidFill>
+                        <a:srgbClr val="B8D4F0"/>
+                      </a:solidFill>
+                      <a:prstDash val="solid"/>
+                      <a:round/>
+                      <a:headEnd type="none" w="med" len="med"/>
+                      <a:tailEnd type="none" w="med" len="med"/>
+                    </a:lnR>
+                    <a:lnT w="6350" cap="flat" cmpd="sng" algn="ctr">
+                      <a:solidFill>
+                        <a:srgbClr val="B8D4F0"/>
+                      </a:solidFill>
+                      <a:prstDash val="solid"/>
+                      <a:round/>
+                      <a:headEnd type="none" w="med" len="med"/>
+                      <a:tailEnd type="none" w="med" len="med"/>
+                    </a:lnT>
+                    <a:lnB w="6350" cap="flat" cmpd="sng" algn="ctr">
+                      <a:solidFill>
+                        <a:srgbClr val="B8D4F0"/>
+                      </a:solidFill>
+                      <a:prstDash val="solid"/>
+                      <a:round/>
+                      <a:headEnd type="none" w="med" len="med"/>
+                      <a:tailEnd type="none" w="med" len="med"/>
+                    </a:lnB>
+                    <a:solidFill>
+                      <a:srgbClr val="FFFFFF"/>
+                    </a:solidFill>
+                  </a:tcPr>
+                </a:tc>
+              </a:tr>
+              <a:tr h="429768">
+                <a:tc>
+                  <a:txBody>
+                    <a:bodyPr/>
+                    <a:lstStyle/>
+                    <a:p>
+                      <a:pPr indent="0" marL="0">
+                        <a:buNone/>
+                      </a:pPr>
+                      <a:r>
+                        <a:rPr lang="en-US" sz="1100" b="1" dirty="0">
+                          <a:solidFill>
+                            <a:srgbClr val="1A1A2E"/>
+                          </a:solidFill>
+                        </a:rPr>
+                        <a:t>Rôles</a:t>
+                      </a:r>
+                      <a:endParaRPr lang="en-US" sz="1100" dirty="0"/>
+                    </a:p>
+                  </a:txBody>
+                  <a:tcPr marL="73152" marR="73152" marT="27432" marB="27432" anchor="ctr">
+                    <a:lnL w="6350" cap="flat" cmpd="sng" algn="ctr">
+                      <a:solidFill>
+                        <a:srgbClr val="B8D4F0"/>
+                      </a:solidFill>
+                      <a:prstDash val="solid"/>
+                      <a:round/>
+                      <a:headEnd type="none" w="med" len="med"/>
+                      <a:tailEnd type="none" w="med" len="med"/>
+                    </a:lnL>
+                    <a:lnR w="6350" cap="flat" cmpd="sng" algn="ctr">
+                      <a:solidFill>
+                        <a:srgbClr val="B8D4F0"/>
+                      </a:solidFill>
+                      <a:prstDash val="solid"/>
+                      <a:round/>
+                      <a:headEnd type="none" w="med" len="med"/>
+                      <a:tailEnd type="none" w="med" len="med"/>
+                    </a:lnR>
+                    <a:lnT w="6350" cap="flat" cmpd="sng" algn="ctr">
+                      <a:solidFill>
+                        <a:srgbClr val="B8D4F0"/>
+                      </a:solidFill>
+                      <a:prstDash val="solid"/>
+                      <a:round/>
+                      <a:headEnd type="none" w="med" len="med"/>
+                      <a:tailEnd type="none" w="med" len="med"/>
+                    </a:lnT>
+                    <a:lnB w="6350" cap="flat" cmpd="sng" algn="ctr">
+                      <a:solidFill>
+                        <a:srgbClr val="B8D4F0"/>
+                      </a:solidFill>
+                      <a:prstDash val="solid"/>
+                      <a:round/>
+                      <a:headEnd type="none" w="med" len="med"/>
+                      <a:tailEnd type="none" w="med" len="med"/>
+                    </a:lnB>
+                    <a:solidFill>
+                      <a:srgbClr val="EEF3FA"/>
+                    </a:solidFill>
+                  </a:tcPr>
+                </a:tc>
+                <a:tc>
+                  <a:txBody>
+                    <a:bodyPr/>
+                    <a:lstStyle/>
+                    <a:p>
+                      <a:pPr indent="0" marL="0">
+                        <a:buNone/>
+                      </a:pPr>
+                      <a:r>
+                        <a:rPr lang="en-US" sz="1100" dirty="0">
+                          <a:solidFill>
+                            <a:srgbClr val="1A1A2E"/>
+                          </a:solidFill>
+                        </a:rPr>
+                        <a:t>« un rôle autre qu'Admin ou SuperAdmin »</a:t>
+                      </a:r>
+                      <a:endParaRPr lang="en-US" sz="1100" dirty="0"/>
+                    </a:p>
+                  </a:txBody>
+                  <a:tcPr marL="73152" marR="73152" marT="27432" marB="27432" anchor="ctr">
+                    <a:lnL w="6350" cap="flat" cmpd="sng" algn="ctr">
+                      <a:solidFill>
+                        <a:srgbClr val="B8D4F0"/>
+                      </a:solidFill>
+                      <a:prstDash val="solid"/>
+                      <a:round/>
+                      <a:headEnd type="none" w="med" len="med"/>
+                      <a:tailEnd type="none" w="med" len="med"/>
+                    </a:lnL>
+                    <a:lnR w="6350" cap="flat" cmpd="sng" algn="ctr">
+                      <a:solidFill>
+                        <a:srgbClr val="B8D4F0"/>
+                      </a:solidFill>
+                      <a:prstDash val="solid"/>
+                      <a:round/>
+                      <a:headEnd type="none" w="med" len="med"/>
+                      <a:tailEnd type="none" w="med" len="med"/>
+                    </a:lnR>
+                    <a:lnT w="6350" cap="flat" cmpd="sng" algn="ctr">
+                      <a:solidFill>
+                        <a:srgbClr val="B8D4F0"/>
+                      </a:solidFill>
+                      <a:prstDash val="solid"/>
+                      <a:round/>
+                      <a:headEnd type="none" w="med" len="med"/>
+                      <a:tailEnd type="none" w="med" len="med"/>
+                    </a:lnT>
+                    <a:lnB w="6350" cap="flat" cmpd="sng" algn="ctr">
+                      <a:solidFill>
+                        <a:srgbClr val="B8D4F0"/>
+                      </a:solidFill>
+                      <a:prstDash val="solid"/>
+                      <a:round/>
+                      <a:headEnd type="none" w="med" len="med"/>
+                      <a:tailEnd type="none" w="med" len="med"/>
+                    </a:lnB>
+                    <a:solidFill>
+                      <a:srgbClr val="EEF3FA"/>
+                    </a:solidFill>
+                  </a:tcPr>
+                </a:tc>
+                <a:tc>
+                  <a:txBody>
+                    <a:bodyPr/>
+                    <a:lstStyle/>
+                    <a:p>
+                      <a:pPr indent="0" marL="0">
+                        <a:buNone/>
+                      </a:pPr>
+                      <a:r>
+                        <a:rPr lang="en-US" sz="1100" dirty="0">
+                          <a:solidFill>
+                            <a:srgbClr val="00338D"/>
+                          </a:solidFill>
+                        </a:rPr>
+                        <a:t>Rôle User nommé, avec son compte de test</a:t>
+                      </a:r>
+                      <a:endParaRPr lang="en-US" sz="1100" dirty="0"/>
+                    </a:p>
+                  </a:txBody>
+                  <a:tcPr marL="73152" marR="73152" marT="27432" marB="27432" anchor="ctr">
+                    <a:lnL w="6350" cap="flat" cmpd="sng" algn="ctr">
+                      <a:solidFill>
+                        <a:srgbClr val="B8D4F0"/>
+                      </a:solidFill>
+                      <a:prstDash val="solid"/>
+                      <a:round/>
+                      <a:headEnd type="none" w="med" len="med"/>
+                      <a:tailEnd type="none" w="med" len="med"/>
+                    </a:lnL>
+                    <a:lnR w="6350" cap="flat" cmpd="sng" algn="ctr">
+                      <a:solidFill>
+                        <a:srgbClr val="B8D4F0"/>
+                      </a:solidFill>
+                      <a:prstDash val="solid"/>
+                      <a:round/>
+                      <a:headEnd type="none" w="med" len="med"/>
+                      <a:tailEnd type="none" w="med" len="med"/>
+                    </a:lnR>
+                    <a:lnT w="6350" cap="flat" cmpd="sng" algn="ctr">
+                      <a:solidFill>
+                        <a:srgbClr val="B8D4F0"/>
+                      </a:solidFill>
+                      <a:prstDash val="solid"/>
+                      <a:round/>
+                      <a:headEnd type="none" w="med" len="med"/>
+                      <a:tailEnd type="none" w="med" len="med"/>
+                    </a:lnT>
+                    <a:lnB w="6350" cap="flat" cmpd="sng" algn="ctr">
+                      <a:solidFill>
+                        <a:srgbClr val="B8D4F0"/>
+                      </a:solidFill>
+                      <a:prstDash val="solid"/>
+                      <a:round/>
+                      <a:headEnd type="none" w="med" len="med"/>
+                      <a:tailEnd type="none" w="med" len="med"/>
+                    </a:lnB>
+                    <a:solidFill>
+                      <a:srgbClr val="DCEFE2"/>
+                    </a:solidFill>
+                  </a:tcPr>
+                </a:tc>
+              </a:tr>
+              <a:tr h="429768">
+                <a:tc>
+                  <a:txBody>
+                    <a:bodyPr/>
+                    <a:lstStyle/>
+                    <a:p>
+                      <a:pPr indent="0" marL="0">
+                        <a:buNone/>
+                      </a:pPr>
+                      <a:r>
+                        <a:rPr lang="en-US" sz="1100" b="1" dirty="0">
+                          <a:solidFill>
+                            <a:srgbClr val="1A1A2E"/>
+                          </a:solidFill>
+                        </a:rPr>
+                        <a:t>Règle de validation : statut de l'entité</a:t>
+                      </a:r>
+                      <a:endParaRPr lang="en-US" sz="1100" dirty="0"/>
+                    </a:p>
+                  </a:txBody>
+                  <a:tcPr marL="73152" marR="73152" marT="27432" marB="27432" anchor="ctr">
+                    <a:lnL w="6350" cap="flat" cmpd="sng" algn="ctr">
+                      <a:solidFill>
+                        <a:srgbClr val="B8D4F0"/>
+                      </a:solidFill>
+                      <a:prstDash val="solid"/>
+                      <a:round/>
+                      <a:headEnd type="none" w="med" len="med"/>
+                      <a:tailEnd type="none" w="med" len="med"/>
+                    </a:lnL>
+                    <a:lnR w="6350" cap="flat" cmpd="sng" algn="ctr">
+                      <a:solidFill>
+                        <a:srgbClr val="B8D4F0"/>
+                      </a:solidFill>
+                      <a:prstDash val="solid"/>
+                      <a:round/>
+                      <a:headEnd type="none" w="med" len="med"/>
+                      <a:tailEnd type="none" w="med" len="med"/>
+                    </a:lnR>
+                    <a:lnT w="6350" cap="flat" cmpd="sng" algn="ctr">
+                      <a:solidFill>
+                        <a:srgbClr val="B8D4F0"/>
+                      </a:solidFill>
+                      <a:prstDash val="solid"/>
+                      <a:round/>
+                      <a:headEnd type="none" w="med" len="med"/>
+                      <a:tailEnd type="none" w="med" len="med"/>
+                    </a:lnT>
+                    <a:lnB w="6350" cap="flat" cmpd="sng" algn="ctr">
+                      <a:solidFill>
+                        <a:srgbClr val="B8D4F0"/>
+                      </a:solidFill>
+                      <a:prstDash val="solid"/>
+                      <a:round/>
+                      <a:headEnd type="none" w="med" len="med"/>
+                      <a:tailEnd type="none" w="med" len="med"/>
+                    </a:lnB>
+                    <a:solidFill>
+                      <a:srgbClr val="FFFFFF"/>
+                    </a:solidFill>
+                  </a:tcPr>
+                </a:tc>
+                <a:tc>
+                  <a:txBody>
+                    <a:bodyPr/>
+                    <a:lstStyle/>
+                    <a:p>
+                      <a:pPr indent="0" marL="0">
+                        <a:buNone/>
+                      </a:pPr>
+                      <a:r>
+                        <a:rPr lang="en-US" sz="1100" dirty="0">
+                          <a:solidFill>
+                            <a:srgbClr val="1A1A2E"/>
+                          </a:solidFill>
+                        </a:rPr>
+                        <a:t>1 cas sur 5 : entité sans demande</a:t>
+                      </a:r>
+                      <a:endParaRPr lang="en-US" sz="1100" dirty="0"/>
+                    </a:p>
+                  </a:txBody>
+                  <a:tcPr marL="73152" marR="73152" marT="27432" marB="27432" anchor="ctr">
+                    <a:lnL w="6350" cap="flat" cmpd="sng" algn="ctr">
+                      <a:solidFill>
+                        <a:srgbClr val="B8D4F0"/>
+                      </a:solidFill>
+                      <a:prstDash val="solid"/>
+                      <a:round/>
+                      <a:headEnd type="none" w="med" len="med"/>
+                      <a:tailEnd type="none" w="med" len="med"/>
+                    </a:lnL>
+                    <a:lnR w="6350" cap="flat" cmpd="sng" algn="ctr">
+                      <a:solidFill>
+                        <a:srgbClr val="B8D4F0"/>
+                      </a:solidFill>
+                      <a:prstDash val="solid"/>
+                      <a:round/>
+                      <a:headEnd type="none" w="med" len="med"/>
+                      <a:tailEnd type="none" w="med" len="med"/>
+                    </a:lnR>
+                    <a:lnT w="6350" cap="flat" cmpd="sng" algn="ctr">
+                      <a:solidFill>
+                        <a:srgbClr val="B8D4F0"/>
+                      </a:solidFill>
+                      <a:prstDash val="solid"/>
+                      <a:round/>
+                      <a:headEnd type="none" w="med" len="med"/>
+                      <a:tailEnd type="none" w="med" len="med"/>
+                    </a:lnT>
+                    <a:lnB w="6350" cap="flat" cmpd="sng" algn="ctr">
+                      <a:solidFill>
+                        <a:srgbClr val="B8D4F0"/>
+                      </a:solidFill>
+                      <a:prstDash val="solid"/>
+                      <a:round/>
+                      <a:headEnd type="none" w="med" len="med"/>
+                      <a:tailEnd type="none" w="med" len="med"/>
+                    </a:lnB>
+                    <a:solidFill>
+                      <a:srgbClr val="FFFFFF"/>
+                    </a:solidFill>
+                  </a:tcPr>
+                </a:tc>
+                <a:tc>
+                  <a:txBody>
+                    <a:bodyPr/>
+                    <a:lstStyle/>
+                    <a:p>
+                      <a:pPr indent="0" marL="0">
+                        <a:buNone/>
+                      </a:pPr>
+                      <a:r>
+                        <a:rPr lang="en-US" sz="1100" dirty="0">
+                          <a:solidFill>
+                            <a:srgbClr val="00338D"/>
+                          </a:solidFill>
+                        </a:rPr>
+                        <a:t>5 cas : aucune demande et Validé acceptés ; En cours, Retard, Révision refusés</a:t>
+                      </a:r>
+                      <a:endParaRPr lang="en-US" sz="1100" dirty="0"/>
+                    </a:p>
+                  </a:txBody>
+                  <a:tcPr marL="73152" marR="73152" marT="27432" marB="27432" anchor="ctr">
+                    <a:lnL w="6350" cap="flat" cmpd="sng" algn="ctr">
+                      <a:solidFill>
+                        <a:srgbClr val="B8D4F0"/>
+                      </a:solidFill>
+                      <a:prstDash val="solid"/>
+                      <a:round/>
+                      <a:headEnd type="none" w="med" len="med"/>
+                      <a:tailEnd type="none" w="med" len="med"/>
+                    </a:lnL>
+                    <a:lnR w="6350" cap="flat" cmpd="sng" algn="ctr">
+                      <a:solidFill>
+                        <a:srgbClr val="B8D4F0"/>
+                      </a:solidFill>
+                      <a:prstDash val="solid"/>
+                      <a:round/>
+                      <a:headEnd type="none" w="med" len="med"/>
+                      <a:tailEnd type="none" w="med" len="med"/>
+                    </a:lnR>
+                    <a:lnT w="6350" cap="flat" cmpd="sng" algn="ctr">
+                      <a:solidFill>
+                        <a:srgbClr val="B8D4F0"/>
+                      </a:solidFill>
+                      <a:prstDash val="solid"/>
+                      <a:round/>
+                      <a:headEnd type="none" w="med" len="med"/>
+                      <a:tailEnd type="none" w="med" len="med"/>
+                    </a:lnT>
+                    <a:lnB w="6350" cap="flat" cmpd="sng" algn="ctr">
+                      <a:solidFill>
+                        <a:srgbClr val="B8D4F0"/>
+                      </a:solidFill>
+                      <a:prstDash val="solid"/>
+                      <a:round/>
+                      <a:headEnd type="none" w="med" len="med"/>
+                      <a:tailEnd type="none" w="med" len="med"/>
+                    </a:lnB>
+                    <a:solidFill>
+                      <a:srgbClr val="FFFFFF"/>
+                    </a:solidFill>
+                  </a:tcPr>
+                </a:tc>
+              </a:tr>
+              <a:tr h="429768">
+                <a:tc>
+                  <a:txBody>
+                    <a:bodyPr/>
+                    <a:lstStyle/>
+                    <a:p>
+                      <a:pPr indent="0" marL="0">
+                        <a:buNone/>
+                      </a:pPr>
+                      <a:r>
+                        <a:rPr lang="en-US" sz="1100" b="1" dirty="0">
+                          <a:solidFill>
+                            <a:srgbClr val="1A1A2E"/>
+                          </a:solidFill>
+                        </a:rPr>
+                        <a:t>Champs obligatoires</a:t>
+                      </a:r>
+                      <a:endParaRPr lang="en-US" sz="1100" dirty="0"/>
+                    </a:p>
+                  </a:txBody>
+                  <a:tcPr marL="73152" marR="73152" marT="27432" marB="27432" anchor="ctr">
+                    <a:lnL w="6350" cap="flat" cmpd="sng" algn="ctr">
+                      <a:solidFill>
+                        <a:srgbClr val="B8D4F0"/>
+                      </a:solidFill>
+                      <a:prstDash val="solid"/>
+                      <a:round/>
+                      <a:headEnd type="none" w="med" len="med"/>
+                      <a:tailEnd type="none" w="med" len="med"/>
+                    </a:lnL>
+                    <a:lnR w="6350" cap="flat" cmpd="sng" algn="ctr">
+                      <a:solidFill>
+                        <a:srgbClr val="B8D4F0"/>
+                      </a:solidFill>
+                      <a:prstDash val="solid"/>
+                      <a:round/>
+                      <a:headEnd type="none" w="med" len="med"/>
+                      <a:tailEnd type="none" w="med" len="med"/>
+                    </a:lnR>
+                    <a:lnT w="6350" cap="flat" cmpd="sng" algn="ctr">
+                      <a:solidFill>
+                        <a:srgbClr val="B8D4F0"/>
+                      </a:solidFill>
+                      <a:prstDash val="solid"/>
+                      <a:round/>
+                      <a:headEnd type="none" w="med" len="med"/>
+                      <a:tailEnd type="none" w="med" len="med"/>
+                    </a:lnT>
+                    <a:lnB w="6350" cap="flat" cmpd="sng" algn="ctr">
+                      <a:solidFill>
+                        <a:srgbClr val="B8D4F0"/>
+                      </a:solidFill>
+                      <a:prstDash val="solid"/>
+                      <a:round/>
+                      <a:headEnd type="none" w="med" len="med"/>
+                      <a:tailEnd type="none" w="med" len="med"/>
+                    </a:lnB>
+                    <a:solidFill>
+                      <a:srgbClr val="EEF3FA"/>
+                    </a:solidFill>
+                  </a:tcPr>
+                </a:tc>
+                <a:tc>
+                  <a:txBody>
+                    <a:bodyPr/>
+                    <a:lstStyle/>
+                    <a:p>
+                      <a:pPr indent="0" marL="0">
+                        <a:buNone/>
+                      </a:pPr>
+                      <a:r>
+                        <a:rPr lang="en-US" sz="1100" dirty="0">
+                          <a:solidFill>
+                            <a:srgbClr val="1A1A2E"/>
+                          </a:solidFill>
+                        </a:rPr>
+                        <a:t>1 cas générique</a:t>
+                      </a:r>
+                      <a:endParaRPr lang="en-US" sz="1100" dirty="0"/>
+                    </a:p>
+                  </a:txBody>
+                  <a:tcPr marL="73152" marR="73152" marT="27432" marB="27432" anchor="ctr">
+                    <a:lnL w="6350" cap="flat" cmpd="sng" algn="ctr">
+                      <a:solidFill>
+                        <a:srgbClr val="B8D4F0"/>
+                      </a:solidFill>
+                      <a:prstDash val="solid"/>
+                      <a:round/>
+                      <a:headEnd type="none" w="med" len="med"/>
+                      <a:tailEnd type="none" w="med" len="med"/>
+                    </a:lnL>
+                    <a:lnR w="6350" cap="flat" cmpd="sng" algn="ctr">
+                      <a:solidFill>
+                        <a:srgbClr val="B8D4F0"/>
+                      </a:solidFill>
+                      <a:prstDash val="solid"/>
+                      <a:round/>
+                      <a:headEnd type="none" w="med" len="med"/>
+                      <a:tailEnd type="none" w="med" len="med"/>
+                    </a:lnR>
+                    <a:lnT w="6350" cap="flat" cmpd="sng" algn="ctr">
+                      <a:solidFill>
+                        <a:srgbClr val="B8D4F0"/>
+                      </a:solidFill>
+                      <a:prstDash val="solid"/>
+                      <a:round/>
+                      <a:headEnd type="none" w="med" len="med"/>
+                      <a:tailEnd type="none" w="med" len="med"/>
+                    </a:lnT>
+                    <a:lnB w="6350" cap="flat" cmpd="sng" algn="ctr">
+                      <a:solidFill>
+                        <a:srgbClr val="B8D4F0"/>
+                      </a:solidFill>
+                      <a:prstDash val="solid"/>
+                      <a:round/>
+                      <a:headEnd type="none" w="med" len="med"/>
+                      <a:tailEnd type="none" w="med" len="med"/>
+                    </a:lnB>
+                    <a:solidFill>
+                      <a:srgbClr val="EEF3FA"/>
+                    </a:solidFill>
+                  </a:tcPr>
+                </a:tc>
+                <a:tc>
+                  <a:txBody>
+                    <a:bodyPr/>
+                    <a:lstStyle/>
+                    <a:p>
+                      <a:pPr indent="0" marL="0">
+                        <a:buNone/>
+                      </a:pPr>
+                      <a:r>
+                        <a:rPr lang="en-US" sz="1100" dirty="0">
+                          <a:solidFill>
+                            <a:srgbClr val="00338D"/>
+                          </a:solidFill>
+                        </a:rPr>
+                        <a:t>1 cas par champ, avec « aucune demande créée »</a:t>
+                      </a:r>
+                      <a:endParaRPr lang="en-US" sz="1100" dirty="0"/>
+                    </a:p>
+                  </a:txBody>
+                  <a:tcPr marL="73152" marR="73152" marT="27432" marB="27432" anchor="ctr">
+                    <a:lnL w="6350" cap="flat" cmpd="sng" algn="ctr">
+                      <a:solidFill>
+                        <a:srgbClr val="B8D4F0"/>
+                      </a:solidFill>
+                      <a:prstDash val="solid"/>
+                      <a:round/>
+                      <a:headEnd type="none" w="med" len="med"/>
+                      <a:tailEnd type="none" w="med" len="med"/>
+                    </a:lnL>
+                    <a:lnR w="6350" cap="flat" cmpd="sng" algn="ctr">
+                      <a:solidFill>
+                        <a:srgbClr val="B8D4F0"/>
+                      </a:solidFill>
+                      <a:prstDash val="solid"/>
+                      <a:round/>
+                      <a:headEnd type="none" w="med" len="med"/>
+                      <a:tailEnd type="none" w="med" len="med"/>
+                    </a:lnR>
+                    <a:lnT w="6350" cap="flat" cmpd="sng" algn="ctr">
+                      <a:solidFill>
+                        <a:srgbClr val="B8D4F0"/>
+                      </a:solidFill>
+                      <a:prstDash val="solid"/>
+                      <a:round/>
+                      <a:headEnd type="none" w="med" len="med"/>
+                      <a:tailEnd type="none" w="med" len="med"/>
+                    </a:lnT>
+                    <a:lnB w="6350" cap="flat" cmpd="sng" algn="ctr">
+                      <a:solidFill>
+                        <a:srgbClr val="B8D4F0"/>
+                      </a:solidFill>
+                      <a:prstDash val="solid"/>
+                      <a:round/>
+                      <a:headEnd type="none" w="med" len="med"/>
+                      <a:tailEnd type="none" w="med" len="med"/>
+                    </a:lnB>
+                    <a:solidFill>
+                      <a:srgbClr val="DCEFE2"/>
+                    </a:solidFill>
+                  </a:tcPr>
+                </a:tc>
+              </a:tr>
+              <a:tr h="429768">
+                <a:tc>
+                  <a:txBody>
+                    <a:bodyPr/>
+                    <a:lstStyle/>
+                    <a:p>
+                      <a:pPr indent="0" marL="0">
+                        <a:buNone/>
+                      </a:pPr>
+                      <a:r>
+                        <a:rPr lang="en-US" sz="1100" b="1" dirty="0">
+                          <a:solidFill>
+                            <a:srgbClr val="1A1A2E"/>
+                          </a:solidFill>
+                        </a:rPr>
+                        <a:t>Bornes du millésime</a:t>
+                      </a:r>
+                      <a:endParaRPr lang="en-US" sz="1100" dirty="0"/>
+                    </a:p>
+                  </a:txBody>
+                  <a:tcPr marL="73152" marR="73152" marT="27432" marB="27432" anchor="ctr">
+                    <a:lnL w="6350" cap="flat" cmpd="sng" algn="ctr">
+                      <a:solidFill>
+                        <a:srgbClr val="B8D4F0"/>
+                      </a:solidFill>
+                      <a:prstDash val="solid"/>
+                      <a:round/>
+                      <a:headEnd type="none" w="med" len="med"/>
+                      <a:tailEnd type="none" w="med" len="med"/>
+                    </a:lnL>
+                    <a:lnR w="6350" cap="flat" cmpd="sng" algn="ctr">
+                      <a:solidFill>
+                        <a:srgbClr val="B8D4F0"/>
+                      </a:solidFill>
+                      <a:prstDash val="solid"/>
+                      <a:round/>
+                      <a:headEnd type="none" w="med" len="med"/>
+                      <a:tailEnd type="none" w="med" len="med"/>
+                    </a:lnR>
+                    <a:lnT w="6350" cap="flat" cmpd="sng" algn="ctr">
+                      <a:solidFill>
+                        <a:srgbClr val="B8D4F0"/>
+                      </a:solidFill>
+                      <a:prstDash val="solid"/>
+                      <a:round/>
+                      <a:headEnd type="none" w="med" len="med"/>
+                      <a:tailEnd type="none" w="med" len="med"/>
+                    </a:lnT>
+                    <a:lnB w="6350" cap="flat" cmpd="sng" algn="ctr">
+                      <a:solidFill>
+                        <a:srgbClr val="B8D4F0"/>
+                      </a:solidFill>
+                      <a:prstDash val="solid"/>
+                      <a:round/>
+                      <a:headEnd type="none" w="med" len="med"/>
+                      <a:tailEnd type="none" w="med" len="med"/>
+                    </a:lnB>
+                    <a:solidFill>
+                      <a:srgbClr val="FFFFFF"/>
+                    </a:solidFill>
+                  </a:tcPr>
+                </a:tc>
+                <a:tc>
+                  <a:txBody>
+                    <a:bodyPr/>
+                    <a:lstStyle/>
+                    <a:p>
+                      <a:pPr indent="0" marL="0">
+                        <a:buNone/>
+                      </a:pPr>
+                      <a:r>
+                        <a:rPr lang="en-US" sz="1100" dirty="0">
+                          <a:solidFill>
+                            <a:srgbClr val="1A1A2E"/>
+                          </a:solidFill>
+                        </a:rPr>
+                        <a:t>1 cas « de -20 à +10 »</a:t>
+                      </a:r>
+                      <a:endParaRPr lang="en-US" sz="1100" dirty="0"/>
+                    </a:p>
+                  </a:txBody>
+                  <a:tcPr marL="73152" marR="73152" marT="27432" marB="27432" anchor="ctr">
+                    <a:lnL w="6350" cap="flat" cmpd="sng" algn="ctr">
+                      <a:solidFill>
+                        <a:srgbClr val="B8D4F0"/>
+                      </a:solidFill>
+                      <a:prstDash val="solid"/>
+                      <a:round/>
+                      <a:headEnd type="none" w="med" len="med"/>
+                      <a:tailEnd type="none" w="med" len="med"/>
+                    </a:lnL>
+                    <a:lnR w="6350" cap="flat" cmpd="sng" algn="ctr">
+                      <a:solidFill>
+                        <a:srgbClr val="B8D4F0"/>
+                      </a:solidFill>
+                      <a:prstDash val="solid"/>
+                      <a:round/>
+                      <a:headEnd type="none" w="med" len="med"/>
+                      <a:tailEnd type="none" w="med" len="med"/>
+                    </a:lnR>
+                    <a:lnT w="6350" cap="flat" cmpd="sng" algn="ctr">
+                      <a:solidFill>
+                        <a:srgbClr val="B8D4F0"/>
+                      </a:solidFill>
+                      <a:prstDash val="solid"/>
+                      <a:round/>
+                      <a:headEnd type="none" w="med" len="med"/>
+                      <a:tailEnd type="none" w="med" len="med"/>
+                    </a:lnT>
+                    <a:lnB w="6350" cap="flat" cmpd="sng" algn="ctr">
+                      <a:solidFill>
+                        <a:srgbClr val="B8D4F0"/>
+                      </a:solidFill>
+                      <a:prstDash val="solid"/>
+                      <a:round/>
+                      <a:headEnd type="none" w="med" len="med"/>
+                      <a:tailEnd type="none" w="med" len="med"/>
+                    </a:lnB>
+                    <a:solidFill>
+                      <a:srgbClr val="FFFFFF"/>
+                    </a:solidFill>
+                  </a:tcPr>
+                </a:tc>
+                <a:tc>
+                  <a:txBody>
+                    <a:bodyPr/>
+                    <a:lstStyle/>
+                    <a:p>
+                      <a:pPr indent="0" marL="0">
+                        <a:buNone/>
+                      </a:pPr>
+                      <a:r>
+                        <a:rPr lang="en-US" sz="1100" dirty="0">
+                          <a:solidFill>
+                            <a:srgbClr val="00338D"/>
+                          </a:solidFill>
+                        </a:rPr>
+                        <a:t>4 cas : les bornes et les valeurs juste au-delà</a:t>
+                      </a:r>
+                      <a:endParaRPr lang="en-US" sz="1100" dirty="0"/>
+                    </a:p>
+                  </a:txBody>
+                  <a:tcPr marL="73152" marR="73152" marT="27432" marB="27432" anchor="ctr">
+                    <a:lnL w="6350" cap="flat" cmpd="sng" algn="ctr">
+                      <a:solidFill>
+                        <a:srgbClr val="B8D4F0"/>
+                      </a:solidFill>
+                      <a:prstDash val="solid"/>
+                      <a:round/>
+                      <a:headEnd type="none" w="med" len="med"/>
+                      <a:tailEnd type="none" w="med" len="med"/>
+                    </a:lnL>
+                    <a:lnR w="6350" cap="flat" cmpd="sng" algn="ctr">
+                      <a:solidFill>
+                        <a:srgbClr val="B8D4F0"/>
+                      </a:solidFill>
+                      <a:prstDash val="solid"/>
+                      <a:round/>
+                      <a:headEnd type="none" w="med" len="med"/>
+                      <a:tailEnd type="none" w="med" len="med"/>
+                    </a:lnR>
+                    <a:lnT w="6350" cap="flat" cmpd="sng" algn="ctr">
+                      <a:solidFill>
+                        <a:srgbClr val="B8D4F0"/>
+                      </a:solidFill>
+                      <a:prstDash val="solid"/>
+                      <a:round/>
+                      <a:headEnd type="none" w="med" len="med"/>
+                      <a:tailEnd type="none" w="med" len="med"/>
+                    </a:lnT>
+                    <a:lnB w="6350" cap="flat" cmpd="sng" algn="ctr">
+                      <a:solidFill>
+                        <a:srgbClr val="B8D4F0"/>
+                      </a:solidFill>
+                      <a:prstDash val="solid"/>
+                      <a:round/>
+                      <a:headEnd type="none" w="med" len="med"/>
+                      <a:tailEnd type="none" w="med" len="med"/>
+                    </a:lnB>
+                    <a:solidFill>
+                      <a:srgbClr val="FFFFFF"/>
+                    </a:solidFill>
+                  </a:tcPr>
+                </a:tc>
+              </a:tr>
+              <a:tr h="429768">
+                <a:tc>
+                  <a:txBody>
+                    <a:bodyPr/>
+                    <a:lstStyle/>
+                    <a:p>
+                      <a:pPr indent="0" marL="0">
+                        <a:buNone/>
+                      </a:pPr>
+                      <a:r>
+                        <a:rPr lang="en-US" sz="1100" b="1" dirty="0">
+                          <a:solidFill>
+                            <a:srgbClr val="1A1A2E"/>
+                          </a:solidFill>
+                        </a:rPr>
+                        <a:t>Doublons</a:t>
+                      </a:r>
+                      <a:endParaRPr lang="en-US" sz="1100" dirty="0"/>
+                    </a:p>
+                  </a:txBody>
+                  <a:tcPr marL="73152" marR="73152" marT="27432" marB="27432" anchor="ctr">
+                    <a:lnL w="6350" cap="flat" cmpd="sng" algn="ctr">
+                      <a:solidFill>
+                        <a:srgbClr val="B8D4F0"/>
+                      </a:solidFill>
+                      <a:prstDash val="solid"/>
+                      <a:round/>
+                      <a:headEnd type="none" w="med" len="med"/>
+                      <a:tailEnd type="none" w="med" len="med"/>
+                    </a:lnL>
+                    <a:lnR w="6350" cap="flat" cmpd="sng" algn="ctr">
+                      <a:solidFill>
+                        <a:srgbClr val="B8D4F0"/>
+                      </a:solidFill>
+                      <a:prstDash val="solid"/>
+                      <a:round/>
+                      <a:headEnd type="none" w="med" len="med"/>
+                      <a:tailEnd type="none" w="med" len="med"/>
+                    </a:lnR>
+                    <a:lnT w="6350" cap="flat" cmpd="sng" algn="ctr">
+                      <a:solidFill>
+                        <a:srgbClr val="B8D4F0"/>
+                      </a:solidFill>
+                      <a:prstDash val="solid"/>
+                      <a:round/>
+                      <a:headEnd type="none" w="med" len="med"/>
+                      <a:tailEnd type="none" w="med" len="med"/>
+                    </a:lnT>
+                    <a:lnB w="6350" cap="flat" cmpd="sng" algn="ctr">
+                      <a:solidFill>
+                        <a:srgbClr val="B8D4F0"/>
+                      </a:solidFill>
+                      <a:prstDash val="solid"/>
+                      <a:round/>
+                      <a:headEnd type="none" w="med" len="med"/>
+                      <a:tailEnd type="none" w="med" len="med"/>
+                    </a:lnB>
+                    <a:solidFill>
+                      <a:srgbClr val="EEF3FA"/>
+                    </a:solidFill>
+                  </a:tcPr>
+                </a:tc>
+                <a:tc>
+                  <a:txBody>
+                    <a:bodyPr/>
+                    <a:lstStyle/>
+                    <a:p>
+                      <a:pPr indent="0" marL="0">
+                        <a:buNone/>
+                      </a:pPr>
+                      <a:r>
+                        <a:rPr lang="en-US" sz="1100" dirty="0">
+                          <a:solidFill>
+                            <a:srgbClr val="1A1A2E"/>
+                          </a:solidFill>
+                        </a:rPr>
+                        <a:t>Reprise Oui et Reprise Non : même résultat</a:t>
+                      </a:r>
+                      <a:endParaRPr lang="en-US" sz="1100" dirty="0"/>
+                    </a:p>
+                  </a:txBody>
+                  <a:tcPr marL="73152" marR="73152" marT="27432" marB="27432" anchor="ctr">
+                    <a:lnL w="6350" cap="flat" cmpd="sng" algn="ctr">
+                      <a:solidFill>
+                        <a:srgbClr val="B8D4F0"/>
+                      </a:solidFill>
+                      <a:prstDash val="solid"/>
+                      <a:round/>
+                      <a:headEnd type="none" w="med" len="med"/>
+                      <a:tailEnd type="none" w="med" len="med"/>
+                    </a:lnL>
+                    <a:lnR w="6350" cap="flat" cmpd="sng" algn="ctr">
+                      <a:solidFill>
+                        <a:srgbClr val="B8D4F0"/>
+                      </a:solidFill>
+                      <a:prstDash val="solid"/>
+                      <a:round/>
+                      <a:headEnd type="none" w="med" len="med"/>
+                      <a:tailEnd type="none" w="med" len="med"/>
+                    </a:lnR>
+                    <a:lnT w="6350" cap="flat" cmpd="sng" algn="ctr">
+                      <a:solidFill>
+                        <a:srgbClr val="B8D4F0"/>
+                      </a:solidFill>
+                      <a:prstDash val="solid"/>
+                      <a:round/>
+                      <a:headEnd type="none" w="med" len="med"/>
+                      <a:tailEnd type="none" w="med" len="med"/>
+                    </a:lnT>
+                    <a:lnB w="6350" cap="flat" cmpd="sng" algn="ctr">
+                      <a:solidFill>
+                        <a:srgbClr val="B8D4F0"/>
+                      </a:solidFill>
+                      <a:prstDash val="solid"/>
+                      <a:round/>
+                      <a:headEnd type="none" w="med" len="med"/>
+                      <a:tailEnd type="none" w="med" len="med"/>
+                    </a:lnB>
+                    <a:solidFill>
+                      <a:srgbClr val="EEF3FA"/>
+                    </a:solidFill>
+                  </a:tcPr>
+                </a:tc>
+                <a:tc>
+                  <a:txBody>
+                    <a:bodyPr/>
+                    <a:lstStyle/>
+                    <a:p>
+                      <a:pPr indent="0" marL="0">
+                        <a:buNone/>
+                      </a:pPr>
+                      <a:r>
+                        <a:rPr lang="en-US" sz="1100" dirty="0">
+                          <a:solidFill>
+                            <a:srgbClr val="00338D"/>
+                          </a:solidFill>
+                        </a:rPr>
+                        <a:t>Aucun</a:t>
+                      </a:r>
+                      <a:endParaRPr lang="en-US" sz="1100" dirty="0"/>
+                    </a:p>
+                  </a:txBody>
+                  <a:tcPr marL="73152" marR="73152" marT="27432" marB="27432" anchor="ctr">
+                    <a:lnL w="6350" cap="flat" cmpd="sng" algn="ctr">
+                      <a:solidFill>
+                        <a:srgbClr val="B8D4F0"/>
+                      </a:solidFill>
+                      <a:prstDash val="solid"/>
+                      <a:round/>
+                      <a:headEnd type="none" w="med" len="med"/>
+                      <a:tailEnd type="none" w="med" len="med"/>
+                    </a:lnL>
+                    <a:lnR w="6350" cap="flat" cmpd="sng" algn="ctr">
+                      <a:solidFill>
+                        <a:srgbClr val="B8D4F0"/>
+                      </a:solidFill>
+                      <a:prstDash val="solid"/>
+                      <a:round/>
+                      <a:headEnd type="none" w="med" len="med"/>
+                      <a:tailEnd type="none" w="med" len="med"/>
+                    </a:lnR>
+                    <a:lnT w="6350" cap="flat" cmpd="sng" algn="ctr">
+                      <a:solidFill>
+                        <a:srgbClr val="B8D4F0"/>
+                      </a:solidFill>
+                      <a:prstDash val="solid"/>
+                      <a:round/>
+                      <a:headEnd type="none" w="med" len="med"/>
+                      <a:tailEnd type="none" w="med" len="med"/>
+                    </a:lnT>
+                    <a:lnB w="6350" cap="flat" cmpd="sng" algn="ctr">
+                      <a:solidFill>
+                        <a:srgbClr val="B8D4F0"/>
+                      </a:solidFill>
+                      <a:prstDash val="solid"/>
+                      <a:round/>
+                      <a:headEnd type="none" w="med" len="med"/>
+                      <a:tailEnd type="none" w="med" len="med"/>
+                    </a:lnB>
+                    <a:solidFill>
+                      <a:srgbClr val="DCEFE2"/>
+                    </a:solidFill>
+                  </a:tcPr>
+                </a:tc>
+              </a:tr>
+              <a:tr h="429768">
+                <a:tc>
+                  <a:txBody>
+                    <a:bodyPr/>
+                    <a:lstStyle/>
+                    <a:p>
+                      <a:pPr indent="0" marL="0">
+                        <a:buNone/>
+                      </a:pPr>
+                      <a:r>
+                        <a:rPr lang="en-US" sz="1100" b="1" dirty="0">
+                          <a:solidFill>
+                            <a:srgbClr val="1A1A2E"/>
+                          </a:solidFill>
+                        </a:rPr>
+                        <a:t>Ce que l'US ne dit pas</a:t>
+                      </a:r>
+                      <a:endParaRPr lang="en-US" sz="1100" dirty="0"/>
+                    </a:p>
+                  </a:txBody>
+                  <a:tcPr marL="73152" marR="73152" marT="27432" marB="27432" anchor="ctr">
+                    <a:lnL w="6350" cap="flat" cmpd="sng" algn="ctr">
+                      <a:solidFill>
+                        <a:srgbClr val="B8D4F0"/>
+                      </a:solidFill>
+                      <a:prstDash val="solid"/>
+                      <a:round/>
+                      <a:headEnd type="none" w="med" len="med"/>
+                      <a:tailEnd type="none" w="med" len="med"/>
+                    </a:lnL>
+                    <a:lnR w="6350" cap="flat" cmpd="sng" algn="ctr">
+                      <a:solidFill>
+                        <a:srgbClr val="B8D4F0"/>
+                      </a:solidFill>
+                      <a:prstDash val="solid"/>
+                      <a:round/>
+                      <a:headEnd type="none" w="med" len="med"/>
+                      <a:tailEnd type="none" w="med" len="med"/>
+                    </a:lnR>
+                    <a:lnT w="6350" cap="flat" cmpd="sng" algn="ctr">
+                      <a:solidFill>
+                        <a:srgbClr val="B8D4F0"/>
+                      </a:solidFill>
+                      <a:prstDash val="solid"/>
+                      <a:round/>
+                      <a:headEnd type="none" w="med" len="med"/>
+                      <a:tailEnd type="none" w="med" len="med"/>
+                    </a:lnT>
+                    <a:lnB w="6350" cap="flat" cmpd="sng" algn="ctr">
+                      <a:solidFill>
+                        <a:srgbClr val="B8D4F0"/>
+                      </a:solidFill>
+                      <a:prstDash val="solid"/>
+                      <a:round/>
+                      <a:headEnd type="none" w="med" len="med"/>
+                      <a:tailEnd type="none" w="med" len="med"/>
+                    </a:lnB>
+                    <a:solidFill>
+                      <a:srgbClr val="FFFFFF"/>
+                    </a:solidFill>
+                  </a:tcPr>
+                </a:tc>
+                <a:tc>
+                  <a:txBody>
+                    <a:bodyPr/>
+                    <a:lstStyle/>
+                    <a:p>
+                      <a:pPr indent="0" marL="0">
+                        <a:buNone/>
+                      </a:pPr>
+                      <a:r>
+                        <a:rPr lang="en-US" sz="1100" dirty="0">
+                          <a:solidFill>
+                            <a:srgbClr val="1A1A2E"/>
+                          </a:solidFill>
+                        </a:rPr>
+                        <a:t>Aucune question ; la contradiction sur l'entité inconnue n'est pas vue</a:t>
+                      </a:r>
+                      <a:endParaRPr lang="en-US" sz="1100" dirty="0"/>
+                    </a:p>
+                  </a:txBody>
+                  <a:tcPr marL="73152" marR="73152" marT="27432" marB="27432" anchor="ctr">
+                    <a:lnL w="6350" cap="flat" cmpd="sng" algn="ctr">
+                      <a:solidFill>
+                        <a:srgbClr val="B8D4F0"/>
+                      </a:solidFill>
+                      <a:prstDash val="solid"/>
+                      <a:round/>
+                      <a:headEnd type="none" w="med" len="med"/>
+                      <a:tailEnd type="none" w="med" len="med"/>
+                    </a:lnL>
+                    <a:lnR w="6350" cap="flat" cmpd="sng" algn="ctr">
+                      <a:solidFill>
+                        <a:srgbClr val="B8D4F0"/>
+                      </a:solidFill>
+                      <a:prstDash val="solid"/>
+                      <a:round/>
+                      <a:headEnd type="none" w="med" len="med"/>
+                      <a:tailEnd type="none" w="med" len="med"/>
+                    </a:lnR>
+                    <a:lnT w="6350" cap="flat" cmpd="sng" algn="ctr">
+                      <a:solidFill>
+                        <a:srgbClr val="B8D4F0"/>
+                      </a:solidFill>
+                      <a:prstDash val="solid"/>
+                      <a:round/>
+                      <a:headEnd type="none" w="med" len="med"/>
+                      <a:tailEnd type="none" w="med" len="med"/>
+                    </a:lnT>
+                    <a:lnB w="6350" cap="flat" cmpd="sng" algn="ctr">
+                      <a:solidFill>
+                        <a:srgbClr val="B8D4F0"/>
+                      </a:solidFill>
+                      <a:prstDash val="solid"/>
+                      <a:round/>
+                      <a:headEnd type="none" w="med" len="med"/>
+                      <a:tailEnd type="none" w="med" len="med"/>
+                    </a:lnB>
+                    <a:solidFill>
+                      <a:srgbClr val="FFFFFF"/>
+                    </a:solidFill>
+                  </a:tcPr>
+                </a:tc>
+                <a:tc>
+                  <a:txBody>
+                    <a:bodyPr/>
+                    <a:lstStyle/>
+                    <a:p>
+                      <a:pPr indent="0" marL="0">
+                        <a:buNone/>
+                      </a:pPr>
+                      <a:r>
+                        <a:rPr lang="en-US" sz="1100" dirty="0">
+                          <a:solidFill>
+                            <a:srgbClr val="00338D"/>
+                          </a:solidFill>
+                        </a:rPr>
+                        <a:t>9 questions au PO, dont 2 bloquantes (entité inconnue, documents)</a:t>
+                      </a:r>
+                      <a:endParaRPr lang="en-US" sz="1100" dirty="0"/>
+                    </a:p>
+                  </a:txBody>
+                  <a:tcPr marL="73152" marR="73152" marT="27432" marB="27432" anchor="ctr">
+                    <a:lnL w="6350" cap="flat" cmpd="sng" algn="ctr">
+                      <a:solidFill>
+                        <a:srgbClr val="B8D4F0"/>
+                      </a:solidFill>
+                      <a:prstDash val="solid"/>
+                      <a:round/>
+                      <a:headEnd type="none" w="med" len="med"/>
+                      <a:tailEnd type="none" w="med" len="med"/>
+                    </a:lnL>
+                    <a:lnR w="6350" cap="flat" cmpd="sng" algn="ctr">
+                      <a:solidFill>
+                        <a:srgbClr val="B8D4F0"/>
+                      </a:solidFill>
+                      <a:prstDash val="solid"/>
+                      <a:round/>
+                      <a:headEnd type="none" w="med" len="med"/>
+                      <a:tailEnd type="none" w="med" len="med"/>
+                    </a:lnR>
+                    <a:lnT w="6350" cap="flat" cmpd="sng" algn="ctr">
+                      <a:solidFill>
+                        <a:srgbClr val="B8D4F0"/>
+                      </a:solidFill>
+                      <a:prstDash val="solid"/>
+                      <a:round/>
+                      <a:headEnd type="none" w="med" len="med"/>
+                      <a:tailEnd type="none" w="med" len="med"/>
+                    </a:lnT>
+                    <a:lnB w="6350" cap="flat" cmpd="sng" algn="ctr">
+                      <a:solidFill>
+                        <a:srgbClr val="B8D4F0"/>
+                      </a:solidFill>
+                      <a:prstDash val="solid"/>
+                      <a:round/>
+                      <a:headEnd type="none" w="med" len="med"/>
+                      <a:tailEnd type="none" w="med" len="med"/>
+                    </a:lnB>
+                    <a:solidFill>
+                      <a:srgbClr val="FFFFFF"/>
+                    </a:solidFill>
+                  </a:tcPr>
+                </a:tc>
+              </a:tr>
+              <a:tr h="429768">
+                <a:tc>
+                  <a:txBody>
+                    <a:bodyPr/>
+                    <a:lstStyle/>
+                    <a:p>
+                      <a:pPr indent="0" marL="0">
+                        <a:buNone/>
+                      </a:pPr>
+                      <a:r>
+                        <a:rPr lang="en-US" sz="1100" b="1" dirty="0">
+                          <a:solidFill>
+                            <a:srgbClr val="1A1A2E"/>
+                          </a:solidFill>
+                        </a:rPr>
+                        <a:t>Volume</a:t>
+                      </a:r>
+                      <a:endParaRPr lang="en-US" sz="1100" dirty="0"/>
+                    </a:p>
+                  </a:txBody>
+                  <a:tcPr marL="73152" marR="73152" marT="27432" marB="27432" anchor="ctr">
+                    <a:lnL w="6350" cap="flat" cmpd="sng" algn="ctr">
+                      <a:solidFill>
+                        <a:srgbClr val="B8D4F0"/>
+                      </a:solidFill>
+                      <a:prstDash val="solid"/>
+                      <a:round/>
+                      <a:headEnd type="none" w="med" len="med"/>
+                      <a:tailEnd type="none" w="med" len="med"/>
+                    </a:lnL>
+                    <a:lnR w="6350" cap="flat" cmpd="sng" algn="ctr">
+                      <a:solidFill>
+                        <a:srgbClr val="B8D4F0"/>
+                      </a:solidFill>
+                      <a:prstDash val="solid"/>
+                      <a:round/>
+                      <a:headEnd type="none" w="med" len="med"/>
+                      <a:tailEnd type="none" w="med" len="med"/>
+                    </a:lnR>
+                    <a:lnT w="6350" cap="flat" cmpd="sng" algn="ctr">
+                      <a:solidFill>
+                        <a:srgbClr val="B8D4F0"/>
+                      </a:solidFill>
+                      <a:prstDash val="solid"/>
+                      <a:round/>
+                      <a:headEnd type="none" w="med" len="med"/>
+                      <a:tailEnd type="none" w="med" len="med"/>
+                    </a:lnT>
+                    <a:lnB w="6350" cap="flat" cmpd="sng" algn="ctr">
+                      <a:solidFill>
+                        <a:srgbClr val="B8D4F0"/>
+                      </a:solidFill>
+                      <a:prstDash val="solid"/>
+                      <a:round/>
+                      <a:headEnd type="none" w="med" len="med"/>
+                      <a:tailEnd type="none" w="med" len="med"/>
+                    </a:lnB>
+                    <a:solidFill>
+                      <a:srgbClr val="EEF3FA"/>
+                    </a:solidFill>
+                  </a:tcPr>
+                </a:tc>
+                <a:tc>
+                  <a:txBody>
+                    <a:bodyPr/>
+                    <a:lstStyle/>
+                    <a:p>
+                      <a:pPr indent="0" marL="0">
+                        <a:buNone/>
+                      </a:pPr>
+                      <a:r>
+                        <a:rPr lang="en-US" sz="1100" dirty="0">
+                          <a:solidFill>
+                            <a:srgbClr val="1A1A2E"/>
+                          </a:solidFill>
+                        </a:rPr>
+                        <a:t>Au moins 15 cas</a:t>
+                      </a:r>
+                      <a:endParaRPr lang="en-US" sz="1100" dirty="0"/>
+                    </a:p>
+                  </a:txBody>
+                  <a:tcPr marL="73152" marR="73152" marT="27432" marB="27432" anchor="ctr">
+                    <a:lnL w="6350" cap="flat" cmpd="sng" algn="ctr">
+                      <a:solidFill>
+                        <a:srgbClr val="B8D4F0"/>
+                      </a:solidFill>
+                      <a:prstDash val="solid"/>
+                      <a:round/>
+                      <a:headEnd type="none" w="med" len="med"/>
+                      <a:tailEnd type="none" w="med" len="med"/>
+                    </a:lnL>
+                    <a:lnR w="6350" cap="flat" cmpd="sng" algn="ctr">
+                      <a:solidFill>
+                        <a:srgbClr val="B8D4F0"/>
+                      </a:solidFill>
+                      <a:prstDash val="solid"/>
+                      <a:round/>
+                      <a:headEnd type="none" w="med" len="med"/>
+                      <a:tailEnd type="none" w="med" len="med"/>
+                    </a:lnR>
+                    <a:lnT w="6350" cap="flat" cmpd="sng" algn="ctr">
+                      <a:solidFill>
+                        <a:srgbClr val="B8D4F0"/>
+                      </a:solidFill>
+                      <a:prstDash val="solid"/>
+                      <a:round/>
+                      <a:headEnd type="none" w="med" len="med"/>
+                      <a:tailEnd type="none" w="med" len="med"/>
+                    </a:lnT>
+                    <a:lnB w="6350" cap="flat" cmpd="sng" algn="ctr">
+                      <a:solidFill>
+                        <a:srgbClr val="B8D4F0"/>
+                      </a:solidFill>
+                      <a:prstDash val="solid"/>
+                      <a:round/>
+                      <a:headEnd type="none" w="med" len="med"/>
+                      <a:tailEnd type="none" w="med" len="med"/>
+                    </a:lnB>
+                    <a:solidFill>
+                      <a:srgbClr val="EEF3FA"/>
+                    </a:solidFill>
+                  </a:tcPr>
+                </a:tc>
+                <a:tc>
+                  <a:txBody>
+                    <a:bodyPr/>
+                    <a:lstStyle/>
+                    <a:p>
+                      <a:pPr indent="0" marL="0">
+                        <a:buNone/>
+                      </a:pPr>
+                      <a:r>
+                        <a:rPr lang="en-US" sz="1100" dirty="0">
+                          <a:solidFill>
+                            <a:srgbClr val="00338D"/>
+                          </a:solidFill>
+                        </a:rPr>
+                        <a:t>23 lignes exécutables, chacune avec sa raison</a:t>
+                      </a:r>
+                      <a:endParaRPr lang="en-US" sz="1100" dirty="0"/>
+                    </a:p>
+                  </a:txBody>
+                  <a:tcPr marL="73152" marR="73152" marT="27432" marB="27432" anchor="ctr">
+                    <a:lnL w="6350" cap="flat" cmpd="sng" algn="ctr">
+                      <a:solidFill>
+                        <a:srgbClr val="B8D4F0"/>
+                      </a:solidFill>
+                      <a:prstDash val="solid"/>
+                      <a:round/>
+                      <a:headEnd type="none" w="med" len="med"/>
+                      <a:tailEnd type="none" w="med" len="med"/>
+                    </a:lnL>
+                    <a:lnR w="6350" cap="flat" cmpd="sng" algn="ctr">
+                      <a:solidFill>
+                        <a:srgbClr val="B8D4F0"/>
+                      </a:solidFill>
+                      <a:prstDash val="solid"/>
+                      <a:round/>
+                      <a:headEnd type="none" w="med" len="med"/>
+                      <a:tailEnd type="none" w="med" len="med"/>
+                    </a:lnR>
+                    <a:lnT w="6350" cap="flat" cmpd="sng" algn="ctr">
+                      <a:solidFill>
+                        <a:srgbClr val="B8D4F0"/>
+                      </a:solidFill>
+                      <a:prstDash val="solid"/>
+                      <a:round/>
+                      <a:headEnd type="none" w="med" len="med"/>
+                      <a:tailEnd type="none" w="med" len="med"/>
+                    </a:lnT>
+                    <a:lnB w="6350" cap="flat" cmpd="sng" algn="ctr">
+                      <a:solidFill>
+                        <a:srgbClr val="B8D4F0"/>
+                      </a:solidFill>
+                      <a:prstDash val="solid"/>
+                      <a:round/>
+                      <a:headEnd type="none" w="med" len="med"/>
+                      <a:tailEnd type="none" w="med" len="med"/>
+                    </a:lnB>
+                    <a:solidFill>
+                      <a:srgbClr val="DCEFE2"/>
+                    </a:solidFill>
+                  </a:tcPr>
+                </a:tc>
+              </a:tr>
+            </a:tbl>
+          </a:graphicData>
+        </a:graphic>
+      </p:graphicFrame>
+      <p:sp>
+        <p:nvSpPr>
+          <p:cNvPr id="5" name="Text 2"/>
+          <p:cNvSpPr txBox="1"/>
+          <p:nvPr/>
+        </p:nvSpPr>
+        <p:spPr>
+          <a:xfrm>
+            <a:off x="548640" y="5943600"/>
+            <a:ext cx="11064240" cy="310896"/>
+          </a:xfrm>
+          <a:prstGeom prst="rect">
+            <a:avLst/>
+          </a:prstGeom>
+          <a:noFill/>
+          <a:ln/>
+        </p:spPr>
+        <p:txBody>
+          <a:bodyPr wrap="square" lIns="0" tIns="0" rIns="0" bIns="0" rtlCol="0" anchor="t"/>
+          <a:lstStyle/>
+          <a:p>
+            <a:pPr indent="0" marL="0">
+              <a:buNone/>
+            </a:pPr>
+            <a:r>
+              <a:rPr lang="en-US" sz="1200" b="1" dirty="0">
+                <a:solidFill>
+                  <a:srgbClr val="00338D"/>
+                </a:solidFill>
+              </a:rPr>
+              <a:t>Gardé de l'agent actuel : </a:t>
+            </a:r>
+            <a:pPr indent="0" marL="0">
+              <a:buNone/>
+            </a:pPr>
+            <a:r>
+              <a:rPr lang="en-US" sz="1200" dirty="0">
+                <a:solidFill>
+                  <a:schemeClr val="tx1"/>
+                </a:solidFill>
+              </a:rPr>
+              <a:t>Reprise absente en Renouvellement, valeur par défaut concrète, ouverture du panneau, recherche d'un collaborateur.</a:t>
+            </a:r>
+            <a:endParaRPr lang="en-US" sz="1200" dirty="0"/>
+          </a:p>
+        </p:txBody>
+      </p:sp>
+      <p:sp>
+        <p:nvSpPr>
+          <p:cNvPr id="25" name="Slide Number Placeholder 0"/>
+          <p:cNvSpPr>
+            <a:spLocks noGrp="1"/>
+          </p:cNvSpPr>
+          <p:nvPr>
+            <p:ph type="sldNum" sz="quarter" idx="4294967295"/>
+          </p:nvPr>
+        </p:nvSpPr>
+        <p:spPr>
+          <a:xfrm>
+            <a:off x="11155680" y="6446520"/>
+            <a:ext cx="457200" cy="274320"/>
+          </a:xfrm>
+          <a:prstGeom prst="rect">
+            <a:avLst/>
+          </a:prstGeom>
+          <a:extLst>
+            <a:ext uri="{C572A759-6A51-4108-AA02-DFA0A04FC94B}">
+              <ma14:wrappingTextBoxFlag xmlns:ma14="http://schemas.microsoft.com/office/mac/drawingml/2011/main" val="0"/>
+            </a:ext>
+          </a:extLst>
+        </p:spPr>
+        <p:txBody>
+          <a:bodyPr/>
+          <a:lstStyle>
+            <a:lvl1pPr>
+              <a:defRPr sz="1000">
+                <a:solidFill>
+                  <a:schemeClr val="accent4"/>
+                </a:solidFill>
+              </a:defRPr>
+            </a:lvl1pPr>
+          </a:lstStyle>
+          <a:p>
+            <a:pPr algn="r"/>
+            <a:fld id="{F7021451-1387-4CA6-816F-3879F97B5CBC}" type="slidenum">
+              <a:rPr b="0" lang="en-US"/>
+              <a:t>6</a:t>
+            </a:fld>
+            <a:endParaRPr lang="en-US"/>
+          </a:p>
+        </p:txBody>
+      </p:sp>
+    </p:spTree>
+  </p:cSld>
+  <p:clrMapOvr>
+    <a:masterClrMapping/>
+  </p:clrMapOvr>
+</p:sld>
+</file>
+
+<file path=ppt/slides/slide7.xml><?xml version="1.0" encoding="utf-8"?>
+<p:sld xmlns:a="http://schemas.openxmlformats.org/drawingml/2006/main" xmlns:r="http://schemas.openxmlformats.org/officeDocument/2006/relationships" xmlns:p="http://schemas.openxmlformats.org/presentationml/2006/main">
+  <p:cSld name="Slide 7">
+    <p:spTree>
+      <p:nvGrpSpPr>
+        <p:cNvPr id="1" name=""/>
+        <p:cNvGrpSpPr/>
+        <p:nvPr/>
+      </p:nvGrpSpPr>
+      <p:grpSpPr>
+        <a:xfrm>
+          <a:off x="0" y="0"/>
+          <a:ext cx="0" cy="0"/>
+          <a:chOff x="0" y="0"/>
+          <a:chExt cx="0" cy="0"/>
+        </a:xfrm>
+      </p:grpSpPr>
+      <p:sp>
+        <p:nvSpPr>
+          <p:cNvPr id="2" name="Text 0"/>
+          <p:cNvSpPr/>
+          <p:nvPr>
+            <p:ph idx="100" type="title" hasCustomPrompt="1"/>
+          </p:nvPr>
+        </p:nvSpPr>
+        <p:spPr>
+          <a:xfrm>
+            <a:off x="548640" y="320040"/>
+            <a:ext cx="11064240" cy="640080"/>
+          </a:xfrm>
+          <a:prstGeom prst="rect">
+            <a:avLst/>
+          </a:prstGeom>
+          <a:noFill/>
+          <a:ln/>
+        </p:spPr>
+        <p:txBody>
+          <a:bodyPr wrap="square" lIns="0" tIns="0" rIns="0" bIns="0" rtlCol="0" anchor="ctr"/>
+          <a:lstStyle/>
+          <a:p>
+            <a:pPr algn="l" indent="0" marL="0">
+              <a:buNone/>
+            </a:pPr>
+            <a:r>
+              <a:rPr lang="en-US" sz="2800" b="1" dirty="0">
+                <a:solidFill>
+                  <a:schemeClr val="tx2"/>
+                </a:solidFill>
+              </a:rPr>
               <a:t>La règle de validation : 5 situations, 1 seule testée</a:t>
             </a:r>
             <a:endParaRPr lang="en-US" sz="2800" dirty="0"/>
@@ -8423,7 +10404,7 @@
       </p:sp>
       <p:graphicFrame>
         <p:nvGraphicFramePr>
-          <p:cNvPr id="7" name="table-situations"/>
+          <p:cNvPr id="8" name="table-situations"/>
           <p:cNvGraphicFramePr>
             <a:graphicFrameLocks noGrp="1"/>
           </p:cNvGraphicFramePr>
@@ -10203,7 +12184,7 @@
             <a:pPr algn="r"/>
             <a:fld id="{F7021451-1387-4CA6-816F-3879F97B5CBC}" type="slidenum">
               <a:rPr b="0" lang="en-US"/>
-              <a:t>6</a:t>
+              <a:t>7</a:t>
             </a:fld>
             <a:endParaRPr lang="en-US"/>
           </a:p>
@@ -10217,9 +12198,9 @@
 </p:sld>
 </file>
 
-<file path=ppt/slides/slide7.xml><?xml version="1.0" encoding="utf-8"?>
+<file path=ppt/slides/slide8.xml><?xml version="1.0" encoding="utf-8"?>
 <p:sld xmlns:a="http://schemas.openxmlformats.org/drawingml/2006/main" xmlns:r="http://schemas.openxmlformats.org/officeDocument/2006/relationships" xmlns:p="http://schemas.openxmlformats.org/presentationml/2006/main">
-  <p:cSld name="Slide 7">
+  <p:cSld name="Slide 8">
     <p:spTree>
       <p:nvGrpSpPr>
         <p:cNvPr id="1" name=""/>
@@ -10312,7 +12293,7 @@
       </p:sp>
       <p:graphicFrame>
         <p:nvGraphicFramePr>
-          <p:cNvPr id="8" name="table-bilan"/>
+          <p:cNvPr id="9" name="table-bilan"/>
           <p:cNvGraphicFramePr>
             <a:graphicFrameLocks noGrp="1"/>
           </p:cNvGraphicFramePr>
@@ -11675,7 +13656,7 @@
             <a:pPr algn="r"/>
             <a:fld id="{F7021451-1387-4CA6-816F-3879F97B5CBC}" type="slidenum">
               <a:rPr b="0" lang="en-US"/>
-              <a:t>7</a:t>
+              <a:t>8</a:t>
             </a:fld>
             <a:endParaRPr lang="en-US"/>
           </a:p>
@@ -11689,9 +13670,9 @@
 </p:sld>
 </file>
 
-<file path=ppt/slides/slide8.xml><?xml version="1.0" encoding="utf-8"?>
+<file path=ppt/slides/slide9.xml><?xml version="1.0" encoding="utf-8"?>
 <p:sld xmlns:a="http://schemas.openxmlformats.org/drawingml/2006/main" xmlns:r="http://schemas.openxmlformats.org/officeDocument/2006/relationships" xmlns:p="http://schemas.openxmlformats.org/presentationml/2006/main">
-  <p:cSld name="Slide 8">
+  <p:cSld name="Slide 9">
     <p:spTree>
       <p:nvGrpSpPr>
         <p:cNvPr id="1" name=""/>
@@ -11817,7 +13798,7 @@
                   <a:schemeClr val="tx1"/>
                 </a:solidFill>
               </a:rPr>
-              <a:t>Remplir le fichier de contexte projet : rôles, comptes de test, statuts, règles validées</a:t>
+              <a:t>Créer le contexte projet depuis le PRD et le DAG, puis le faire relire</a:t>
             </a:r>
             <a:endParaRPr lang="en-US" sz="1500" dirty="0"/>
           </a:p>
@@ -11836,7 +13817,7 @@
                   <a:schemeClr val="tx1"/>
                 </a:solidFill>
               </a:rPr>
-              <a:t>Rejouer la nouvelle version sur 3 US déjà traitées à la main</a:t>
+              <a:t>Rejouer le nouvel agent sur 3 US déjà traitées à la main</a:t>
             </a:r>
             <a:endParaRPr lang="en-US" sz="1500" dirty="0"/>
           </a:p>
@@ -11965,8 +13946,8 @@
         </p:nvSpPr>
         <p:spPr>
           <a:xfrm>
-            <a:off x="7178040" y="2286000"/>
-            <a:ext cx="4251960" cy="1645920"/>
+            <a:off x="7178040" y="2240280"/>
+            <a:ext cx="4251960" cy="1737360"/>
           </a:xfrm>
           <a:prstGeom prst="rect">
             <a:avLst/>
@@ -11980,56 +13961,74 @@
           <a:p>
             <a:pPr marL="342900" indent="-342900">
               <a:spcAft>
-                <a:spcPts val="1000"/>
+                <a:spcPts val="600"/>
               </a:spcAft>
               <a:buSzPct val="100000"/>
               <a:buChar char="•"/>
             </a:pPr>
             <a:r>
-              <a:rPr lang="en-US" sz="1400" dirty="0">
+              <a:rPr lang="en-US" sz="1350" dirty="0">
                 <a:solidFill>
                   <a:schemeClr val="bg1"/>
                 </a:solidFill>
               </a:rPr>
               <a:t>Valider la démarche</a:t>
             </a:r>
-            <a:endParaRPr lang="en-US" sz="1400" dirty="0"/>
+            <a:endParaRPr lang="en-US" sz="1350" dirty="0"/>
           </a:p>
           <a:p>
             <a:pPr marL="342900" indent="-342900">
               <a:spcAft>
-                <a:spcPts val="1000"/>
+                <a:spcPts val="600"/>
               </a:spcAft>
               <a:buSzPct val="100000"/>
               <a:buChar char="•"/>
             </a:pPr>
             <a:r>
-              <a:rPr lang="en-US" sz="1400" dirty="0">
+              <a:rPr lang="en-US" sz="1350" dirty="0">
                 <a:solidFill>
                   <a:schemeClr val="bg1"/>
                 </a:solidFill>
               </a:rPr>
               <a:t>Choisir les 3 US de référence</a:t>
             </a:r>
-            <a:endParaRPr lang="en-US" sz="1400" dirty="0"/>
+            <a:endParaRPr lang="en-US" sz="1350" dirty="0"/>
           </a:p>
           <a:p>
             <a:pPr marL="342900" indent="-342900">
               <a:spcAft>
-                <a:spcPts val="1000"/>
+                <a:spcPts val="600"/>
               </a:spcAft>
               <a:buSzPct val="100000"/>
               <a:buChar char="•"/>
             </a:pPr>
             <a:r>
-              <a:rPr lang="en-US" sz="1400" dirty="0">
+              <a:rPr lang="en-US" sz="1350" dirty="0">
                 <a:solidFill>
                   <a:schemeClr val="bg1"/>
                 </a:solidFill>
               </a:rPr>
-              <a:t>Un accès pour mettre à jour les consignes de l'agent dans le dépôt</a:t>
+              <a:t>Un accès au dépôt pour l'installer</a:t>
             </a:r>
-            <a:endParaRPr lang="en-US" sz="1400" dirty="0"/>
+            <a:endParaRPr lang="en-US" sz="1350" dirty="0"/>
+          </a:p>
+          <a:p>
+            <a:pPr marL="342900" indent="-342900">
+              <a:spcAft>
+                <a:spcPts val="600"/>
+              </a:spcAft>
+              <a:buSzPct val="100000"/>
+              <a:buChar char="•"/>
+            </a:pPr>
+            <a:r>
+              <a:rPr lang="en-US" sz="1350" dirty="0">
+                <a:solidFill>
+                  <a:schemeClr val="bg1"/>
+                </a:solidFill>
+              </a:rPr>
+              <a:t>L'accord pour envoyer le PRD et le DAG à l'outil IA</a:t>
+            </a:r>
+            <a:endParaRPr lang="en-US" sz="1350" dirty="0"/>
           </a:p>
         </p:txBody>
       </p:sp>
@@ -12141,7 +14140,7 @@
             <a:pPr algn="r"/>
             <a:fld id="{F7021451-1387-4CA6-816F-3879F97B5CBC}" type="slidenum">
               <a:rPr b="0" lang="en-US"/>
-              <a:t>8</a:t>
+              <a:t>9</a:t>
             </a:fld>
             <a:endParaRPr lang="en-US"/>
           </a:p>

</xml_diff>

<commit_message>
Mise à jour des présentations et du mail
</commit_message>
<xml_diff>
--- a/doc/Agent-QC-actuel-vs-propose.pptx
+++ b/doc/Agent-QC-actuel-vs-propose.pptx
@@ -115,7 +115,7 @@
   <p:extLst>
     <p:ext uri="{521415D9-36F7-43E2-AB2F-B90AF26B5E84}">
       <p14:sectionLst xmlns:p14="http://schemas.microsoft.com/office/powerpoint/2010/main">
-        <p14:section name="Agent QC" id="{cb60ade3-0637-78d5-4d17-bfc8d81ab1da}">
+        <p14:section name="Agent QC" id="{d4021ae9-59aa-7bed-74e7-cb9a45607c7e}">
           <p14:sldIdLst>
             <p14:sldId id="256"/>
             <p14:sldId id="257"/>
@@ -708,7 +708,7 @@
           <a:p>
             <a:r>
               <a:rPr lang="en-US" dirty="0"/>
-              <a:t>Relevé dans le fichier qc.agent.md du dépôt de l'équipe, sur ses cas pour l'US 417829 et dans le retour d'équipe sur un autre projet. Le défaut le plus visible : chaque cas tient en une ligne Given, When, Then, en anglais, sans dire avec quel rôle se connecter, sur quel écran partir ni quelles données préparer. Le plus grave : quand l'US est floue, il écrit quand même un résultat attendu, parce que ses consignes lui interdisent d'ajouter une section où poser une question. La publication technique dans Azure DevOps fonctionne et est conservée.</a:t>
+              <a:t>Sources : la sortie de l'agent pour l'US 417829 (cas TC-001 à TC-014, début de TC-015, et sa liste de cas UI) et son fichier de consignes qc.agent.md ; « l. » renvoie au numéro de ligne de ce fichier. Les parties 1, 2 et 4 de sa sortie (analyse, risques, cas limites) n'ont pas été relues : on ne dit donc pas qu'il n'a vu aucun risque, seulement que son format ne prévoit aucune place pour une question au PO (l. 207 : aucune partie en plus). Les numéros de section de l'US renvoient à la description de l'US 417829 : §1 Accès, §2 Panneau, §3 Nature du mandat, §4 Validation, §5 Création. Point le plus important : la règle de validation du §4 décrit cinq situations, l'agent n'en couvre qu'une dans les cas relus. Point le plus visible : chaque cas tient en une ligne, sans dire avec quel rôle se connecter ni quelles données préparer. Ce qui est réussi est conservé.</a:t>
             </a:r>
             <a:endParaRPr lang="en-US" dirty="0"/>
           </a:p>
@@ -972,7 +972,7 @@
           <a:p>
             <a:r>
               <a:rPr lang="en-US" dirty="0"/>
-              <a:t>Limite de la comparaison : la sortie de l'agent actuel a été produite par l'agent de l'équipe ; notre résultat a été produit en appliquant les nouvelles consignes en dehors de cet outil. Le vrai test sera de rejouer le nouvel agent dans l'outil de l'équipe sur la même US. Comparaison faite sur la sortie de l'agent actuel (TC-001 à TC-014 et début de TC-015) et sur la version proposée appliquée à l'US complète. Sur l'accès, le panneau et les champs du formulaire, les deux couvertures sont proches. La différence est ailleurs. Exécutabilité : les cas actuels ne disent ni qui se connecte ni quelles données préparer. Règle métier : la validation dépend du statut de la demande existante sur l'entité ; l'agent actuel n'en teste qu'un cas. Honnêteté : l'US dit qu'une entité inconnue est refusée alors que la saisie libre est impossible ; l'agent actuel ne le voit pas, la version proposée en fait une question bloquante. Les textes exacts des messages sont dans les maquettes : ils restent à compléter.</a:t>
+              <a:t>Limite de la comparaison : la sortie de l'agent actuel a été produite par l'agent de l'équipe ; notre résultat a été produit en appliquant les nouvelles consignes en dehors de cet outil. Le vrai test sera de rejouer le nouvel agent dans l'outil de l'équipe sur la même US. Comparaison faite sur la sortie de l'agent actuel (TC-001 à TC-014 et début de TC-015) et sur la version proposée appliquée à l'US complète. Sur l'accès, le panneau et les champs du formulaire, les deux couvertures sont proches. La différence est ailleurs. Exécutabilité : les cas actuels ne disent ni qui se connecte ni quelles données préparer. Règle métier : la validation dépend du statut de la demande existante sur l'entité ; l'agent actuel n'en teste qu'un cas. Ce que l'US ne dit pas : au §3, l'US annonce une erreur « entité ID inconnue » alors que l'entité ne peut pas être saisie librement ; l'agent actuel prévoit de tester ce message sans relever ce point, la version proposée en fait une question bloquante. Millésime : les deux versions testent la valeur par défaut et la plage de -20 à +10 ans (TC-009, TC-010) ; pas de différence ici. Les textes exacts des messages sont dans les maquettes : ils restent à compléter.</a:t>
             </a:r>
             <a:endParaRPr lang="en-US" dirty="0"/>
           </a:p>
@@ -1060,7 +1060,7 @@
           <a:p>
             <a:r>
               <a:rPr lang="en-US" dirty="0"/>
-              <a:t>C'est la règle métier la plus importante de l'US, dans sa section Validation. Elle compte cinq situations : deux où la création est acceptée, trois où elle est refusée. L'agent actuel n'en teste qu'une, la plus simple. La version proposée les teste toutes ; pour chaque refus, elle vérifie aussi que la demande déjà existante n'a pas été modifiée. À droite, l'un des trois scénarios de refus, en version abrégée. Le texte exact du message d'erreur est dans les maquettes : il sera recopié dans le scénario.</a:t>
+              <a:t>Texte exact de l'US 417829, section 4 Validation, quatrième point, affiché en haut de la diapo. Il décrit cinq situations : deux où la création est possible (entité sans statut, entité au statut validé), trois où elle est refusée (une demande déjà en cours, en retard ou en révision). Dans les cas TC-001 à TC-015, l'agent actuel n'en couvre qu'une : TC-012, « une entité sans demande existante ». La version proposée couvre les cinq ; pour chaque refus, elle vérifie aussi que la demande déjà existante n'a pas changé. À droite, l'un des trois scénarios de refus, en version abrégée. Deux points restent à confirmer avec le PO : le texte exact du message d'erreur (« cf maquettes » dans l'US) et le sens de « pas encore de statut », que nous lisons comme « aucune demande sur cette entité ».</a:t>
             </a:r>
             <a:endParaRPr lang="en-US" dirty="0"/>
           </a:p>
@@ -2489,7 +2489,7 @@
                   <a:schemeClr val="tx1"/>
                 </a:solidFill>
               </a:rPr>
-              <a:t>Panneau à droite, liste visible (TC-004) ; millésime de -20 à +10 ans (TC-010) ; création puis redirection (TC-012)</a:t>
+              <a:t>Panneau à droite, liste visible (TC-004, US §2) ; millésime de -20 à +10 ans (TC-010, US §3) ; création puis redirection (TC-012, US §5)</a:t>
             </a:r>
             <a:endParaRPr lang="en-US" sz="1250" dirty="0"/>
           </a:p>
@@ -2807,7 +2807,7 @@
                   <a:schemeClr val="tx2"/>
                 </a:solidFill>
               </a:rPr>
-              <a:t>Publication technique solide</a:t>
+              <a:t>Publication bien outillée</a:t>
             </a:r>
             <a:endParaRPr lang="en-US" sz="1450" dirty="0"/>
           </a:p>
@@ -2843,7 +2843,7 @@
                   <a:schemeClr val="tx1"/>
                 </a:solidFill>
               </a:rPr>
-              <a:t>Codes HTTP contrôlés, liens vérifiés entre cas et US dans Azure DevOps</a:t>
+              <a:t>Ses consignes contrôlent chaque code HTTP et vérifient le lien entre chaque cas et l'US</a:t>
             </a:r>
             <a:endParaRPr lang="en-US" sz="1250" dirty="0"/>
           </a:p>
@@ -2989,7 +2989,7 @@
                   <a:schemeClr val="accent1"/>
                 </a:solidFill>
               </a:rPr>
-              <a:t>Il applique ses consignes à la lettre : ses défauts viennent de ses consignes, pas du modèle.</a:t>
+              <a:t>Sur l'US 417829 (cas TC-001 à TC-015 et autres cas UI) : ses défauts viennent surtout de ses consignes.</a:t>
             </a:r>
             <a:endParaRPr lang="en-US" sz="1600" dirty="0"/>
           </a:p>
@@ -3160,7 +3160,7 @@
                             <a:srgbClr val="FFFFFF"/>
                           </a:solidFill>
                         </a:rPr>
-                        <a:t>Pourquoi : ses consignes</a:t>
+                        <a:t>Cause dans qc.agent.md</a:t>
                       </a:r>
                       <a:endParaRPr lang="en-US" sz="1200" dirty="0"/>
                     </a:p>
@@ -3269,7 +3269,7 @@
                   </a:tcPr>
                 </a:tc>
               </a:tr>
-              <a:tr h="502920">
+              <a:tr h="530352">
                 <a:tc>
                   <a:txBody>
                     <a:bodyPr/>
@@ -3279,14 +3279,14 @@
                         <a:buNone/>
                       </a:pPr>
                       <a:r>
-                        <a:rPr lang="en-US" sz="1000" b="1" dirty="0">
+                        <a:rPr lang="en-US" sz="950" b="1" dirty="0">
                           <a:solidFill>
                             <a:srgbClr val="1A1A2E"/>
                           </a:solidFill>
                         </a:rPr>
-                        <a:t>Une phrase par scénario, sans aucun Et, en Given, When, Then</a:t>
+                        <a:t>Chaque cas tient en une ligne Given, When, Then, sans aucun Et</a:t>
                       </a:r>
-                      <a:endParaRPr lang="en-US" sz="1000" dirty="0"/>
+                      <a:endParaRPr lang="en-US" sz="950" dirty="0"/>
                     </a:p>
                   </a:txBody>
                   <a:tcPr marL="73152" marR="73152" marT="27432" marB="27432" anchor="ctr">
@@ -3340,14 +3340,14 @@
                         <a:buNone/>
                       </a:pPr>
                       <a:r>
-                        <a:rPr lang="en-US" sz="1000" i="1" dirty="0">
+                        <a:rPr lang="en-US" sz="950" i="1" dirty="0">
                           <a:solidFill>
                             <a:srgbClr val="1A1A2E"/>
                           </a:solidFill>
                         </a:rPr>
-                        <a:t>TC-013 : « Given une entité valide, Nature Nouveau, Reprise Oui et tous les champs renseignés »</a:t>
+                        <a:t>TC-013 : « Given une entité valide, Nature « Nouveau », Reprise « Oui » et tous les champs renseignés, When … »</a:t>
                       </a:r>
-                      <a:endParaRPr lang="en-US" sz="1000" dirty="0"/>
+                      <a:endParaRPr lang="en-US" sz="950" dirty="0"/>
                     </a:p>
                   </a:txBody>
                   <a:tcPr marL="73152" marR="73152" marT="27432" marB="27432" anchor="ctr">
@@ -3401,14 +3401,14 @@
                         <a:buNone/>
                       </a:pPr>
                       <a:r>
-                        <a:rPr lang="en-US" sz="1000" dirty="0">
+                        <a:rPr lang="en-US" sz="950" dirty="0">
                           <a:solidFill>
                             <a:srgbClr val="1A1A2E"/>
                           </a:solidFill>
                         </a:rPr>
-                        <a:t>Tableau imposé : un scénario par cellule ; exemple en anglais</a:t>
+                        <a:t>Gherkin dans une cellule de tableau (l. 205-206) ; exemple en Given, When, Then (l. 232)</a:t>
                       </a:r>
-                      <a:endParaRPr lang="en-US" sz="1000" dirty="0"/>
+                      <a:endParaRPr lang="en-US" sz="950" dirty="0"/>
                     </a:p>
                   </a:txBody>
                   <a:tcPr marL="73152" marR="73152" marT="27432" marB="27432" anchor="ctr">
@@ -3462,14 +3462,14 @@
                         <a:buNone/>
                       </a:pPr>
                       <a:r>
-                        <a:rPr lang="en-US" sz="1000" dirty="0">
+                        <a:rPr lang="en-US" sz="950" dirty="0">
                           <a:solidFill>
                             <a:srgbClr val="00338D"/>
                           </a:solidFill>
                         </a:rPr>
-                        <a:t>Un bloc Gherkin en français, une ligne par étape</a:t>
+                        <a:t>Gherkin en français, une ligne par étape</a:t>
                       </a:r>
-                      <a:endParaRPr lang="en-US" sz="1000" dirty="0"/>
+                      <a:endParaRPr lang="en-US" sz="950" dirty="0"/>
                     </a:p>
                   </a:txBody>
                   <a:tcPr marL="73152" marR="73152" marT="27432" marB="27432" anchor="ctr">
@@ -3515,7 +3515,7 @@
                   </a:tcPr>
                 </a:tc>
               </a:tr>
-              <a:tr h="502920">
+              <a:tr h="530352">
                 <a:tc>
                   <a:txBody>
                     <a:bodyPr/>
@@ -3525,14 +3525,14 @@
                         <a:buNone/>
                       </a:pPr>
                       <a:r>
-                        <a:rPr lang="en-US" sz="1000" b="1" dirty="0">
+                        <a:rPr lang="en-US" sz="950" b="1" dirty="0">
                           <a:solidFill>
                             <a:srgbClr val="1A1A2E"/>
                           </a:solidFill>
                         </a:rPr>
                         <a:t>Ni rôle, ni écran, ni données</a:t>
                       </a:r>
-                      <a:endParaRPr lang="en-US" sz="1000" dirty="0"/>
+                      <a:endParaRPr lang="en-US" sz="950" dirty="0"/>
                     </a:p>
                   </a:txBody>
                   <a:tcPr marL="73152" marR="73152" marT="27432" marB="27432" anchor="ctr">
@@ -3586,14 +3586,14 @@
                         <a:buNone/>
                       </a:pPr>
                       <a:r>
-                        <a:rPr lang="en-US" sz="1000" i="1" dirty="0">
+                        <a:rPr lang="en-US" sz="950" i="1" dirty="0">
                           <a:solidFill>
                             <a:srgbClr val="1A1A2E"/>
                           </a:solidFill>
                         </a:rPr>
-                        <a:t>TC-005 : « Given le formulaire de création ouvert » ; TC-003 : « un rôle autre qu'Admin »</a:t>
+                        <a:t>TC-005 : « Given le formulaire de création ouvert » ; TC-003 : « un rôle autre qu'Admin ou SuperAdmin »</a:t>
                       </a:r>
-                      <a:endParaRPr lang="en-US" sz="1000" dirty="0"/>
+                      <a:endParaRPr lang="en-US" sz="950" dirty="0"/>
                     </a:p>
                   </a:txBody>
                   <a:tcPr marL="73152" marR="73152" marT="27432" marB="27432" anchor="ctr">
@@ -3647,14 +3647,14 @@
                         <a:buNone/>
                       </a:pPr>
                       <a:r>
-                        <a:rPr lang="en-US" sz="1000" dirty="0">
+                        <a:rPr lang="en-US" sz="950" dirty="0">
                           <a:solidFill>
                             <a:srgbClr val="1A1A2E"/>
                           </a:solidFill>
                         </a:rPr>
-                        <a:t>« Given un utilisateur actif » donné en exemple</a:t>
+                        <a:t>Exemple à copier : « Given un utilisateur actif » (l. 232)</a:t>
                       </a:r>
-                      <a:endParaRPr lang="en-US" sz="1000" dirty="0"/>
+                      <a:endParaRPr lang="en-US" sz="950" dirty="0"/>
                     </a:p>
                   </a:txBody>
                   <a:tcPr marL="73152" marR="73152" marT="27432" marB="27432" anchor="ctr">
@@ -3708,14 +3708,14 @@
                         <a:buNone/>
                       </a:pPr>
                       <a:r>
-                        <a:rPr lang="en-US" sz="1000" dirty="0">
+                        <a:rPr lang="en-US" sz="950" dirty="0">
                           <a:solidFill>
                             <a:srgbClr val="00338D"/>
                           </a:solidFill>
                         </a:rPr>
                         <a:t>Rôle et compte, écran, données fictives dans chaque cas</a:t>
                       </a:r>
-                      <a:endParaRPr lang="en-US" sz="1000" dirty="0"/>
+                      <a:endParaRPr lang="en-US" sz="950" dirty="0"/>
                     </a:p>
                   </a:txBody>
                   <a:tcPr marL="73152" marR="73152" marT="27432" marB="27432" anchor="ctr">
@@ -3761,7 +3761,7 @@
                   </a:tcPr>
                 </a:tc>
               </a:tr>
-              <a:tr h="502920">
+              <a:tr h="530352">
                 <a:tc>
                   <a:txBody>
                     <a:bodyPr/>
@@ -3771,14 +3771,14 @@
                         <a:buNone/>
                       </a:pPr>
                       <a:r>
-                        <a:rPr lang="en-US" sz="1000" b="1" dirty="0">
+                        <a:rPr lang="en-US" sz="950" b="1" dirty="0">
                           <a:solidFill>
                             <a:srgbClr val="1A1A2E"/>
                           </a:solidFill>
                         </a:rPr>
-                        <a:t>Actions entassées ou sautées</a:t>
+                        <a:t>Actions résumées en une clause</a:t>
                       </a:r>
-                      <a:endParaRPr lang="en-US" sz="1000" dirty="0"/>
+                      <a:endParaRPr lang="en-US" sz="950" dirty="0"/>
                     </a:p>
                   </a:txBody>
                   <a:tcPr marL="73152" marR="73152" marT="27432" marB="27432" anchor="ctr">
@@ -3832,14 +3832,14 @@
                         <a:buNone/>
                       </a:pPr>
                       <a:r>
-                        <a:rPr lang="en-US" sz="1000" i="1" dirty="0">
+                        <a:rPr lang="en-US" sz="950" i="1" dirty="0">
                           <a:solidFill>
                             <a:srgbClr val="1A1A2E"/>
                           </a:solidFill>
                         </a:rPr>
-                        <a:t>TC-008 : « saisit un nom ou prénom … et le sélectionne » ; « tous les champs renseignés »</a:t>
+                        <a:t>TC-008 : « saisit un nom ou prénom … et le sélectionne » ; TC-012 : « tous les champs renseignés »</a:t>
                       </a:r>
-                      <a:endParaRPr lang="en-US" sz="1000" dirty="0"/>
+                      <a:endParaRPr lang="en-US" sz="950" dirty="0"/>
                     </a:p>
                   </a:txBody>
                   <a:tcPr marL="73152" marR="73152" marT="27432" marB="27432" anchor="ctr">
@@ -3893,14 +3893,14 @@
                         <a:buNone/>
                       </a:pPr>
                       <a:r>
-                        <a:rPr lang="en-US" sz="1000" dirty="0">
+                        <a:rPr lang="en-US" sz="950" dirty="0">
                           <a:solidFill>
                             <a:srgbClr val="1A1A2E"/>
                           </a:solidFill>
                         </a:rPr>
-                        <a:t>Une seule clause When imposée</a:t>
+                        <a:t>Une seule ligne par cas ; aucune règle sur les données</a:t>
                       </a:r>
-                      <a:endParaRPr lang="en-US" sz="1000" dirty="0"/>
+                      <a:endParaRPr lang="en-US" sz="950" dirty="0"/>
                     </a:p>
                   </a:txBody>
                   <a:tcPr marL="73152" marR="73152" marT="27432" marB="27432" anchor="ctr">
@@ -3954,14 +3954,14 @@
                         <a:buNone/>
                       </a:pPr>
                       <a:r>
-                        <a:rPr lang="en-US" sz="1000" dirty="0">
+                        <a:rPr lang="en-US" sz="950" dirty="0">
                           <a:solidFill>
                             <a:srgbClr val="00338D"/>
                           </a:solidFill>
                         </a:rPr>
                         <a:t>Quand puis Et : une action par ligne</a:t>
                       </a:r>
-                      <a:endParaRPr lang="en-US" sz="1000" dirty="0"/>
+                      <a:endParaRPr lang="en-US" sz="950" dirty="0"/>
                     </a:p>
                   </a:txBody>
                   <a:tcPr marL="73152" marR="73152" marT="27432" marB="27432" anchor="ctr">
@@ -4007,7 +4007,7 @@
                   </a:tcPr>
                 </a:tc>
               </a:tr>
-              <a:tr h="502920">
+              <a:tr h="530352">
                 <a:tc>
                   <a:txBody>
                     <a:bodyPr/>
@@ -4017,14 +4017,14 @@
                         <a:buNone/>
                       </a:pPr>
                       <a:r>
-                        <a:rPr lang="en-US" sz="1000" b="1" dirty="0">
+                        <a:rPr lang="en-US" sz="950" b="1" dirty="0">
                           <a:solidFill>
                             <a:srgbClr val="1A1A2E"/>
                           </a:solidFill>
                         </a:rPr>
-                        <a:t>Résultats invérifiables ou vagues</a:t>
+                        <a:t>Résultats impossibles à vérifier</a:t>
                       </a:r>
-                      <a:endParaRPr lang="en-US" sz="1000" dirty="0"/>
+                      <a:endParaRPr lang="en-US" sz="950" dirty="0"/>
                     </a:p>
                   </a:txBody>
                   <a:tcPr marL="73152" marR="73152" marT="27432" marB="27432" anchor="ctr">
@@ -4078,14 +4078,14 @@
                         <a:buNone/>
                       </a:pPr>
                       <a:r>
-                        <a:rPr lang="en-US" sz="1000" i="1" dirty="0">
+                        <a:rPr lang="en-US" sz="950" i="1" dirty="0">
                           <a:solidFill>
                             <a:srgbClr val="1A1A2E"/>
                           </a:solidFill>
                         </a:rPr>
-                        <a:t>TC-008 : « le collaborateur est affecté » avant la création ; TC-013 : « formulaire adapté »</a:t>
+                        <a:t>TC-008 : « le collaborateur est affecté à la demande », avant sa création ; TC-013 : « le formulaire adapté »</a:t>
                       </a:r>
-                      <a:endParaRPr lang="en-US" sz="1000" dirty="0"/>
+                      <a:endParaRPr lang="en-US" sz="950" dirty="0"/>
                     </a:p>
                   </a:txBody>
                   <a:tcPr marL="73152" marR="73152" marT="27432" marB="27432" anchor="ctr">
@@ -4139,14 +4139,14 @@
                         <a:buNone/>
                       </a:pPr>
                       <a:r>
-                        <a:rPr lang="en-US" sz="1000" dirty="0">
+                        <a:rPr lang="en-US" sz="950" dirty="0">
                           <a:solidFill>
                             <a:srgbClr val="1A1A2E"/>
                           </a:solidFill>
                         </a:rPr>
-                        <a:t>Exemple vague copié à la lettre</a:t>
+                        <a:t>Aucune règle sur le résultat attendu</a:t>
                       </a:r>
-                      <a:endParaRPr lang="en-US" sz="1000" dirty="0"/>
+                      <a:endParaRPr lang="en-US" sz="950" dirty="0"/>
                     </a:p>
                   </a:txBody>
                   <a:tcPr marL="73152" marR="73152" marT="27432" marB="27432" anchor="ctr">
@@ -4200,14 +4200,14 @@
                         <a:buNone/>
                       </a:pPr>
                       <a:r>
-                        <a:rPr lang="en-US" sz="1000" dirty="0">
+                        <a:rPr lang="en-US" sz="950" dirty="0">
                           <a:solidFill>
                             <a:srgbClr val="00338D"/>
                           </a:solidFill>
                         </a:rPr>
                         <a:t>Résultat exact ; un refus vérifie que rien n'a changé</a:t>
                       </a:r>
-                      <a:endParaRPr lang="en-US" sz="1000" dirty="0"/>
+                      <a:endParaRPr lang="en-US" sz="950" dirty="0"/>
                     </a:p>
                   </a:txBody>
                   <a:tcPr marL="73152" marR="73152" marT="27432" marB="27432" anchor="ctr">
@@ -4253,7 +4253,7 @@
                   </a:tcPr>
                 </a:tc>
               </a:tr>
-              <a:tr h="502920">
+              <a:tr h="530352">
                 <a:tc>
                   <a:txBody>
                     <a:bodyPr/>
@@ -4263,14 +4263,14 @@
                         <a:buNone/>
                       </a:pPr>
                       <a:r>
-                        <a:rPr lang="en-US" sz="1000" b="1" dirty="0">
+                        <a:rPr lang="en-US" sz="950" b="1" dirty="0">
                           <a:solidFill>
                             <a:srgbClr val="1A1A2E"/>
                           </a:solidFill>
                         </a:rPr>
-                        <a:t>Règles métier oubliées</a:t>
+                        <a:t>Règle de validation peu couverte</a:t>
                       </a:r>
-                      <a:endParaRPr lang="en-US" sz="1000" dirty="0"/>
+                      <a:endParaRPr lang="en-US" sz="950" dirty="0"/>
                     </a:p>
                   </a:txBody>
                   <a:tcPr marL="73152" marR="73152" marT="27432" marB="27432" anchor="ctr">
@@ -4324,14 +4324,14 @@
                         <a:buNone/>
                       </a:pPr>
                       <a:r>
-                        <a:rPr lang="en-US" sz="1000" i="1" dirty="0">
+                        <a:rPr lang="en-US" sz="950" i="1" dirty="0">
                           <a:solidFill>
                             <a:srgbClr val="1A1A2E"/>
                           </a:solidFill>
                         </a:rPr>
-                        <a:t>Statut de l'entité : 1 situation sur 5 ; millésime : 1 cas, sans les bornes</a:t>
+                        <a:t>US §4 : 5 situations selon le statut de l'entité ; une seule dans TC-001 à TC-015 (TC-012)</a:t>
                       </a:r>
-                      <a:endParaRPr lang="en-US" sz="1000" dirty="0"/>
+                      <a:endParaRPr lang="en-US" sz="950" dirty="0"/>
                     </a:p>
                   </a:txBody>
                   <a:tcPr marL="73152" marR="73152" marT="27432" marB="27432" anchor="ctr">
@@ -4385,14 +4385,14 @@
                         <a:buNone/>
                       </a:pPr>
                       <a:r>
-                        <a:rPr lang="en-US" sz="1000" dirty="0">
+                        <a:rPr lang="en-US" sz="950" dirty="0">
                           <a:solidFill>
                             <a:srgbClr val="1A1A2E"/>
                           </a:solidFill>
                         </a:rPr>
-                        <a:t>Aucune étape qui extrait les règles</a:t>
+                        <a:t>Aucune étape qui extrait les règles de l'US</a:t>
                       </a:r>
-                      <a:endParaRPr lang="en-US" sz="1000" dirty="0"/>
+                      <a:endParaRPr lang="en-US" sz="950" dirty="0"/>
                     </a:p>
                   </a:txBody>
                   <a:tcPr marL="73152" marR="73152" marT="27432" marB="27432" anchor="ctr">
@@ -4446,14 +4446,14 @@
                         <a:buNone/>
                       </a:pPr>
                       <a:r>
-                        <a:rPr lang="en-US" sz="1000" dirty="0">
+                        <a:rPr lang="en-US" sz="950" dirty="0">
                           <a:solidFill>
                             <a:srgbClr val="00338D"/>
                           </a:solidFill>
                         </a:rPr>
-                        <a:t>Règles extraites de l'US, combinaisons, valeurs limites</a:t>
+                        <a:t>Une ligne par situation décrite dans l'US</a:t>
                       </a:r>
-                      <a:endParaRPr lang="en-US" sz="1000" dirty="0"/>
+                      <a:endParaRPr lang="en-US" sz="950" dirty="0"/>
                     </a:p>
                   </a:txBody>
                   <a:tcPr marL="73152" marR="73152" marT="27432" marB="27432" anchor="ctr">
@@ -4499,7 +4499,7 @@
                   </a:tcPr>
                 </a:tc>
               </a:tr>
-              <a:tr h="502920">
+              <a:tr h="530352">
                 <a:tc>
                   <a:txBody>
                     <a:bodyPr/>
@@ -4509,14 +4509,14 @@
                         <a:buNone/>
                       </a:pPr>
                       <a:r>
-                        <a:rPr lang="en-US" sz="1000" b="1" dirty="0">
+                        <a:rPr lang="en-US" sz="950" b="1" dirty="0">
                           <a:solidFill>
                             <a:srgbClr val="1A1A2E"/>
                           </a:solidFill>
                         </a:rPr>
-                        <a:t>Aucune question sur ce que l'US ne dit pas</a:t>
+                        <a:t>Aucune question au PO, des ajouts non demandés</a:t>
                       </a:r>
-                      <a:endParaRPr lang="en-US" sz="1000" dirty="0"/>
+                      <a:endParaRPr lang="en-US" sz="950" dirty="0"/>
                     </a:p>
                   </a:txBody>
                   <a:tcPr marL="73152" marR="73152" marT="27432" marB="27432" anchor="ctr">
@@ -4570,14 +4570,14 @@
                         <a:buNone/>
                       </a:pPr>
                       <a:r>
-                        <a:rPr lang="en-US" sz="1000" i="1" dirty="0">
+                        <a:rPr lang="en-US" sz="950" i="1" dirty="0">
                           <a:solidFill>
                             <a:srgbClr val="1A1A2E"/>
                           </a:solidFill>
                         </a:rPr>
-                        <a:t>Documents obligatoires, entité inconnue : ni cas, ni question</a:t>
+                        <a:t>Erreur « Entité ID inconnue » prévue en test UI, alors que TC-011 dit la saisie libre impossible ; « anti double clic » absent de l'US</a:t>
                       </a:r>
-                      <a:endParaRPr lang="en-US" sz="1000" dirty="0"/>
+                      <a:endParaRPr lang="en-US" sz="950" dirty="0"/>
                     </a:p>
                   </a:txBody>
                   <a:tcPr marL="73152" marR="73152" marT="27432" marB="27432" anchor="ctr">
@@ -4631,14 +4631,14 @@
                         <a:buNone/>
                       </a:pPr>
                       <a:r>
-                        <a:rPr lang="en-US" sz="1000" dirty="0">
+                        <a:rPr lang="en-US" sz="950" dirty="0">
                           <a:solidFill>
                             <a:srgbClr val="1A1A2E"/>
                           </a:solidFill>
                         </a:rPr>
-                        <a:t>« N'ajoute aucune section »</a:t>
+                        <a:t>Structure fixe en 5 parties, aucune partie à ajouter (l. 207)</a:t>
                       </a:r>
-                      <a:endParaRPr lang="en-US" sz="1000" dirty="0"/>
+                      <a:endParaRPr lang="en-US" sz="950" dirty="0"/>
                     </a:p>
                   </a:txBody>
                   <a:tcPr marL="73152" marR="73152" marT="27432" marB="27432" anchor="ctr">
@@ -4692,14 +4692,14 @@
                         <a:buNone/>
                       </a:pPr>
                       <a:r>
-                        <a:rPr lang="en-US" sz="1000" dirty="0">
+                        <a:rPr lang="en-US" sz="950" dirty="0">
                           <a:solidFill>
                             <a:srgbClr val="00338D"/>
                           </a:solidFill>
                         </a:rPr>
-                        <a:t>Questions au PO au lieu de résultats inventés</a:t>
+                        <a:t>Une règle floue devient une question au PO</a:t>
                       </a:r>
-                      <a:endParaRPr lang="en-US" sz="1000" dirty="0"/>
+                      <a:endParaRPr lang="en-US" sz="950" dirty="0"/>
                     </a:p>
                   </a:txBody>
                   <a:tcPr marL="73152" marR="73152" marT="27432" marB="27432" anchor="ctr">
@@ -4745,7 +4745,7 @@
                   </a:tcPr>
                 </a:tc>
               </a:tr>
-              <a:tr h="502920">
+              <a:tr h="530352">
                 <a:tc>
                   <a:txBody>
                     <a:bodyPr/>
@@ -4755,14 +4755,14 @@
                         <a:buNone/>
                       </a:pPr>
                       <a:r>
-                        <a:rPr lang="en-US" sz="1000" b="1" dirty="0">
+                        <a:rPr lang="en-US" sz="950" b="1" dirty="0">
                           <a:solidFill>
                             <a:srgbClr val="1A1A2E"/>
                           </a:solidFill>
                         </a:rPr>
-                        <a:t>Des cas en double</a:t>
+                        <a:t>Deux cas pour un même résultat écrit</a:t>
                       </a:r>
-                      <a:endParaRPr lang="en-US" sz="1000" dirty="0"/>
+                      <a:endParaRPr lang="en-US" sz="950" dirty="0"/>
                     </a:p>
                   </a:txBody>
                   <a:tcPr marL="73152" marR="73152" marT="27432" marB="27432" anchor="ctr">
@@ -4816,14 +4816,14 @@
                         <a:buNone/>
                       </a:pPr>
                       <a:r>
-                        <a:rPr lang="en-US" sz="1000" i="1" dirty="0">
+                        <a:rPr lang="en-US" sz="950" i="1" dirty="0">
                           <a:solidFill>
                             <a:srgbClr val="1A1A2E"/>
                           </a:solidFill>
                         </a:rPr>
-                        <a:t>TC-013 et TC-014 : Reprise Oui et Non, même résultat</a:t>
+                        <a:t>TC-013 et TC-014 : Reprise Oui, puis Non, « la demande est créée » et redirigée ; l'US ne dit pas ce que change Reprise</a:t>
                       </a:r>
-                      <a:endParaRPr lang="en-US" sz="1000" dirty="0"/>
+                      <a:endParaRPr lang="en-US" sz="950" dirty="0"/>
                     </a:p>
                   </a:txBody>
                   <a:tcPr marL="73152" marR="73152" marT="27432" marB="27432" anchor="ctr">
@@ -4877,14 +4877,14 @@
                         <a:buNone/>
                       </a:pPr>
                       <a:r>
-                        <a:rPr lang="en-US" sz="1000" dirty="0">
+                        <a:rPr lang="en-US" sz="950" dirty="0">
                           <a:solidFill>
                             <a:srgbClr val="1A1A2E"/>
                           </a:solidFill>
                         </a:rPr>
                         <a:t>Aucune règle sur les doublons</a:t>
                       </a:r>
-                      <a:endParaRPr lang="en-US" sz="1000" dirty="0"/>
+                      <a:endParaRPr lang="en-US" sz="950" dirty="0"/>
                     </a:p>
                   </a:txBody>
                   <a:tcPr marL="73152" marR="73152" marT="27432" marB="27432" anchor="ctr">
@@ -4938,14 +4938,14 @@
                         <a:buNone/>
                       </a:pPr>
                       <a:r>
-                        <a:rPr lang="en-US" sz="1000" dirty="0">
+                        <a:rPr lang="en-US" sz="950" dirty="0">
                           <a:solidFill>
                             <a:srgbClr val="00338D"/>
                           </a:solidFill>
                         </a:rPr>
-                        <a:t>Un cas par résultat attendu distinct</a:t>
+                        <a:t>Un cas par résultat distinct</a:t>
                       </a:r>
-                      <a:endParaRPr lang="en-US" sz="1000" dirty="0"/>
+                      <a:endParaRPr lang="en-US" sz="950" dirty="0"/>
                     </a:p>
                   </a:txBody>
                   <a:tcPr marL="73152" marR="73152" marT="27432" marB="27432" anchor="ctr">
@@ -4991,7 +4991,7 @@
                   </a:tcPr>
                 </a:tc>
               </a:tr>
-              <a:tr h="502920">
+              <a:tr h="530352">
                 <a:tc>
                   <a:txBody>
                     <a:bodyPr/>
@@ -5001,14 +5001,14 @@
                         <a:buNone/>
                       </a:pPr>
                       <a:r>
-                        <a:rPr lang="en-US" sz="1000" b="1" dirty="0">
+                        <a:rPr lang="en-US" sz="950" b="1" dirty="0">
                           <a:solidFill>
                             <a:srgbClr val="1A1A2E"/>
                           </a:solidFill>
                         </a:rPr>
-                        <a:t>Chaque US isolée, publication automatique</a:t>
+                        <a:t>Publication automatique, cas « Fonctionnel » seulement</a:t>
                       </a:r>
-                      <a:endParaRPr lang="en-US" sz="1000" dirty="0"/>
+                      <a:endParaRPr lang="en-US" sz="950" dirty="0"/>
                     </a:p>
                   </a:txBody>
                   <a:tcPr marL="73152" marR="73152" marT="27432" marB="27432" anchor="ctr">
@@ -5062,14 +5062,14 @@
                         <a:buNone/>
                       </a:pPr>
                       <a:r>
-                        <a:rPr lang="en-US" sz="1000" i="1" dirty="0">
+                        <a:rPr lang="en-US" sz="950" i="1" dirty="0">
                           <a:solidFill>
                             <a:srgbClr val="1A1A2E"/>
                           </a:solidFill>
                         </a:rPr>
-                        <a:t>Ni Feature parente ni cas existants ; un plan créé par US</a:t>
+                        <a:t>Un plan « QC - &lt;titre de l'US&gt; » créé pour chaque US ; les cas UI, dont l'erreur « Entité ID inconnue », ne sont jamais créés</a:t>
                       </a:r>
-                      <a:endParaRPr lang="en-US" sz="1000" dirty="0"/>
+                      <a:endParaRPr lang="en-US" sz="950" dirty="0"/>
                     </a:p>
                   </a:txBody>
                   <a:tcPr marL="73152" marR="73152" marT="27432" marB="27432" anchor="ctr">
@@ -5123,14 +5123,14 @@
                         <a:buNone/>
                       </a:pPr>
                       <a:r>
-                        <a:rPr lang="en-US" sz="1000" dirty="0">
+                        <a:rPr lang="en-US" sz="950" dirty="0">
                           <a:solidFill>
                             <a:srgbClr val="1A1A2E"/>
                           </a:solidFill>
                         </a:rPr>
-                        <a:t>Ne lit que l'US ; publication obligatoire</a:t>
+                        <a:t>Création obligatoire dès qu'un ID est fourni (l. 51, 173) ; Fonctionnel seulement (l. 170)</a:t>
                       </a:r>
-                      <a:endParaRPr lang="en-US" sz="1000" dirty="0"/>
+                      <a:endParaRPr lang="en-US" sz="950" dirty="0"/>
                     </a:p>
                   </a:txBody>
                   <a:tcPr marL="73152" marR="73152" marT="27432" marB="27432" anchor="ctr">
@@ -5184,14 +5184,14 @@
                         <a:buNone/>
                       </a:pPr>
                       <a:r>
-                        <a:rPr lang="en-US" sz="1000" dirty="0">
+                        <a:rPr lang="en-US" sz="950" dirty="0">
                           <a:solidFill>
                             <a:srgbClr val="00338D"/>
                           </a:solidFill>
                         </a:rPr>
-                        <a:t>Contexte projet relu et enrichi après chaque US ; publication après accord</a:t>
+                        <a:t>Relecture, accord, plan existant</a:t>
                       </a:r>
-                      <a:endParaRPr lang="en-US" sz="1000" dirty="0"/>
+                      <a:endParaRPr lang="en-US" sz="950" dirty="0"/>
                     </a:p>
                   </a:txBody>
                   <a:tcPr marL="73152" marR="73152" marT="27432" marB="27432" anchor="ctr">
@@ -8322,7 +8322,7 @@
                   <a:schemeClr val="accent1"/>
                 </a:solidFill>
               </a:rPr>
-              <a:t>Même US « Créer une nouvelle demande ». Notre résultat est un premier essai, à rejouer avec le nouvel agent dans l'outil de l'équipe.</a:t>
+              <a:t>Même US. Notre résultat est un premier essai, à rejouer avec le nouvel agent dans l'outil de l'équipe.</a:t>
             </a:r>
             <a:endParaRPr lang="en-US" sz="1600" dirty="0"/>
           </a:p>
@@ -8351,9 +8351,9 @@
             <a:tbl>
               <a:tblPr/>
               <a:tblGrid>
-                <a:gridCol w="2286000"/>
-                <a:gridCol w="4206240"/>
-                <a:gridCol w="4572000"/>
+                <a:gridCol w="2194560"/>
+                <a:gridCol w="4389120"/>
+                <a:gridCol w="4480560"/>
               </a:tblGrid>
               <a:tr h="329184">
                 <a:tc>
@@ -8540,7 +8540,7 @@
                   </a:tcPr>
                 </a:tc>
               </a:tr>
-              <a:tr h="429768">
+              <a:tr h="438912">
                 <a:tc>
                   <a:txBody>
                     <a:bodyPr/>
@@ -8550,14 +8550,14 @@
                         <a:buNone/>
                       </a:pPr>
                       <a:r>
-                        <a:rPr lang="en-US" sz="1100" b="1" dirty="0">
+                        <a:rPr lang="en-US" sz="1050" b="1" dirty="0">
                           <a:solidFill>
                             <a:srgbClr val="1A1A2E"/>
                           </a:solidFill>
                         </a:rPr>
                         <a:t>Forme</a:t>
                       </a:r>
-                      <a:endParaRPr lang="en-US" sz="1100" dirty="0"/>
+                      <a:endParaRPr lang="en-US" sz="1050" dirty="0"/>
                     </a:p>
                   </a:txBody>
                   <a:tcPr marL="73152" marR="73152" marT="27432" marB="27432" anchor="ctr">
@@ -8611,14 +8611,14 @@
                         <a:buNone/>
                       </a:pPr>
                       <a:r>
-                        <a:rPr lang="en-US" sz="1100" dirty="0">
+                        <a:rPr lang="en-US" sz="1050" dirty="0">
                           <a:solidFill>
                             <a:srgbClr val="1A1A2E"/>
                           </a:solidFill>
                         </a:rPr>
-                        <a:t>Une ligne Given, When, Then en anglais par cas ; « Fonctionnel » partout</a:t>
+                        <a:t>Une ligne Given, When, Then par cas ; « Fonctionnel » partout (TC-001 à TC-014)</a:t>
                       </a:r>
-                      <a:endParaRPr lang="en-US" sz="1100" dirty="0"/>
+                      <a:endParaRPr lang="en-US" sz="1050" dirty="0"/>
                     </a:p>
                   </a:txBody>
                   <a:tcPr marL="73152" marR="73152" marT="27432" marB="27432" anchor="ctr">
@@ -8672,14 +8672,14 @@
                         <a:buNone/>
                       </a:pPr>
                       <a:r>
-                        <a:rPr lang="en-US" sz="1100" dirty="0">
+                        <a:rPr lang="en-US" sz="1050" dirty="0">
                           <a:solidFill>
                             <a:srgbClr val="00338D"/>
                           </a:solidFill>
                         </a:rPr>
                         <a:t>Gherkin en français, préconditions, actions et résultats sur des lignes séparées</a:t>
                       </a:r>
-                      <a:endParaRPr lang="en-US" sz="1100" dirty="0"/>
+                      <a:endParaRPr lang="en-US" sz="1050" dirty="0"/>
                     </a:p>
                   </a:txBody>
                   <a:tcPr marL="73152" marR="73152" marT="27432" marB="27432" anchor="ctr">
@@ -8725,7 +8725,7 @@
                   </a:tcPr>
                 </a:tc>
               </a:tr>
-              <a:tr h="429768">
+              <a:tr h="438912">
                 <a:tc>
                   <a:txBody>
                     <a:bodyPr/>
@@ -8735,14 +8735,14 @@
                         <a:buNone/>
                       </a:pPr>
                       <a:r>
-                        <a:rPr lang="en-US" sz="1100" b="1" dirty="0">
+                        <a:rPr lang="en-US" sz="1050" b="1" dirty="0">
                           <a:solidFill>
                             <a:srgbClr val="1A1A2E"/>
                           </a:solidFill>
                         </a:rPr>
                         <a:t>Préconditions</a:t>
                       </a:r>
-                      <a:endParaRPr lang="en-US" sz="1100" dirty="0"/>
+                      <a:endParaRPr lang="en-US" sz="1050" dirty="0"/>
                     </a:p>
                   </a:txBody>
                   <a:tcPr marL="73152" marR="73152" marT="27432" marB="27432" anchor="ctr">
@@ -8796,14 +8796,14 @@
                         <a:buNone/>
                       </a:pPr>
                       <a:r>
-                        <a:rPr lang="en-US" sz="1100" dirty="0">
+                        <a:rPr lang="en-US" sz="1050" dirty="0">
                           <a:solidFill>
                             <a:srgbClr val="1A1A2E"/>
                           </a:solidFill>
                         </a:rPr>
-                        <a:t>« Given le formulaire ouvert » : ni rôle, ni écran ; « une entité valide »</a:t>
+                        <a:t>« Given le formulaire de création ouvert » (TC-005) ; « une entité valide » (TC-013)</a:t>
                       </a:r>
-                      <a:endParaRPr lang="en-US" sz="1100" dirty="0"/>
+                      <a:endParaRPr lang="en-US" sz="1050" dirty="0"/>
                     </a:p>
                   </a:txBody>
                   <a:tcPr marL="73152" marR="73152" marT="27432" marB="27432" anchor="ctr">
@@ -8857,14 +8857,14 @@
                         <a:buNone/>
                       </a:pPr>
                       <a:r>
-                        <a:rPr lang="en-US" sz="1100" dirty="0">
+                        <a:rPr lang="en-US" sz="1050" dirty="0">
                           <a:solidFill>
                             <a:srgbClr val="00338D"/>
                           </a:solidFill>
                         </a:rPr>
-                        <a:t>Rôle et compte, écran de départ, entité et statut de sa demande, documents joints</a:t>
+                        <a:t>Rôle et compte, écran de départ, entité et statut de sa demande</a:t>
                       </a:r>
-                      <a:endParaRPr lang="en-US" sz="1100" dirty="0"/>
+                      <a:endParaRPr lang="en-US" sz="1050" dirty="0"/>
                     </a:p>
                   </a:txBody>
                   <a:tcPr marL="73152" marR="73152" marT="27432" marB="27432" anchor="ctr">
@@ -8910,7 +8910,7 @@
                   </a:tcPr>
                 </a:tc>
               </a:tr>
-              <a:tr h="429768">
+              <a:tr h="438912">
                 <a:tc>
                   <a:txBody>
                     <a:bodyPr/>
@@ -8920,14 +8920,14 @@
                         <a:buNone/>
                       </a:pPr>
                       <a:r>
-                        <a:rPr lang="en-US" sz="1100" b="1" dirty="0">
+                        <a:rPr lang="en-US" sz="1050" b="1" dirty="0">
                           <a:solidFill>
                             <a:srgbClr val="1A1A2E"/>
                           </a:solidFill>
                         </a:rPr>
-                        <a:t>Rôles</a:t>
+                        <a:t>Rôles (US §1)</a:t>
                       </a:r>
-                      <a:endParaRPr lang="en-US" sz="1100" dirty="0"/>
+                      <a:endParaRPr lang="en-US" sz="1050" dirty="0"/>
                     </a:p>
                   </a:txBody>
                   <a:tcPr marL="73152" marR="73152" marT="27432" marB="27432" anchor="ctr">
@@ -8981,14 +8981,14 @@
                         <a:buNone/>
                       </a:pPr>
                       <a:r>
-                        <a:rPr lang="en-US" sz="1100" dirty="0">
+                        <a:rPr lang="en-US" sz="1050" dirty="0">
                           <a:solidFill>
                             <a:srgbClr val="1A1A2E"/>
                           </a:solidFill>
                         </a:rPr>
-                        <a:t>« un rôle autre qu'Admin ou SuperAdmin »</a:t>
+                        <a:t>« un rôle autre qu'Admin ou SuperAdmin » (TC-003)</a:t>
                       </a:r>
-                      <a:endParaRPr lang="en-US" sz="1100" dirty="0"/>
+                      <a:endParaRPr lang="en-US" sz="1050" dirty="0"/>
                     </a:p>
                   </a:txBody>
                   <a:tcPr marL="73152" marR="73152" marT="27432" marB="27432" anchor="ctr">
@@ -9042,14 +9042,14 @@
                         <a:buNone/>
                       </a:pPr>
                       <a:r>
-                        <a:rPr lang="en-US" sz="1100" dirty="0">
+                        <a:rPr lang="en-US" sz="1050" dirty="0">
                           <a:solidFill>
                             <a:srgbClr val="00338D"/>
                           </a:solidFill>
                         </a:rPr>
                         <a:t>Rôle User nommé, avec son compte de test</a:t>
                       </a:r>
-                      <a:endParaRPr lang="en-US" sz="1100" dirty="0"/>
+                      <a:endParaRPr lang="en-US" sz="1050" dirty="0"/>
                     </a:p>
                   </a:txBody>
                   <a:tcPr marL="73152" marR="73152" marT="27432" marB="27432" anchor="ctr">
@@ -9095,7 +9095,7 @@
                   </a:tcPr>
                 </a:tc>
               </a:tr>
-              <a:tr h="429768">
+              <a:tr h="438912">
                 <a:tc>
                   <a:txBody>
                     <a:bodyPr/>
@@ -9105,14 +9105,14 @@
                         <a:buNone/>
                       </a:pPr>
                       <a:r>
-                        <a:rPr lang="en-US" sz="1100" b="1" dirty="0">
+                        <a:rPr lang="en-US" sz="1050" b="1" dirty="0">
                           <a:solidFill>
                             <a:srgbClr val="1A1A2E"/>
                           </a:solidFill>
                         </a:rPr>
-                        <a:t>Règle de validation : statut de l'entité</a:t>
+                        <a:t>Règle de validation (US §4)</a:t>
                       </a:r>
-                      <a:endParaRPr lang="en-US" sz="1100" dirty="0"/>
+                      <a:endParaRPr lang="en-US" sz="1050" dirty="0"/>
                     </a:p>
                   </a:txBody>
                   <a:tcPr marL="73152" marR="73152" marT="27432" marB="27432" anchor="ctr">
@@ -9166,14 +9166,14 @@
                         <a:buNone/>
                       </a:pPr>
                       <a:r>
-                        <a:rPr lang="en-US" sz="1100" dirty="0">
+                        <a:rPr lang="en-US" sz="1050" dirty="0">
                           <a:solidFill>
                             <a:srgbClr val="1A1A2E"/>
                           </a:solidFill>
                         </a:rPr>
-                        <a:t>1 cas sur 5 : entité sans demande</a:t>
+                        <a:t>1 situation sur 5 : entité sans demande (TC-012)</a:t>
                       </a:r>
-                      <a:endParaRPr lang="en-US" sz="1100" dirty="0"/>
+                      <a:endParaRPr lang="en-US" sz="1050" dirty="0"/>
                     </a:p>
                   </a:txBody>
                   <a:tcPr marL="73152" marR="73152" marT="27432" marB="27432" anchor="ctr">
@@ -9227,14 +9227,14 @@
                         <a:buNone/>
                       </a:pPr>
                       <a:r>
-                        <a:rPr lang="en-US" sz="1100" dirty="0">
+                        <a:rPr lang="en-US" sz="1050" dirty="0">
                           <a:solidFill>
                             <a:srgbClr val="00338D"/>
                           </a:solidFill>
                         </a:rPr>
-                        <a:t>5 cas : aucune demande et Validé acceptés ; En cours, Retard, Révision refusés</a:t>
+                        <a:t>5 situations : 2 acceptées, 3 refusées, avec vérification que la demande existante ne change pas</a:t>
                       </a:r>
-                      <a:endParaRPr lang="en-US" sz="1100" dirty="0"/>
+                      <a:endParaRPr lang="en-US" sz="1050" dirty="0"/>
                     </a:p>
                   </a:txBody>
                   <a:tcPr marL="73152" marR="73152" marT="27432" marB="27432" anchor="ctr">
@@ -9280,7 +9280,7 @@
                   </a:tcPr>
                 </a:tc>
               </a:tr>
-              <a:tr h="429768">
+              <a:tr h="438912">
                 <a:tc>
                   <a:txBody>
                     <a:bodyPr/>
@@ -9290,14 +9290,14 @@
                         <a:buNone/>
                       </a:pPr>
                       <a:r>
-                        <a:rPr lang="en-US" sz="1100" b="1" dirty="0">
+                        <a:rPr lang="en-US" sz="1050" b="1" dirty="0">
                           <a:solidFill>
                             <a:srgbClr val="1A1A2E"/>
                           </a:solidFill>
                         </a:rPr>
-                        <a:t>Champs obligatoires</a:t>
+                        <a:t>Champs obligatoires (US §3, §4)</a:t>
                       </a:r>
-                      <a:endParaRPr lang="en-US" sz="1100" dirty="0"/>
+                      <a:endParaRPr lang="en-US" sz="1050" dirty="0"/>
                     </a:p>
                   </a:txBody>
                   <a:tcPr marL="73152" marR="73152" marT="27432" marB="27432" anchor="ctr">
@@ -9351,14 +9351,14 @@
                         <a:buNone/>
                       </a:pPr>
                       <a:r>
-                        <a:rPr lang="en-US" sz="1100" dirty="0">
+                        <a:rPr lang="en-US" sz="1050" dirty="0">
                           <a:solidFill>
                             <a:srgbClr val="1A1A2E"/>
                           </a:solidFill>
                         </a:rPr>
-                        <a:t>1 cas générique</a:t>
+                        <a:t>1 cas générique (TC-015)</a:t>
                       </a:r>
-                      <a:endParaRPr lang="en-US" sz="1100" dirty="0"/>
+                      <a:endParaRPr lang="en-US" sz="1050" dirty="0"/>
                     </a:p>
                   </a:txBody>
                   <a:tcPr marL="73152" marR="73152" marT="27432" marB="27432" anchor="ctr">
@@ -9412,14 +9412,14 @@
                         <a:buNone/>
                       </a:pPr>
                       <a:r>
-                        <a:rPr lang="en-US" sz="1100" dirty="0">
+                        <a:rPr lang="en-US" sz="1050" dirty="0">
                           <a:solidFill>
                             <a:srgbClr val="00338D"/>
                           </a:solidFill>
                         </a:rPr>
                         <a:t>1 cas par champ, avec « aucune demande créée »</a:t>
                       </a:r>
-                      <a:endParaRPr lang="en-US" sz="1100" dirty="0"/>
+                      <a:endParaRPr lang="en-US" sz="1050" dirty="0"/>
                     </a:p>
                   </a:txBody>
                   <a:tcPr marL="73152" marR="73152" marT="27432" marB="27432" anchor="ctr">
@@ -9465,7 +9465,7 @@
                   </a:tcPr>
                 </a:tc>
               </a:tr>
-              <a:tr h="429768">
+              <a:tr h="438912">
                 <a:tc>
                   <a:txBody>
                     <a:bodyPr/>
@@ -9475,14 +9475,14 @@
                         <a:buNone/>
                       </a:pPr>
                       <a:r>
-                        <a:rPr lang="en-US" sz="1100" b="1" dirty="0">
+                        <a:rPr lang="en-US" sz="1050" b="1" dirty="0">
                           <a:solidFill>
                             <a:srgbClr val="1A1A2E"/>
                           </a:solidFill>
                         </a:rPr>
-                        <a:t>Bornes du millésime</a:t>
+                        <a:t>Ajouts absents de l'US</a:t>
                       </a:r>
-                      <a:endParaRPr lang="en-US" sz="1100" dirty="0"/>
+                      <a:endParaRPr lang="en-US" sz="1050" dirty="0"/>
                     </a:p>
                   </a:txBody>
                   <a:tcPr marL="73152" marR="73152" marT="27432" marB="27432" anchor="ctr">
@@ -9536,14 +9536,14 @@
                         <a:buNone/>
                       </a:pPr>
                       <a:r>
-                        <a:rPr lang="en-US" sz="1100" dirty="0">
+                        <a:rPr lang="en-US" sz="1050" dirty="0">
                           <a:solidFill>
                             <a:srgbClr val="1A1A2E"/>
                           </a:solidFill>
                         </a:rPr>
-                        <a:t>1 cas « de -20 à +10 »</a:t>
+                        <a:t>« Désactivation du bouton pendant l'envoi (anti double clic) »</a:t>
                       </a:r>
-                      <a:endParaRPr lang="en-US" sz="1100" dirty="0"/>
+                      <a:endParaRPr lang="en-US" sz="1050" dirty="0"/>
                     </a:p>
                   </a:txBody>
                   <a:tcPr marL="73152" marR="73152" marT="27432" marB="27432" anchor="ctr">
@@ -9597,14 +9597,14 @@
                         <a:buNone/>
                       </a:pPr>
                       <a:r>
-                        <a:rPr lang="en-US" sz="1100" dirty="0">
+                        <a:rPr lang="en-US" sz="1050" dirty="0">
                           <a:solidFill>
                             <a:srgbClr val="00338D"/>
                           </a:solidFill>
                         </a:rPr>
-                        <a:t>4 cas : les bornes et les valeurs juste au-delà</a:t>
+                        <a:t>Aucun</a:t>
                       </a:r>
-                      <a:endParaRPr lang="en-US" sz="1100" dirty="0"/>
+                      <a:endParaRPr lang="en-US" sz="1050" dirty="0"/>
                     </a:p>
                   </a:txBody>
                   <a:tcPr marL="73152" marR="73152" marT="27432" marB="27432" anchor="ctr">
@@ -9650,7 +9650,7 @@
                   </a:tcPr>
                 </a:tc>
               </a:tr>
-              <a:tr h="429768">
+              <a:tr h="438912">
                 <a:tc>
                   <a:txBody>
                     <a:bodyPr/>
@@ -9660,14 +9660,14 @@
                         <a:buNone/>
                       </a:pPr>
                       <a:r>
-                        <a:rPr lang="en-US" sz="1100" b="1" dirty="0">
+                        <a:rPr lang="en-US" sz="1050" b="1" dirty="0">
                           <a:solidFill>
                             <a:srgbClr val="1A1A2E"/>
                           </a:solidFill>
                         </a:rPr>
-                        <a:t>Doublons</a:t>
+                        <a:t>Reprise (US §3)</a:t>
                       </a:r>
-                      <a:endParaRPr lang="en-US" sz="1100" dirty="0"/>
+                      <a:endParaRPr lang="en-US" sz="1050" dirty="0"/>
                     </a:p>
                   </a:txBody>
                   <a:tcPr marL="73152" marR="73152" marT="27432" marB="27432" anchor="ctr">
@@ -9721,14 +9721,14 @@
                         <a:buNone/>
                       </a:pPr>
                       <a:r>
-                        <a:rPr lang="en-US" sz="1100" dirty="0">
+                        <a:rPr lang="en-US" sz="1050" dirty="0">
                           <a:solidFill>
                             <a:srgbClr val="1A1A2E"/>
                           </a:solidFill>
                         </a:rPr>
-                        <a:t>Reprise Oui et Reprise Non : même résultat</a:t>
+                        <a:t>TC-013 et TC-014 : même résultat écrit pour Oui et Non</a:t>
                       </a:r>
-                      <a:endParaRPr lang="en-US" sz="1100" dirty="0"/>
+                      <a:endParaRPr lang="en-US" sz="1050" dirty="0"/>
                     </a:p>
                   </a:txBody>
                   <a:tcPr marL="73152" marR="73152" marT="27432" marB="27432" anchor="ctr">
@@ -9782,14 +9782,14 @@
                         <a:buNone/>
                       </a:pPr>
                       <a:r>
-                        <a:rPr lang="en-US" sz="1100" dirty="0">
+                        <a:rPr lang="en-US" sz="1050" dirty="0">
                           <a:solidFill>
                             <a:srgbClr val="00338D"/>
                           </a:solidFill>
                         </a:rPr>
-                        <a:t>Aucun</a:t>
+                        <a:t>Affichage de Reprise vérifié ; son effet, non décrit par l'US, n'est pas inventé</a:t>
                       </a:r>
-                      <a:endParaRPr lang="en-US" sz="1100" dirty="0"/>
+                      <a:endParaRPr lang="en-US" sz="1050" dirty="0"/>
                     </a:p>
                   </a:txBody>
                   <a:tcPr marL="73152" marR="73152" marT="27432" marB="27432" anchor="ctr">
@@ -9835,7 +9835,7 @@
                   </a:tcPr>
                 </a:tc>
               </a:tr>
-              <a:tr h="429768">
+              <a:tr h="438912">
                 <a:tc>
                   <a:txBody>
                     <a:bodyPr/>
@@ -9845,14 +9845,14 @@
                         <a:buNone/>
                       </a:pPr>
                       <a:r>
-                        <a:rPr lang="en-US" sz="1100" b="1" dirty="0">
+                        <a:rPr lang="en-US" sz="1050" b="1" dirty="0">
                           <a:solidFill>
                             <a:srgbClr val="1A1A2E"/>
                           </a:solidFill>
                         </a:rPr>
                         <a:t>Ce que l'US ne dit pas</a:t>
                       </a:r>
-                      <a:endParaRPr lang="en-US" sz="1100" dirty="0"/>
+                      <a:endParaRPr lang="en-US" sz="1050" dirty="0"/>
                     </a:p>
                   </a:txBody>
                   <a:tcPr marL="73152" marR="73152" marT="27432" marB="27432" anchor="ctr">
@@ -9906,14 +9906,14 @@
                         <a:buNone/>
                       </a:pPr>
                       <a:r>
-                        <a:rPr lang="en-US" sz="1100" dirty="0">
+                        <a:rPr lang="en-US" sz="1050" dirty="0">
                           <a:solidFill>
                             <a:srgbClr val="1A1A2E"/>
                           </a:solidFill>
                         </a:rPr>
-                        <a:t>Aucune question ; la contradiction sur l'entité inconnue n'est pas vue</a:t>
+                        <a:t>Aucune question ; l'erreur « Entité ID inconnue » est prévue en test UI sans relever que la saisie libre est impossible (TC-011)</a:t>
                       </a:r>
-                      <a:endParaRPr lang="en-US" sz="1100" dirty="0"/>
+                      <a:endParaRPr lang="en-US" sz="1050" dirty="0"/>
                     </a:p>
                   </a:txBody>
                   <a:tcPr marL="73152" marR="73152" marT="27432" marB="27432" anchor="ctr">
@@ -9967,14 +9967,14 @@
                         <a:buNone/>
                       </a:pPr>
                       <a:r>
-                        <a:rPr lang="en-US" sz="1100" dirty="0">
+                        <a:rPr lang="en-US" sz="1050" dirty="0">
                           <a:solidFill>
                             <a:srgbClr val="00338D"/>
                           </a:solidFill>
                         </a:rPr>
-                        <a:t>9 questions au PO, dont 2 bloquantes (entité inconnue, documents)</a:t>
+                        <a:t>9 questions au PO, dont 2 bloquantes : Entité ID inconnue (§3), documents obligatoires (§4)</a:t>
                       </a:r>
-                      <a:endParaRPr lang="en-US" sz="1100" dirty="0"/>
+                      <a:endParaRPr lang="en-US" sz="1050" dirty="0"/>
                     </a:p>
                   </a:txBody>
                   <a:tcPr marL="73152" marR="73152" marT="27432" marB="27432" anchor="ctr">
@@ -10020,7 +10020,7 @@
                   </a:tcPr>
                 </a:tc>
               </a:tr>
-              <a:tr h="429768">
+              <a:tr h="438912">
                 <a:tc>
                   <a:txBody>
                     <a:bodyPr/>
@@ -10030,14 +10030,14 @@
                         <a:buNone/>
                       </a:pPr>
                       <a:r>
-                        <a:rPr lang="en-US" sz="1100" b="1" dirty="0">
+                        <a:rPr lang="en-US" sz="1050" b="1" dirty="0">
                           <a:solidFill>
                             <a:srgbClr val="1A1A2E"/>
                           </a:solidFill>
                         </a:rPr>
                         <a:t>Volume</a:t>
                       </a:r>
-                      <a:endParaRPr lang="en-US" sz="1100" dirty="0"/>
+                      <a:endParaRPr lang="en-US" sz="1050" dirty="0"/>
                     </a:p>
                   </a:txBody>
                   <a:tcPr marL="73152" marR="73152" marT="27432" marB="27432" anchor="ctr">
@@ -10091,14 +10091,14 @@
                         <a:buNone/>
                       </a:pPr>
                       <a:r>
-                        <a:rPr lang="en-US" sz="1100" dirty="0">
+                        <a:rPr lang="en-US" sz="1050" dirty="0">
                           <a:solidFill>
                             <a:srgbClr val="1A1A2E"/>
                           </a:solidFill>
                         </a:rPr>
                         <a:t>Au moins 15 cas</a:t>
                       </a:r>
-                      <a:endParaRPr lang="en-US" sz="1100" dirty="0"/>
+                      <a:endParaRPr lang="en-US" sz="1050" dirty="0"/>
                     </a:p>
                   </a:txBody>
                   <a:tcPr marL="73152" marR="73152" marT="27432" marB="27432" anchor="ctr">
@@ -10152,14 +10152,14 @@
                         <a:buNone/>
                       </a:pPr>
                       <a:r>
-                        <a:rPr lang="en-US" sz="1100" dirty="0">
+                        <a:rPr lang="en-US" sz="1050" dirty="0">
                           <a:solidFill>
                             <a:srgbClr val="00338D"/>
                           </a:solidFill>
                         </a:rPr>
                         <a:t>23 lignes exécutables, chacune avec sa raison</a:t>
                       </a:r>
-                      <a:endParaRPr lang="en-US" sz="1100" dirty="0"/>
+                      <a:endParaRPr lang="en-US" sz="1050" dirty="0"/>
                     </a:p>
                   </a:txBody>
                   <a:tcPr marL="73152" marR="73152" marT="27432" marB="27432" anchor="ctr">
@@ -10358,7 +10358,7 @@
                   <a:schemeClr val="tx2"/>
                 </a:solidFill>
               </a:rPr>
-              <a:t>La règle de validation : 5 situations, 1 seule testée</a:t>
+              <a:t>La règle de validation : 5 situations, 1 seule dans les cas actuels</a:t>
             </a:r>
             <a:endParaRPr lang="en-US" sz="2800" dirty="0"/>
           </a:p>
@@ -10396,9 +10396,67 @@
                   <a:schemeClr val="accent1"/>
                 </a:solidFill>
               </a:rPr>
-              <a:t>Avant de créer une demande, le système regarde si l'entité a déjà une demande, et dans quel statut.</a:t>
+              <a:t>US 417829, §4 Validation, 4e point : ce que vérifie le système au clic sur « Valider la création ».</a:t>
             </a:r>
             <a:endParaRPr lang="en-US" sz="1600" dirty="0"/>
+          </a:p>
+        </p:txBody>
+      </p:sp>
+      <p:sp>
+        <p:nvSpPr>
+          <p:cNvPr id="4" name="card"/>
+          <p:cNvSpPr/>
+          <p:nvPr/>
+        </p:nvSpPr>
+        <p:spPr>
+          <a:xfrm>
+            <a:off x="548640" y="1536192"/>
+            <a:ext cx="11064240" cy="566928"/>
+          </a:xfrm>
+          <a:prstGeom prst="roundRect">
+            <a:avLst>
+              <a:gd name="adj" fmla="val 16129"/>
+            </a:avLst>
+          </a:prstGeom>
+          <a:solidFill>
+            <a:schemeClr val="bg2"/>
+          </a:solidFill>
+          <a:ln/>
+        </p:spPr>
+      </p:sp>
+      <p:sp>
+        <p:nvSpPr>
+          <p:cNvPr id="5" name="Text 3"/>
+          <p:cNvSpPr txBox="1"/>
+          <p:nvPr/>
+        </p:nvSpPr>
+        <p:spPr>
+          <a:xfrm>
+            <a:off x="731520" y="1536192"/>
+            <a:ext cx="10698480" cy="566928"/>
+          </a:xfrm>
+          <a:prstGeom prst="rect">
+            <a:avLst/>
+          </a:prstGeom>
+          <a:noFill/>
+          <a:ln/>
+        </p:spPr>
+        <p:txBody>
+          <a:bodyPr wrap="square" lIns="0" tIns="0" rIns="0" bIns="0" rtlCol="0" anchor="ctr"/>
+          <a:lstStyle/>
+          <a:p>
+            <a:pPr indent="0" marL="0">
+              <a:buNone/>
+            </a:pPr>
+            <a:r>
+              <a:rPr lang="en-US" sz="1200" i="1" dirty="0">
+                <a:solidFill>
+                  <a:srgbClr val="00338D"/>
+                </a:solidFill>
+              </a:rPr>
+              <a:t>« une création de demande possible avec une entité ID qui n'a pas encore de statut ou bien un statut validé (erreur si une entité ID a déjà une demande en statut : en cours, retard ou révision) »</a:t>
+            </a:r>
+            <a:endParaRPr lang="en-US" sz="1200" dirty="0"/>
           </a:p>
         </p:txBody>
       </p:sp>
@@ -10417,7 +10475,7 @@
           </p:nvPr>
         </p:nvGraphicFramePr>
         <p:xfrm>
-          <a:off x="548640" y="1572768"/>
+          <a:off x="548640" y="2212848"/>
           <a:ext cx="11064240" cy="914400"/>
         </p:xfrm>
         <a:graphic>
@@ -10425,12 +10483,12 @@
             <a:tbl>
               <a:tblPr/>
               <a:tblGrid>
-                <a:gridCol w="3108960"/>
                 <a:gridCol w="3017520"/>
-                <a:gridCol w="2103120"/>
-                <a:gridCol w="2834640"/>
+                <a:gridCol w="2011680"/>
+                <a:gridCol w="3291840"/>
+                <a:gridCol w="2743200"/>
               </a:tblGrid>
-              <a:tr h="365760">
+              <a:tr h="347472">
                 <a:tc>
                   <a:txBody>
                     <a:bodyPr/>
@@ -10567,7 +10625,7 @@
                             <a:srgbClr val="FFFFFF"/>
                           </a:solidFill>
                         </a:rPr>
-                        <a:t>Agent actuel</a:t>
+                        <a:t>Agent actuel (TC-001 à TC-015)</a:t>
                       </a:r>
                       <a:endParaRPr lang="en-US" sz="1200" dirty="0"/>
                     </a:p>
@@ -10676,7 +10734,7 @@
                   </a:tcPr>
                 </a:tc>
               </a:tr>
-              <a:tr h="457200">
+              <a:tr h="384048">
                 <a:tc>
                   <a:txBody>
                     <a:bodyPr/>
@@ -10686,14 +10744,14 @@
                         <a:buNone/>
                       </a:pPr>
                       <a:r>
-                        <a:rPr lang="en-US" sz="1250" b="1" dirty="0">
+                        <a:rPr lang="en-US" sz="1150" b="1" dirty="0">
                           <a:solidFill>
                             <a:srgbClr val="1A1A2E"/>
                           </a:solidFill>
                         </a:rPr>
-                        <a:t>L'entité n'a aucune demande</a:t>
+                        <a:t>Entité sans statut</a:t>
                       </a:r>
-                      <a:endParaRPr lang="en-US" sz="1250" dirty="0"/>
+                      <a:endParaRPr lang="en-US" sz="1150" dirty="0"/>
                     </a:p>
                   </a:txBody>
                   <a:tcPr marL="91440" marR="91440" marT="27432" marB="27432" anchor="ctr">
@@ -10747,14 +10805,14 @@
                         <a:buNone/>
                       </a:pPr>
                       <a:r>
-                        <a:rPr lang="en-US" sz="1250" dirty="0">
+                        <a:rPr lang="en-US" sz="1150" dirty="0">
                           <a:solidFill>
                             <a:srgbClr val="1A1A2E"/>
                           </a:solidFill>
                         </a:rPr>
-                        <a:t>Création acceptée</a:t>
+                        <a:t>Création possible</a:t>
                       </a:r>
-                      <a:endParaRPr lang="en-US" sz="1250" dirty="0"/>
+                      <a:endParaRPr lang="en-US" sz="1150" dirty="0"/>
                     </a:p>
                   </a:txBody>
                   <a:tcPr marL="91440" marR="91440" marT="27432" marB="27432" anchor="ctr">
@@ -10808,14 +10866,14 @@
                         <a:buNone/>
                       </a:pPr>
                       <a:r>
-                        <a:rPr lang="en-US" sz="1250" b="1" dirty="0">
+                        <a:rPr lang="en-US" sz="1150" b="1" dirty="0">
                           <a:solidFill>
                             <a:srgbClr val="2E7D4F"/>
                           </a:solidFill>
                         </a:rPr>
-                        <a:t>Testé (TC-012)</a:t>
+                        <a:t>Trouvé (TC-012 : « entité sans demande existante »)</a:t>
                       </a:r>
-                      <a:endParaRPr lang="en-US" sz="1250" dirty="0"/>
+                      <a:endParaRPr lang="en-US" sz="1150" dirty="0"/>
                     </a:p>
                   </a:txBody>
                   <a:tcPr marL="91440" marR="91440" marT="27432" marB="27432" anchor="ctr">
@@ -10869,14 +10927,14 @@
                         <a:buNone/>
                       </a:pPr>
                       <a:r>
-                        <a:rPr lang="en-US" sz="1250" b="1" dirty="0">
+                        <a:rPr lang="en-US" sz="1150" b="1" dirty="0">
                           <a:solidFill>
                             <a:srgbClr val="2E7D4F"/>
                           </a:solidFill>
                         </a:rPr>
                         <a:t>Testé</a:t>
                       </a:r>
-                      <a:endParaRPr lang="en-US" sz="1250" dirty="0"/>
+                      <a:endParaRPr lang="en-US" sz="1150" dirty="0"/>
                     </a:p>
                   </a:txBody>
                   <a:tcPr marL="91440" marR="91440" marT="27432" marB="27432" anchor="ctr">
@@ -10922,7 +10980,7 @@
                   </a:tcPr>
                 </a:tc>
               </a:tr>
-              <a:tr h="457200">
+              <a:tr h="384048">
                 <a:tc>
                   <a:txBody>
                     <a:bodyPr/>
@@ -10932,14 +10990,14 @@
                         <a:buNone/>
                       </a:pPr>
                       <a:r>
-                        <a:rPr lang="en-US" sz="1250" b="1" dirty="0">
+                        <a:rPr lang="en-US" sz="1150" b="1" dirty="0">
                           <a:solidFill>
                             <a:srgbClr val="1A1A2E"/>
                           </a:solidFill>
                         </a:rPr>
-                        <a:t>Elle a une demande Validée</a:t>
+                        <a:t>Entité au statut validé</a:t>
                       </a:r>
-                      <a:endParaRPr lang="en-US" sz="1250" dirty="0"/>
+                      <a:endParaRPr lang="en-US" sz="1150" dirty="0"/>
                     </a:p>
                   </a:txBody>
                   <a:tcPr marL="91440" marR="91440" marT="27432" marB="27432" anchor="ctr">
@@ -10993,14 +11051,14 @@
                         <a:buNone/>
                       </a:pPr>
                       <a:r>
-                        <a:rPr lang="en-US" sz="1250" dirty="0">
+                        <a:rPr lang="en-US" sz="1150" dirty="0">
                           <a:solidFill>
                             <a:srgbClr val="1A1A2E"/>
                           </a:solidFill>
                         </a:rPr>
-                        <a:t>Création acceptée</a:t>
+                        <a:t>Création possible</a:t>
                       </a:r>
-                      <a:endParaRPr lang="en-US" sz="1250" dirty="0"/>
+                      <a:endParaRPr lang="en-US" sz="1150" dirty="0"/>
                     </a:p>
                   </a:txBody>
                   <a:tcPr marL="91440" marR="91440" marT="27432" marB="27432" anchor="ctr">
@@ -11054,14 +11112,14 @@
                         <a:buNone/>
                       </a:pPr>
                       <a:r>
-                        <a:rPr lang="en-US" sz="1250" b="1" dirty="0">
+                        <a:rPr lang="en-US" sz="1150" b="1" dirty="0">
                           <a:solidFill>
                             <a:srgbClr val="B23B3B"/>
                           </a:solidFill>
                         </a:rPr>
-                        <a:t>Non testé</a:t>
+                        <a:t>Non trouvé</a:t>
                       </a:r>
-                      <a:endParaRPr lang="en-US" sz="1250" dirty="0"/>
+                      <a:endParaRPr lang="en-US" sz="1150" dirty="0"/>
                     </a:p>
                   </a:txBody>
                   <a:tcPr marL="91440" marR="91440" marT="27432" marB="27432" anchor="ctr">
@@ -11115,14 +11173,14 @@
                         <a:buNone/>
                       </a:pPr>
                       <a:r>
-                        <a:rPr lang="en-US" sz="1250" b="1" dirty="0">
+                        <a:rPr lang="en-US" sz="1150" b="1" dirty="0">
                           <a:solidFill>
                             <a:srgbClr val="2E7D4F"/>
                           </a:solidFill>
                         </a:rPr>
                         <a:t>Testé</a:t>
                       </a:r>
-                      <a:endParaRPr lang="en-US" sz="1250" dirty="0"/>
+                      <a:endParaRPr lang="en-US" sz="1150" dirty="0"/>
                     </a:p>
                   </a:txBody>
                   <a:tcPr marL="91440" marR="91440" marT="27432" marB="27432" anchor="ctr">
@@ -11168,7 +11226,7 @@
                   </a:tcPr>
                 </a:tc>
               </a:tr>
-              <a:tr h="457200">
+              <a:tr h="384048">
                 <a:tc>
                   <a:txBody>
                     <a:bodyPr/>
@@ -11178,14 +11236,14 @@
                         <a:buNone/>
                       </a:pPr>
                       <a:r>
-                        <a:rPr lang="en-US" sz="1250" b="1" dirty="0">
+                        <a:rPr lang="en-US" sz="1150" b="1" dirty="0">
                           <a:solidFill>
                             <a:srgbClr val="1A1A2E"/>
                           </a:solidFill>
                         </a:rPr>
-                        <a:t>Elle a une demande En cours</a:t>
+                        <a:t>Entité avec une demande en cours</a:t>
                       </a:r>
-                      <a:endParaRPr lang="en-US" sz="1250" dirty="0"/>
+                      <a:endParaRPr lang="en-US" sz="1150" dirty="0"/>
                     </a:p>
                   </a:txBody>
                   <a:tcPr marL="91440" marR="91440" marT="27432" marB="27432" anchor="ctr">
@@ -11239,14 +11297,14 @@
                         <a:buNone/>
                       </a:pPr>
                       <a:r>
-                        <a:rPr lang="en-US" sz="1250" dirty="0">
+                        <a:rPr lang="en-US" sz="1150" dirty="0">
                           <a:solidFill>
                             <a:srgbClr val="1A1A2E"/>
                           </a:solidFill>
                         </a:rPr>
-                        <a:t>Création refusée, message d'erreur</a:t>
+                        <a:t>Erreur</a:t>
                       </a:r>
-                      <a:endParaRPr lang="en-US" sz="1250" dirty="0"/>
+                      <a:endParaRPr lang="en-US" sz="1150" dirty="0"/>
                     </a:p>
                   </a:txBody>
                   <a:tcPr marL="91440" marR="91440" marT="27432" marB="27432" anchor="ctr">
@@ -11300,14 +11358,14 @@
                         <a:buNone/>
                       </a:pPr>
                       <a:r>
-                        <a:rPr lang="en-US" sz="1250" b="1" dirty="0">
+                        <a:rPr lang="en-US" sz="1150" b="1" dirty="0">
                           <a:solidFill>
                             <a:srgbClr val="B23B3B"/>
                           </a:solidFill>
                         </a:rPr>
-                        <a:t>Non testé</a:t>
+                        <a:t>Non trouvé</a:t>
                       </a:r>
-                      <a:endParaRPr lang="en-US" sz="1250" dirty="0"/>
+                      <a:endParaRPr lang="en-US" sz="1150" dirty="0"/>
                     </a:p>
                   </a:txBody>
                   <a:tcPr marL="91440" marR="91440" marT="27432" marB="27432" anchor="ctr">
@@ -11361,14 +11419,14 @@
                         <a:buNone/>
                       </a:pPr>
                       <a:r>
-                        <a:rPr lang="en-US" sz="1250" b="1" dirty="0">
+                        <a:rPr lang="en-US" sz="1150" b="1" dirty="0">
                           <a:solidFill>
                             <a:srgbClr val="2E7D4F"/>
                           </a:solidFill>
                         </a:rPr>
                         <a:t>Testé, demande existante inchangée</a:t>
                       </a:r>
-                      <a:endParaRPr lang="en-US" sz="1250" dirty="0"/>
+                      <a:endParaRPr lang="en-US" sz="1150" dirty="0"/>
                     </a:p>
                   </a:txBody>
                   <a:tcPr marL="91440" marR="91440" marT="27432" marB="27432" anchor="ctr">
@@ -11414,7 +11472,7 @@
                   </a:tcPr>
                 </a:tc>
               </a:tr>
-              <a:tr h="457200">
+              <a:tr h="384048">
                 <a:tc>
                   <a:txBody>
                     <a:bodyPr/>
@@ -11424,14 +11482,14 @@
                         <a:buNone/>
                       </a:pPr>
                       <a:r>
-                        <a:rPr lang="en-US" sz="1250" b="1" dirty="0">
+                        <a:rPr lang="en-US" sz="1150" b="1" dirty="0">
                           <a:solidFill>
                             <a:srgbClr val="1A1A2E"/>
                           </a:solidFill>
                         </a:rPr>
-                        <a:t>Elle a une demande en Retard</a:t>
+                        <a:t>Entité avec une demande en retard</a:t>
                       </a:r>
-                      <a:endParaRPr lang="en-US" sz="1250" dirty="0"/>
+                      <a:endParaRPr lang="en-US" sz="1150" dirty="0"/>
                     </a:p>
                   </a:txBody>
                   <a:tcPr marL="91440" marR="91440" marT="27432" marB="27432" anchor="ctr">
@@ -11485,14 +11543,14 @@
                         <a:buNone/>
                       </a:pPr>
                       <a:r>
-                        <a:rPr lang="en-US" sz="1250" dirty="0">
+                        <a:rPr lang="en-US" sz="1150" dirty="0">
                           <a:solidFill>
                             <a:srgbClr val="1A1A2E"/>
                           </a:solidFill>
                         </a:rPr>
-                        <a:t>Création refusée, message d'erreur</a:t>
+                        <a:t>Erreur</a:t>
                       </a:r>
-                      <a:endParaRPr lang="en-US" sz="1250" dirty="0"/>
+                      <a:endParaRPr lang="en-US" sz="1150" dirty="0"/>
                     </a:p>
                   </a:txBody>
                   <a:tcPr marL="91440" marR="91440" marT="27432" marB="27432" anchor="ctr">
@@ -11546,14 +11604,14 @@
                         <a:buNone/>
                       </a:pPr>
                       <a:r>
-                        <a:rPr lang="en-US" sz="1250" b="1" dirty="0">
+                        <a:rPr lang="en-US" sz="1150" b="1" dirty="0">
                           <a:solidFill>
                             <a:srgbClr val="B23B3B"/>
                           </a:solidFill>
                         </a:rPr>
-                        <a:t>Non testé</a:t>
+                        <a:t>Non trouvé</a:t>
                       </a:r>
-                      <a:endParaRPr lang="en-US" sz="1250" dirty="0"/>
+                      <a:endParaRPr lang="en-US" sz="1150" dirty="0"/>
                     </a:p>
                   </a:txBody>
                   <a:tcPr marL="91440" marR="91440" marT="27432" marB="27432" anchor="ctr">
@@ -11607,14 +11665,14 @@
                         <a:buNone/>
                       </a:pPr>
                       <a:r>
-                        <a:rPr lang="en-US" sz="1250" b="1" dirty="0">
+                        <a:rPr lang="en-US" sz="1150" b="1" dirty="0">
                           <a:solidFill>
                             <a:srgbClr val="2E7D4F"/>
                           </a:solidFill>
                         </a:rPr>
                         <a:t>Testé, demande existante inchangée</a:t>
                       </a:r>
-                      <a:endParaRPr lang="en-US" sz="1250" dirty="0"/>
+                      <a:endParaRPr lang="en-US" sz="1150" dirty="0"/>
                     </a:p>
                   </a:txBody>
                   <a:tcPr marL="91440" marR="91440" marT="27432" marB="27432" anchor="ctr">
@@ -11660,7 +11718,7 @@
                   </a:tcPr>
                 </a:tc>
               </a:tr>
-              <a:tr h="457200">
+              <a:tr h="384048">
                 <a:tc>
                   <a:txBody>
                     <a:bodyPr/>
@@ -11670,14 +11728,14 @@
                         <a:buNone/>
                       </a:pPr>
                       <a:r>
-                        <a:rPr lang="en-US" sz="1250" b="1" dirty="0">
+                        <a:rPr lang="en-US" sz="1150" b="1" dirty="0">
                           <a:solidFill>
                             <a:srgbClr val="1A1A2E"/>
                           </a:solidFill>
                         </a:rPr>
-                        <a:t>Elle a une demande en Révision</a:t>
+                        <a:t>Entité avec une demande en révision</a:t>
                       </a:r>
-                      <a:endParaRPr lang="en-US" sz="1250" dirty="0"/>
+                      <a:endParaRPr lang="en-US" sz="1150" dirty="0"/>
                     </a:p>
                   </a:txBody>
                   <a:tcPr marL="91440" marR="91440" marT="27432" marB="27432" anchor="ctr">
@@ -11731,14 +11789,14 @@
                         <a:buNone/>
                       </a:pPr>
                       <a:r>
-                        <a:rPr lang="en-US" sz="1250" dirty="0">
+                        <a:rPr lang="en-US" sz="1150" dirty="0">
                           <a:solidFill>
                             <a:srgbClr val="1A1A2E"/>
                           </a:solidFill>
                         </a:rPr>
-                        <a:t>Création refusée, message d'erreur</a:t>
+                        <a:t>Erreur</a:t>
                       </a:r>
-                      <a:endParaRPr lang="en-US" sz="1250" dirty="0"/>
+                      <a:endParaRPr lang="en-US" sz="1150" dirty="0"/>
                     </a:p>
                   </a:txBody>
                   <a:tcPr marL="91440" marR="91440" marT="27432" marB="27432" anchor="ctr">
@@ -11792,14 +11850,14 @@
                         <a:buNone/>
                       </a:pPr>
                       <a:r>
-                        <a:rPr lang="en-US" sz="1250" b="1" dirty="0">
+                        <a:rPr lang="en-US" sz="1150" b="1" dirty="0">
                           <a:solidFill>
                             <a:srgbClr val="B23B3B"/>
                           </a:solidFill>
                         </a:rPr>
-                        <a:t>Non testé</a:t>
+                        <a:t>Non trouvé</a:t>
                       </a:r>
-                      <a:endParaRPr lang="en-US" sz="1250" dirty="0"/>
+                      <a:endParaRPr lang="en-US" sz="1150" dirty="0"/>
                     </a:p>
                   </a:txBody>
                   <a:tcPr marL="91440" marR="91440" marT="27432" marB="27432" anchor="ctr">
@@ -11853,14 +11911,14 @@
                         <a:buNone/>
                       </a:pPr>
                       <a:r>
-                        <a:rPr lang="en-US" sz="1250" b="1" dirty="0">
+                        <a:rPr lang="en-US" sz="1150" b="1" dirty="0">
                           <a:solidFill>
                             <a:srgbClr val="2E7D4F"/>
                           </a:solidFill>
                         </a:rPr>
                         <a:t>Testé, demande existante inchangée</a:t>
                       </a:r>
-                      <a:endParaRPr lang="en-US" sz="1250" dirty="0"/>
+                      <a:endParaRPr lang="en-US" sz="1150" dirty="0"/>
                     </a:p>
                   </a:txBody>
                   <a:tcPr marL="91440" marR="91440" marT="27432" marB="27432" anchor="ctr">
@@ -11912,18 +11970,18 @@
       </p:graphicFrame>
       <p:sp>
         <p:nvSpPr>
-          <p:cNvPr id="5" name="card"/>
+          <p:cNvPr id="7" name="card"/>
           <p:cNvSpPr/>
           <p:nvPr/>
         </p:nvSpPr>
         <p:spPr>
           <a:xfrm>
-            <a:off x="548640" y="4526280"/>
-            <a:ext cx="3931920" cy="1371600"/>
+            <a:off x="548640" y="4572000"/>
+            <a:ext cx="3931920" cy="1417320"/>
           </a:xfrm>
           <a:prstGeom prst="roundRect">
             <a:avLst>
-              <a:gd name="adj" fmla="val 6667"/>
+              <a:gd name="adj" fmla="val 6452"/>
             </a:avLst>
           </a:prstGeom>
           <a:solidFill>
@@ -11934,14 +11992,14 @@
       </p:sp>
       <p:sp>
         <p:nvSpPr>
-          <p:cNvPr id="6" name="Text 3"/>
+          <p:cNvPr id="8" name="Text 5"/>
           <p:cNvSpPr txBox="1"/>
           <p:nvPr/>
         </p:nvSpPr>
         <p:spPr>
           <a:xfrm>
-            <a:off x="777240" y="4526280"/>
-            <a:ext cx="3566160" cy="1371600"/>
+            <a:off x="777240" y="4572000"/>
+            <a:ext cx="3566160" cy="1417320"/>
           </a:xfrm>
           <a:prstGeom prst="rect">
             <a:avLst/>
@@ -11976,7 +12034,7 @@
                   <a:schemeClr val="bg1"/>
                 </a:solidFill>
               </a:rPr>
-              <a:t>Les trois refus empêchent de créer deux demandes en parallèle pour la même entité. Si cette règle casse, aucun cas actuel ne le verra.</a:t>
+              <a:t>Si cette règle casse, une entité reçoit une nouvelle demande alors qu'une autre est en cours, en retard ou en révision. Aucun des cas TC-001 à TC-015 ne le verrait.</a:t>
             </a:r>
             <a:endParaRPr lang="en-US" sz="1200" dirty="0"/>
           </a:p>
@@ -11984,18 +12042,18 @@
       </p:sp>
       <p:sp>
         <p:nvSpPr>
-          <p:cNvPr id="7" name="card"/>
+          <p:cNvPr id="9" name="card"/>
           <p:cNvSpPr/>
           <p:nvPr/>
         </p:nvSpPr>
         <p:spPr>
           <a:xfrm>
-            <a:off x="4663440" y="4526280"/>
-            <a:ext cx="6949440" cy="1371600"/>
+            <a:off x="4663440" y="4572000"/>
+            <a:ext cx="6949440" cy="1417320"/>
           </a:xfrm>
           <a:prstGeom prst="roundRect">
             <a:avLst>
-              <a:gd name="adj" fmla="val 6667"/>
+              <a:gd name="adj" fmla="val 6452"/>
             </a:avLst>
           </a:prstGeom>
           <a:solidFill>
@@ -12006,14 +12064,14 @@
       </p:sp>
       <p:sp>
         <p:nvSpPr>
-          <p:cNvPr id="8" name="Text 5"/>
+          <p:cNvPr id="10" name="Text 7"/>
           <p:cNvSpPr txBox="1"/>
           <p:nvPr/>
         </p:nvSpPr>
         <p:spPr>
           <a:xfrm>
-            <a:off x="4800600" y="4572000"/>
-            <a:ext cx="6720840" cy="1280160"/>
+            <a:off x="4800600" y="4617720"/>
+            <a:ext cx="6720840" cy="1325880"/>
           </a:xfrm>
           <a:prstGeom prst="rect">
             <a:avLst/>

</xml_diff>

<commit_message>
Résultat du nouvel agent sur l'US 417829, comparatif et skills mis à jour
</commit_message>
<xml_diff>
--- a/doc/Agent-QC-actuel-vs-propose.pptx
+++ b/doc/Agent-QC-actuel-vs-propose.pptx
@@ -115,7 +115,7 @@
   <p:extLst>
     <p:ext uri="{521415D9-36F7-43E2-AB2F-B90AF26B5E84}">
       <p14:sectionLst xmlns:p14="http://schemas.microsoft.com/office/powerpoint/2010/main">
-        <p14:section name="Agent QC" id="{d4021ae9-59aa-7bed-74e7-cb9a45607c7e}">
+        <p14:section name="Agent QC" id="{ca6efd4f-7ff0-45fa-255d-c0c0eb66d19c}">
           <p14:sldIdLst>
             <p14:sldId id="256"/>
             <p14:sldId id="257"/>
@@ -972,7 +972,7 @@
           <a:p>
             <a:r>
               <a:rPr lang="en-US" dirty="0"/>
-              <a:t>Limite de la comparaison : la sortie de l'agent actuel a été produite par l'agent de l'équipe ; notre résultat a été produit en appliquant les nouvelles consignes en dehors de cet outil. Le vrai test sera de rejouer le nouvel agent dans l'outil de l'équipe sur la même US. Comparaison faite sur la sortie de l'agent actuel (TC-001 à TC-014 et début de TC-015) et sur la version proposée appliquée à l'US complète. Sur l'accès, le panneau et les champs du formulaire, les deux couvertures sont proches. La différence est ailleurs. Exécutabilité : les cas actuels ne disent ni qui se connecte ni quelles données préparer. Règle métier : la validation dépend du statut de la demande existante sur l'entité ; l'agent actuel n'en teste qu'un cas. Ce que l'US ne dit pas : au §3, l'US annonce une erreur « entité ID inconnue » alors que l'entité ne peut pas être saisie librement ; l'agent actuel prévoit de tester ce message sans relever ce point, la version proposée en fait une question bloquante. Millésime : les deux versions testent la valeur par défaut et la plage de -20 à +10 ans (TC-009, TC-010) ; pas de différence ici. Les textes exacts des messages sont dans les maquettes : ils restent à compléter.</a:t>
+              <a:t>Les deux résultats viennent du même modèle, Claude Sonnet 5.5 : l'agent actuel dans l'onglet Agents du dépôt GitHub, le nouvel agent dans Claude Code avec ses deux commandes, analyse puis rédaction. Le nouvel agent a lu l'US dans un fichier exporté, sans les commentaires ni les maquettes, avec un contexte projet presque vide. Un premier passage était trop prudent (2 situations sur 5) : la consigne sur les messages sans texte a été corrigée, puis l'agent relancé. Comparaison faite sur la sortie de l'agent actuel (TC-001 à TC-014 et début de TC-015) et sur la version proposée appliquée à l'US complète. Sur l'accès, le panneau et les champs du formulaire, les deux couvertures sont proches. La différence est ailleurs. Exécutabilité : les cas actuels ne disent ni qui se connecte ni quelles données préparer. Règle métier : la validation dépend du statut de la demande existante sur l'entité ; l'agent actuel n'en teste qu'un cas. Ce que l'US ne dit pas : au §3, l'US annonce une erreur « entité ID inconnue » alors que l'entité ne peut pas être saisie librement ; l'agent actuel prévoit de tester ce message sans relever ce point, la version proposée en fait une question bloquante. Millésime : les deux versions testent la valeur par défaut et la plage de -20 à +10 ans (TC-009, TC-010) ; pas de différence ici. Les textes exacts des messages sont dans les maquettes : ils restent à compléter.</a:t>
             </a:r>
             <a:endParaRPr lang="en-US" dirty="0"/>
           </a:p>
@@ -8322,7 +8322,7 @@
                   <a:schemeClr val="accent1"/>
                 </a:solidFill>
               </a:rPr>
-              <a:t>Même US. Notre résultat est un premier essai, à rejouer avec le nouvel agent dans l'outil de l'équipe.</a:t>
+              <a:t>Même US, même modèle (Claude Sonnet 5.5) : le nouvel agent a été lancé dans Claude Code.</a:t>
             </a:r>
             <a:endParaRPr lang="en-US" sz="1600" dirty="0"/>
           </a:p>
@@ -8492,7 +8492,7 @@
                             <a:srgbClr val="FFFFFF"/>
                           </a:solidFill>
                         </a:rPr>
-                        <a:t>Version proposée</a:t>
+                        <a:t>Nouvel agent</a:t>
                       </a:r>
                       <a:endParaRPr lang="en-US" sz="1200" dirty="0"/>
                     </a:p>
@@ -9417,7 +9417,7 @@
                             <a:srgbClr val="00338D"/>
                           </a:solidFill>
                         </a:rPr>
-                        <a:t>1 cas par champ, avec « aucune demande créée »</a:t>
+                        <a:t>1 cas par champ sans valeur par défaut (2), avec « aucune demande créée »</a:t>
                       </a:r>
                       <a:endParaRPr lang="en-US" sz="1050" dirty="0"/>
                     </a:p>
@@ -9787,7 +9787,7 @@
                             <a:srgbClr val="00338D"/>
                           </a:solidFill>
                         </a:rPr>
-                        <a:t>Affichage de Reprise vérifié ; son effet, non décrit par l'US, n'est pas inventé</a:t>
+                        <a:t>Valeurs Oui et Non vérifiées ; son effet, non décrit par l'US, n'est pas inventé</a:t>
                       </a:r>
                       <a:endParaRPr lang="en-US" sz="1050" dirty="0"/>
                     </a:p>
@@ -9972,7 +9972,7 @@
                             <a:srgbClr val="00338D"/>
                           </a:solidFill>
                         </a:rPr>
-                        <a:t>9 questions au PO, dont 2 bloquantes : Entité ID inconnue (§3), documents obligatoires (§4)</a:t>
+                        <a:t>12 questions au PO, dont 6 bloquantes, parmi lesquelles Entité ID inconnue (§3) et documents obligatoires (§4)</a:t>
                       </a:r>
                       <a:endParaRPr lang="en-US" sz="1050" dirty="0"/>
                     </a:p>
@@ -10157,7 +10157,7 @@
                             <a:srgbClr val="00338D"/>
                           </a:solidFill>
                         </a:rPr>
-                        <a:t>23 lignes exécutables, chacune avec sa raison</a:t>
+                        <a:t>22 cas exécutables (14 scénarios), 0 erreur au contrôle</a:t>
                       </a:r>
                       <a:endParaRPr lang="en-US" sz="1050" dirty="0"/>
                     </a:p>
@@ -10239,7 +10239,7 @@
                   <a:srgbClr val="00338D"/>
                 </a:solidFill>
               </a:rPr>
-              <a:t>Gardé de l'agent actuel : </a:t>
+              <a:t>À reprendre de l'agent actuel : </a:t>
             </a:r>
             <a:pPr indent="0" marL="0">
               <a:buNone/>
@@ -10250,7 +10250,7 @@
                   <a:schemeClr val="tx1"/>
                 </a:solidFill>
               </a:rPr>
-              <a:t>Reprise absente en Renouvellement, valeur par défaut concrète, ouverture du panneau, recherche d'un collaborateur.</a:t>
+              <a:t>vérifier que Reprise est absent en Renouvellement (TC-005), un nom concret par défaut (TC-007).</a:t>
             </a:r>
             <a:endParaRPr lang="en-US" sz="1200" dirty="0"/>
           </a:p>
@@ -10686,7 +10686,7 @@
                             <a:srgbClr val="FFFFFF"/>
                           </a:solidFill>
                         </a:rPr>
-                        <a:t>Version proposée</a:t>
+                        <a:t>Nouvel agent</a:t>
                       </a:r>
                       <a:endParaRPr lang="en-US" sz="1200" dirty="0"/>
                     </a:p>

</xml_diff>

<commit_message>
Présentations, comparatif et mail mis à jour avec le lancement du 27/10
</commit_message>
<xml_diff>
--- a/doc/Agent-QC-actuel-vs-propose.pptx
+++ b/doc/Agent-QC-actuel-vs-propose.pptx
@@ -115,7 +115,7 @@
   <p:extLst>
     <p:ext uri="{521415D9-36F7-43E2-AB2F-B90AF26B5E84}">
       <p14:sectionLst xmlns:p14="http://schemas.microsoft.com/office/powerpoint/2010/main">
-        <p14:section name="Agent QC" id="{ca6efd4f-7ff0-45fa-255d-c0c0eb66d19c}">
+        <p14:section name="Agent QC" id="{bdc24a01-06f4-7476-4228-b97ecbfde913}">
           <p14:sldIdLst>
             <p14:sldId id="256"/>
             <p14:sldId id="257"/>
@@ -972,7 +972,7 @@
           <a:p>
             <a:r>
               <a:rPr lang="en-US" dirty="0"/>
-              <a:t>Les deux résultats viennent du même modèle, Claude Sonnet 5.5 : l'agent actuel dans l'onglet Agents du dépôt GitHub, le nouvel agent dans Claude Code avec ses deux commandes, analyse puis rédaction. Le nouvel agent a lu l'US dans un fichier exporté, sans les commentaires ni les maquettes, avec un contexte projet presque vide. Un premier passage était trop prudent (2 situations sur 5) : la consigne sur les messages sans texte a été corrigée, puis l'agent relancé. Comparaison faite sur la sortie de l'agent actuel (TC-001 à TC-014 et début de TC-015) et sur la version proposée appliquée à l'US complète. Sur l'accès, le panneau et les champs du formulaire, les deux couvertures sont proches. La différence est ailleurs. Exécutabilité : les cas actuels ne disent ni qui se connecte ni quelles données préparer. Règle métier : la validation dépend du statut de la demande existante sur l'entité ; l'agent actuel n'en teste qu'un cas. Ce que l'US ne dit pas : au §3, l'US annonce une erreur « entité ID inconnue » alors que l'entité ne peut pas être saisie librement ; l'agent actuel prévoit de tester ce message sans relever ce point, la version proposée en fait une question bloquante. Millésime : les deux versions testent la valeur par défaut et la plage de -20 à +10 ans (TC-009, TC-010) ; pas de différence ici. Les textes exacts des messages sont dans les maquettes : ils restent à compléter.</a:t>
+              <a:t>Les deux résultats viennent du même modèle, Claude Sonnet 5.5 : l'agent actuel dans l'onglet Agents du dépôt GitHub, le nouvel agent dans Claude Code avec ses deux commandes, analyse puis rédaction. Le nouvel agent a lu l'US dans un fichier exporté, sans les commentaires ni les maquettes, avec un contexte projet presque vide. Trois lancements : le premier était trop prudent (2 situations sur 5), la consigne sur les messages sans texte a été corrigée ; le deuxième donnait 22 cas ; le troisième, le 27/10, 25 cas avec l'absence de Reprise vérifiée. Les chiffres varient d'un lancement à l'autre : l'agent se juge sur plusieurs lancements. Comparaison faite sur la sortie de l'agent actuel (TC-001 à TC-014 et début de TC-015) et sur la version proposée appliquée à l'US complète. Sur l'accès, le panneau et les champs du formulaire, les deux couvertures sont proches. La différence est ailleurs. Exécutabilité : les cas actuels ne disent ni qui se connecte ni quelles données préparer. Règle métier : la validation dépend du statut de la demande existante sur l'entité ; l'agent actuel n'en teste qu'un cas. Ce que l'US ne dit pas : au §3, l'US annonce une erreur « entité ID inconnue » alors que l'entité ne peut pas être saisie librement ; l'agent actuel prévoit de tester ce message sans relever ce point, la version proposée en fait une question bloquante. Millésime : les deux versions testent la valeur par défaut et la plage de -20 à +10 ans (TC-009, TC-010) ; pas de différence ici. Les textes exacts des messages sont dans les maquettes : ils restent à compléter.</a:t>
             </a:r>
             <a:endParaRPr lang="en-US" dirty="0"/>
           </a:p>
@@ -5661,7 +5661,7 @@
                   <a:schemeClr val="bg1"/>
                 </a:solidFill>
               </a:rPr>
-              <a:t>Après « oui », dans le plan existant ou en CSV</a:t>
+              <a:t>Tableau Azure DevOps par script ; après « oui », ou en CSV</a:t>
             </a:r>
             <a:endParaRPr lang="en-US" sz="1300" dirty="0"/>
           </a:p>
@@ -6460,11 +6460,11 @@
             <a:tbl>
               <a:tblPr/>
               <a:tblGrid>
-                <a:gridCol w="1783080"/>
+                <a:gridCol w="1600200"/>
                 <a:gridCol w="2377440"/>
-                <a:gridCol w="2240280"/>
+                <a:gridCol w="2423160"/>
               </a:tblGrid>
-              <a:tr h="329184">
+              <a:tr h="310896">
                 <a:tc>
                   <a:txBody>
                     <a:bodyPr/>
@@ -6649,7 +6649,7 @@
                   </a:tcPr>
                 </a:tc>
               </a:tr>
-              <a:tr h="420624">
+              <a:tr h="411480">
                 <a:tc>
                   <a:txBody>
                     <a:bodyPr/>
@@ -6841,7 +6841,7 @@
                   </a:tcPr>
                 </a:tc>
               </a:tr>
-              <a:tr h="420624">
+              <a:tr h="411480">
                 <a:tc>
                   <a:txBody>
                     <a:bodyPr/>
@@ -7033,7 +7033,7 @@
                   </a:tcPr>
                 </a:tc>
               </a:tr>
-              <a:tr h="420624">
+              <a:tr h="411480">
                 <a:tc>
                   <a:txBody>
                     <a:bodyPr/>
@@ -7177,7 +7177,7 @@
                             <a:srgbClr val="1A1A2E"/>
                           </a:solidFill>
                         </a:rPr>
-                        <a:t>Scénarios contrôlés par script</a:t>
+                        <a:t>Scénarios contrôlés, tableau Azure DevOps, propositions pour le contexte</a:t>
                       </a:r>
                       <a:endParaRPr lang="en-US" sz="1150" dirty="0"/>
                     </a:p>
@@ -7225,7 +7225,7 @@
                   </a:tcPr>
                 </a:tc>
               </a:tr>
-              <a:tr h="420624">
+              <a:tr h="411480">
                 <a:tc>
                   <a:txBody>
                     <a:bodyPr/>
@@ -7417,7 +7417,7 @@
                   </a:tcPr>
                 </a:tc>
               </a:tr>
-              <a:tr h="420624">
+              <a:tr h="411480">
                 <a:tc>
                   <a:txBody>
                     <a:bodyPr/>
@@ -7609,7 +7609,7 @@
                   </a:tcPr>
                 </a:tc>
               </a:tr>
-              <a:tr h="420624">
+              <a:tr h="411480">
                 <a:tc>
                   <a:txBody>
                     <a:bodyPr/>
@@ -7813,7 +7813,7 @@
         </p:nvSpPr>
         <p:spPr>
           <a:xfrm>
-            <a:off x="548640" y="4526280"/>
+            <a:off x="548640" y="4663440"/>
             <a:ext cx="6400800" cy="365760"/>
           </a:xfrm>
           <a:prstGeom prst="rect">
@@ -7830,7 +7830,7 @@
               <a:buNone/>
             </a:pPr>
             <a:r>
-              <a:rPr lang="en-US" sz="1200" b="1" dirty="0">
+              <a:rPr lang="en-US" sz="1150" b="1" dirty="0">
                 <a:solidFill>
                   <a:srgbClr val="00338D"/>
                 </a:solidFill>
@@ -7841,14 +7841,14 @@
               <a:buNone/>
             </a:pPr>
             <a:r>
-              <a:rPr lang="en-US" sz="1200" dirty="0">
+              <a:rPr lang="en-US" sz="1150" dirty="0">
                 <a:solidFill>
                   <a:schemeClr val="tx1"/>
                 </a:solidFill>
               </a:rPr>
               <a:t>un document déposé ne lance aucune analyse ; l'agent dit ce qu'il a reçu et attend.</a:t>
             </a:r>
-            <a:endParaRPr lang="en-US" sz="1200" dirty="0"/>
+            <a:endParaRPr lang="en-US" sz="1150" dirty="0"/>
           </a:p>
         </p:txBody>
       </p:sp>
@@ -7945,7 +7945,7 @@
                   <a:schemeClr val="bg1"/>
                 </a:solidFill>
               </a:rPr>
-              <a:t>L'analyse d'une US propose des lignes, chacune avec sa source</a:t>
+              <a:t>L'analyse puis la rédaction proposent des lignes sourcées : rôles, comptes, données, variations, flux</a:t>
             </a:r>
             <a:endParaRPr lang="en-US" sz="1350" dirty="0"/>
           </a:p>
@@ -8322,7 +8322,7 @@
                   <a:schemeClr val="accent1"/>
                 </a:solidFill>
               </a:rPr>
-              <a:t>Même US, même modèle (Claude Sonnet 5.5) : le nouvel agent a été lancé dans Claude Code.</a:t>
+              <a:t>Même US, même modèle (Claude Sonnet 5.5) : le nouvel agent lancé dans Claude Code le 27/10.</a:t>
             </a:r>
             <a:endParaRPr lang="en-US" sz="1600" dirty="0"/>
           </a:p>
@@ -9232,7 +9232,7 @@
                             <a:srgbClr val="00338D"/>
                           </a:solidFill>
                         </a:rPr>
-                        <a:t>5 situations : 2 acceptées, 3 refusées, avec vérification que la demande existante ne change pas</a:t>
+                        <a:t>5 situations sur 5, dans les deux natures : 4 créations, 4 refus, la demande existante vérifiée inchangée</a:t>
                       </a:r>
                       <a:endParaRPr lang="en-US" sz="1050" dirty="0"/>
                     </a:p>
@@ -9417,7 +9417,7 @@
                             <a:srgbClr val="00338D"/>
                           </a:solidFill>
                         </a:rPr>
-                        <a:t>1 cas par champ sans valeur par défaut (2), avec « aucune demande créée »</a:t>
+                        <a:t>N° Requête BSC vide : refus et « aucune demande n'est créée » ; les autres champs ont une valeur par défaut</a:t>
                       </a:r>
                       <a:endParaRPr lang="en-US" sz="1050" dirty="0"/>
                     </a:p>
@@ -9787,7 +9787,7 @@
                             <a:srgbClr val="00338D"/>
                           </a:solidFill>
                         </a:rPr>
-                        <a:t>Valeurs Oui et Non vérifiées ; son effet, non décrit par l'US, n'est pas inventé</a:t>
+                        <a:t>Absent en Renouvellement, Oui et Non en Nouveau ; son effet, non décrit par l'US, n'est pas inventé</a:t>
                       </a:r>
                       <a:endParaRPr lang="en-US" sz="1050" dirty="0"/>
                     </a:p>
@@ -9972,7 +9972,7 @@
                             <a:srgbClr val="00338D"/>
                           </a:solidFill>
                         </a:rPr>
-                        <a:t>12 questions au PO, dont 6 bloquantes, parmi lesquelles Entité ID inconnue (§3) et documents obligatoires (§4)</a:t>
+                        <a:t>14 questions au PO, dont 4 bloquantes : Entité ID inconnue (§3), documents obligatoires (§4), millésime en Nouveau</a:t>
                       </a:r>
                       <a:endParaRPr lang="en-US" sz="1050" dirty="0"/>
                     </a:p>
@@ -10157,7 +10157,7 @@
                             <a:srgbClr val="00338D"/>
                           </a:solidFill>
                         </a:rPr>
-                        <a:t>22 cas exécutables (14 scénarios), 0 erreur au contrôle</a:t>
+                        <a:t>25 cas exécutables (14 scénarios), 0 erreur au contrôle</a:t>
                       </a:r>
                       <a:endParaRPr lang="en-US" sz="1050" dirty="0"/>
                     </a:p>
@@ -10239,7 +10239,7 @@
                   <a:srgbClr val="00338D"/>
                 </a:solidFill>
               </a:rPr>
-              <a:t>À reprendre de l'agent actuel : </a:t>
+              <a:t>Repris de l'agent actuel : </a:t>
             </a:r>
             <a:pPr indent="0" marL="0">
               <a:buNone/>
@@ -10250,7 +10250,7 @@
                   <a:schemeClr val="tx1"/>
                 </a:solidFill>
               </a:rPr>
-              <a:t>vérifier que Reprise est absent en Renouvellement (TC-005), un nom concret par défaut (TC-007).</a:t>
+              <a:t>Reprise absent en Renouvellement (TC-005), nom concret par défaut (TC-007), saisie libre de l'entité interdite (TC-011).</a:t>
             </a:r>
             <a:endParaRPr lang="en-US" sz="1200" dirty="0"/>
           </a:p>
@@ -13875,7 +13875,7 @@
                   <a:schemeClr val="tx1"/>
                 </a:solidFill>
               </a:rPr>
-              <a:t>Rejouer le nouvel agent sur 3 US déjà traitées à la main</a:t>
+              <a:t>Rejouer le nouvel agent sur 3 US déjà traitées à la main, deux fois chacune</a:t>
             </a:r>
             <a:endParaRPr lang="en-US" sz="1500" dirty="0"/>
           </a:p>

</xml_diff>